<commit_message>
docs: add 5-minute speech script aligned to grading rubric
</commit_message>
<xml_diff>
--- a/docs/Proofolio_발표.pptx
+++ b/docs/Proofolio_발표.pptx
@@ -5,14 +5,14 @@
     <p:sldMasterId id="2147483648" r:id="rId1"/>
   </p:sldMasterIdLst>
   <p:sldIdLst>
-    <p:sldId id="256" r:id="rId7"/>
-    <p:sldId id="257" r:id="rId8"/>
-    <p:sldId id="258" r:id="rId9"/>
-    <p:sldId id="259" r:id="rId10"/>
-    <p:sldId id="260" r:id="rId11"/>
-    <p:sldId id="261" r:id="rId12"/>
+    <p:sldId id="256" r:id="rId2"/>
+    <p:sldId id="257" r:id="rId3"/>
+    <p:sldId id="258" r:id="rId4"/>
+    <p:sldId id="259" r:id="rId5"/>
+    <p:sldId id="260" r:id="rId6"/>
+    <p:sldId id="261" r:id="rId7"/>
   </p:sldIdLst>
-  <p:sldSz cx="12191695" cy="6858000" type="screen4x3"/>
+  <p:sldSz cx="12192000" cy="6858000"/>
   <p:notesSz cx="6858000" cy="9144000"/>
   <p:defaultTextStyle>
     <a:defPPr>
@@ -109,6 +109,22 @@
       </a:defRPr>
     </a:lvl9pPr>
   </p:defaultTextStyle>
+  <p:extLst>
+    <p:ext uri="{EFAFB233-063F-42B5-8137-9DF3F51BA10A}">
+      <p15:sldGuideLst xmlns:p15="http://schemas.microsoft.com/office/powerpoint/2012/main">
+        <p15:guide id="1" orient="horz" pos="2160">
+          <p15:clr>
+            <a:srgbClr val="A4A3A4"/>
+          </p15:clr>
+        </p15:guide>
+        <p15:guide id="2" pos="2880">
+          <p15:clr>
+            <a:srgbClr val="A4A3A4"/>
+          </p15:clr>
+        </p15:guide>
+      </p15:sldGuideLst>
+    </p:ext>
+  </p:extLst>
 </p:presentation>
 </file>
 
@@ -150,10 +166,9 @@
           <a:lstStyle/>
           <a:p>
             <a:r>
-              <a:rPr lang="en-US" smtClean="0"/>
+              <a:rPr lang="en-US"/>
               <a:t>Click to edit Master title style</a:t>
             </a:r>
-            <a:endParaRPr lang="en-US"/>
           </a:p>
         </p:txBody>
       </p:sp>
@@ -269,10 +284,9 @@
           </a:lstStyle>
           <a:p>
             <a:r>
-              <a:rPr lang="en-US" smtClean="0"/>
+              <a:rPr lang="en-US"/>
               <a:t>Click to edit Master subtitle style</a:t>
             </a:r>
-            <a:endParaRPr lang="en-US"/>
           </a:p>
         </p:txBody>
       </p:sp>
@@ -293,7 +307,7 @@
           <a:p>
             <a:fld id="{5BCAD085-E8A6-8845-BD4E-CB4CCA059FC4}" type="datetimeFigureOut">
               <a:rPr lang="en-US" smtClean="0"/>
-              <a:t>1/27/13</a:t>
+              <a:t>6/1/26</a:t>
             </a:fld>
             <a:endParaRPr lang="en-US"/>
           </a:p>
@@ -387,10 +401,9 @@
           <a:lstStyle/>
           <a:p>
             <a:r>
-              <a:rPr lang="en-US" smtClean="0"/>
+              <a:rPr lang="en-US"/>
               <a:t>Click to edit Master title style</a:t>
             </a:r>
-            <a:endParaRPr lang="en-US"/>
           </a:p>
         </p:txBody>
       </p:sp>
@@ -411,38 +424,37 @@
           <a:p>
             <a:pPr lvl="0"/>
             <a:r>
-              <a:rPr lang="en-US" smtClean="0"/>
+              <a:rPr lang="en-US"/>
               <a:t>Click to edit Master text styles</a:t>
             </a:r>
           </a:p>
           <a:p>
             <a:pPr lvl="1"/>
             <a:r>
-              <a:rPr lang="en-US" smtClean="0"/>
+              <a:rPr lang="en-US"/>
               <a:t>Second level</a:t>
             </a:r>
           </a:p>
           <a:p>
             <a:pPr lvl="2"/>
             <a:r>
-              <a:rPr lang="en-US" smtClean="0"/>
+              <a:rPr lang="en-US"/>
               <a:t>Third level</a:t>
             </a:r>
           </a:p>
           <a:p>
             <a:pPr lvl="3"/>
             <a:r>
-              <a:rPr lang="en-US" smtClean="0"/>
+              <a:rPr lang="en-US"/>
               <a:t>Fourth level</a:t>
             </a:r>
           </a:p>
           <a:p>
             <a:pPr lvl="4"/>
             <a:r>
-              <a:rPr lang="en-US" smtClean="0"/>
+              <a:rPr lang="en-US"/>
               <a:t>Fifth level</a:t>
             </a:r>
-            <a:endParaRPr lang="en-US"/>
           </a:p>
         </p:txBody>
       </p:sp>
@@ -463,7 +475,7 @@
           <a:p>
             <a:fld id="{5BCAD085-E8A6-8845-BD4E-CB4CCA059FC4}" type="datetimeFigureOut">
               <a:rPr lang="en-US" smtClean="0"/>
-              <a:t>1/27/13</a:t>
+              <a:t>6/1/26</a:t>
             </a:fld>
             <a:endParaRPr lang="en-US"/>
           </a:p>
@@ -562,10 +574,9 @@
           <a:lstStyle/>
           <a:p>
             <a:r>
-              <a:rPr lang="en-US" smtClean="0"/>
+              <a:rPr lang="en-US"/>
               <a:t>Click to edit Master title style</a:t>
             </a:r>
-            <a:endParaRPr lang="en-US"/>
           </a:p>
         </p:txBody>
       </p:sp>
@@ -591,38 +602,37 @@
           <a:p>
             <a:pPr lvl="0"/>
             <a:r>
-              <a:rPr lang="en-US" smtClean="0"/>
+              <a:rPr lang="en-US"/>
               <a:t>Click to edit Master text styles</a:t>
             </a:r>
           </a:p>
           <a:p>
             <a:pPr lvl="1"/>
             <a:r>
-              <a:rPr lang="en-US" smtClean="0"/>
+              <a:rPr lang="en-US"/>
               <a:t>Second level</a:t>
             </a:r>
           </a:p>
           <a:p>
             <a:pPr lvl="2"/>
             <a:r>
-              <a:rPr lang="en-US" smtClean="0"/>
+              <a:rPr lang="en-US"/>
               <a:t>Third level</a:t>
             </a:r>
           </a:p>
           <a:p>
             <a:pPr lvl="3"/>
             <a:r>
-              <a:rPr lang="en-US" smtClean="0"/>
+              <a:rPr lang="en-US"/>
               <a:t>Fourth level</a:t>
             </a:r>
           </a:p>
           <a:p>
             <a:pPr lvl="4"/>
             <a:r>
-              <a:rPr lang="en-US" smtClean="0"/>
+              <a:rPr lang="en-US"/>
               <a:t>Fifth level</a:t>
             </a:r>
-            <a:endParaRPr lang="en-US"/>
           </a:p>
         </p:txBody>
       </p:sp>
@@ -643,7 +653,7 @@
           <a:p>
             <a:fld id="{5BCAD085-E8A6-8845-BD4E-CB4CCA059FC4}" type="datetimeFigureOut">
               <a:rPr lang="en-US" smtClean="0"/>
-              <a:t>1/27/13</a:t>
+              <a:t>6/1/26</a:t>
             </a:fld>
             <a:endParaRPr lang="en-US"/>
           </a:p>
@@ -737,10 +747,9 @@
           <a:lstStyle/>
           <a:p>
             <a:r>
-              <a:rPr lang="en-US" smtClean="0"/>
+              <a:rPr lang="en-US"/>
               <a:t>Click to edit Master title style</a:t>
             </a:r>
-            <a:endParaRPr lang="en-US"/>
           </a:p>
         </p:txBody>
       </p:sp>
@@ -761,38 +770,37 @@
           <a:p>
             <a:pPr lvl="0"/>
             <a:r>
-              <a:rPr lang="en-US" smtClean="0"/>
+              <a:rPr lang="en-US"/>
               <a:t>Click to edit Master text styles</a:t>
             </a:r>
           </a:p>
           <a:p>
             <a:pPr lvl="1"/>
             <a:r>
-              <a:rPr lang="en-US" smtClean="0"/>
+              <a:rPr lang="en-US"/>
               <a:t>Second level</a:t>
             </a:r>
           </a:p>
           <a:p>
             <a:pPr lvl="2"/>
             <a:r>
-              <a:rPr lang="en-US" smtClean="0"/>
+              <a:rPr lang="en-US"/>
               <a:t>Third level</a:t>
             </a:r>
           </a:p>
           <a:p>
             <a:pPr lvl="3"/>
             <a:r>
-              <a:rPr lang="en-US" smtClean="0"/>
+              <a:rPr lang="en-US"/>
               <a:t>Fourth level</a:t>
             </a:r>
           </a:p>
           <a:p>
             <a:pPr lvl="4"/>
             <a:r>
-              <a:rPr lang="en-US" smtClean="0"/>
+              <a:rPr lang="en-US"/>
               <a:t>Fifth level</a:t>
             </a:r>
-            <a:endParaRPr lang="en-US"/>
           </a:p>
         </p:txBody>
       </p:sp>
@@ -813,7 +821,7 @@
           <a:p>
             <a:fld id="{5BCAD085-E8A6-8845-BD4E-CB4CCA059FC4}" type="datetimeFigureOut">
               <a:rPr lang="en-US" smtClean="0"/>
-              <a:t>1/27/13</a:t>
+              <a:t>6/1/26</a:t>
             </a:fld>
             <a:endParaRPr lang="en-US"/>
           </a:p>
@@ -916,10 +924,9 @@
           </a:lstStyle>
           <a:p>
             <a:r>
-              <a:rPr lang="en-US" smtClean="0"/>
+              <a:rPr lang="en-US"/>
               <a:t>Click to edit Master title style</a:t>
             </a:r>
-            <a:endParaRPr lang="en-US"/>
           </a:p>
         </p:txBody>
       </p:sp>
@@ -1036,7 +1043,7 @@
           <a:p>
             <a:pPr lvl="0"/>
             <a:r>
-              <a:rPr lang="en-US" smtClean="0"/>
+              <a:rPr lang="en-US"/>
               <a:t>Click to edit Master text styles</a:t>
             </a:r>
           </a:p>
@@ -1059,7 +1066,7 @@
           <a:p>
             <a:fld id="{5BCAD085-E8A6-8845-BD4E-CB4CCA059FC4}" type="datetimeFigureOut">
               <a:rPr lang="en-US" smtClean="0"/>
-              <a:t>1/27/13</a:t>
+              <a:t>6/1/26</a:t>
             </a:fld>
             <a:endParaRPr lang="en-US"/>
           </a:p>
@@ -1153,10 +1160,9 @@
           <a:lstStyle/>
           <a:p>
             <a:r>
-              <a:rPr lang="en-US" smtClean="0"/>
+              <a:rPr lang="en-US"/>
               <a:t>Click to edit Master title style</a:t>
             </a:r>
-            <a:endParaRPr lang="en-US"/>
           </a:p>
         </p:txBody>
       </p:sp>
@@ -1210,38 +1216,37 @@
           <a:p>
             <a:pPr lvl="0"/>
             <a:r>
-              <a:rPr lang="en-US" smtClean="0"/>
+              <a:rPr lang="en-US"/>
               <a:t>Click to edit Master text styles</a:t>
             </a:r>
           </a:p>
           <a:p>
             <a:pPr lvl="1"/>
             <a:r>
-              <a:rPr lang="en-US" smtClean="0"/>
+              <a:rPr lang="en-US"/>
               <a:t>Second level</a:t>
             </a:r>
           </a:p>
           <a:p>
             <a:pPr lvl="2"/>
             <a:r>
-              <a:rPr lang="en-US" smtClean="0"/>
+              <a:rPr lang="en-US"/>
               <a:t>Third level</a:t>
             </a:r>
           </a:p>
           <a:p>
             <a:pPr lvl="3"/>
             <a:r>
-              <a:rPr lang="en-US" smtClean="0"/>
+              <a:rPr lang="en-US"/>
               <a:t>Fourth level</a:t>
             </a:r>
           </a:p>
           <a:p>
             <a:pPr lvl="4"/>
             <a:r>
-              <a:rPr lang="en-US" smtClean="0"/>
+              <a:rPr lang="en-US"/>
               <a:t>Fifth level</a:t>
             </a:r>
-            <a:endParaRPr lang="en-US"/>
           </a:p>
         </p:txBody>
       </p:sp>
@@ -1295,38 +1300,37 @@
           <a:p>
             <a:pPr lvl="0"/>
             <a:r>
-              <a:rPr lang="en-US" smtClean="0"/>
+              <a:rPr lang="en-US"/>
               <a:t>Click to edit Master text styles</a:t>
             </a:r>
           </a:p>
           <a:p>
             <a:pPr lvl="1"/>
             <a:r>
-              <a:rPr lang="en-US" smtClean="0"/>
+              <a:rPr lang="en-US"/>
               <a:t>Second level</a:t>
             </a:r>
           </a:p>
           <a:p>
             <a:pPr lvl="2"/>
             <a:r>
-              <a:rPr lang="en-US" smtClean="0"/>
+              <a:rPr lang="en-US"/>
               <a:t>Third level</a:t>
             </a:r>
           </a:p>
           <a:p>
             <a:pPr lvl="3"/>
             <a:r>
-              <a:rPr lang="en-US" smtClean="0"/>
+              <a:rPr lang="en-US"/>
               <a:t>Fourth level</a:t>
             </a:r>
           </a:p>
           <a:p>
             <a:pPr lvl="4"/>
             <a:r>
-              <a:rPr lang="en-US" smtClean="0"/>
+              <a:rPr lang="en-US"/>
               <a:t>Fifth level</a:t>
             </a:r>
-            <a:endParaRPr lang="en-US"/>
           </a:p>
         </p:txBody>
       </p:sp>
@@ -1347,7 +1351,7 @@
           <a:p>
             <a:fld id="{5BCAD085-E8A6-8845-BD4E-CB4CCA059FC4}" type="datetimeFigureOut">
               <a:rPr lang="en-US" smtClean="0"/>
-              <a:t>1/27/13</a:t>
+              <a:t>6/1/26</a:t>
             </a:fld>
             <a:endParaRPr lang="en-US"/>
           </a:p>
@@ -1445,10 +1449,9 @@
           </a:lstStyle>
           <a:p>
             <a:r>
-              <a:rPr lang="en-US" smtClean="0"/>
+              <a:rPr lang="en-US"/>
               <a:t>Click to edit Master title style</a:t>
             </a:r>
-            <a:endParaRPr lang="en-US"/>
           </a:p>
         </p:txBody>
       </p:sp>
@@ -1511,7 +1514,7 @@
           <a:p>
             <a:pPr lvl="0"/>
             <a:r>
-              <a:rPr lang="en-US" smtClean="0"/>
+              <a:rPr lang="en-US"/>
               <a:t>Click to edit Master text styles</a:t>
             </a:r>
           </a:p>
@@ -1567,38 +1570,37 @@
           <a:p>
             <a:pPr lvl="0"/>
             <a:r>
-              <a:rPr lang="en-US" smtClean="0"/>
+              <a:rPr lang="en-US"/>
               <a:t>Click to edit Master text styles</a:t>
             </a:r>
           </a:p>
           <a:p>
             <a:pPr lvl="1"/>
             <a:r>
-              <a:rPr lang="en-US" smtClean="0"/>
+              <a:rPr lang="en-US"/>
               <a:t>Second level</a:t>
             </a:r>
           </a:p>
           <a:p>
             <a:pPr lvl="2"/>
             <a:r>
-              <a:rPr lang="en-US" smtClean="0"/>
+              <a:rPr lang="en-US"/>
               <a:t>Third level</a:t>
             </a:r>
           </a:p>
           <a:p>
             <a:pPr lvl="3"/>
             <a:r>
-              <a:rPr lang="en-US" smtClean="0"/>
+              <a:rPr lang="en-US"/>
               <a:t>Fourth level</a:t>
             </a:r>
           </a:p>
           <a:p>
             <a:pPr lvl="4"/>
             <a:r>
-              <a:rPr lang="en-US" smtClean="0"/>
+              <a:rPr lang="en-US"/>
               <a:t>Fifth level</a:t>
             </a:r>
-            <a:endParaRPr lang="en-US"/>
           </a:p>
         </p:txBody>
       </p:sp>
@@ -1661,7 +1663,7 @@
           <a:p>
             <a:pPr lvl="0"/>
             <a:r>
-              <a:rPr lang="en-US" smtClean="0"/>
+              <a:rPr lang="en-US"/>
               <a:t>Click to edit Master text styles</a:t>
             </a:r>
           </a:p>
@@ -1717,38 +1719,37 @@
           <a:p>
             <a:pPr lvl="0"/>
             <a:r>
-              <a:rPr lang="en-US" smtClean="0"/>
+              <a:rPr lang="en-US"/>
               <a:t>Click to edit Master text styles</a:t>
             </a:r>
           </a:p>
           <a:p>
             <a:pPr lvl="1"/>
             <a:r>
-              <a:rPr lang="en-US" smtClean="0"/>
+              <a:rPr lang="en-US"/>
               <a:t>Second level</a:t>
             </a:r>
           </a:p>
           <a:p>
             <a:pPr lvl="2"/>
             <a:r>
-              <a:rPr lang="en-US" smtClean="0"/>
+              <a:rPr lang="en-US"/>
               <a:t>Third level</a:t>
             </a:r>
           </a:p>
           <a:p>
             <a:pPr lvl="3"/>
             <a:r>
-              <a:rPr lang="en-US" smtClean="0"/>
+              <a:rPr lang="en-US"/>
               <a:t>Fourth level</a:t>
             </a:r>
           </a:p>
           <a:p>
             <a:pPr lvl="4"/>
             <a:r>
-              <a:rPr lang="en-US" smtClean="0"/>
+              <a:rPr lang="en-US"/>
               <a:t>Fifth level</a:t>
             </a:r>
-            <a:endParaRPr lang="en-US"/>
           </a:p>
         </p:txBody>
       </p:sp>
@@ -1769,7 +1770,7 @@
           <a:p>
             <a:fld id="{5BCAD085-E8A6-8845-BD4E-CB4CCA059FC4}" type="datetimeFigureOut">
               <a:rPr lang="en-US" smtClean="0"/>
-              <a:t>1/27/13</a:t>
+              <a:t>6/1/26</a:t>
             </a:fld>
             <a:endParaRPr lang="en-US"/>
           </a:p>
@@ -1863,10 +1864,9 @@
           <a:lstStyle/>
           <a:p>
             <a:r>
-              <a:rPr lang="en-US" smtClean="0"/>
+              <a:rPr lang="en-US"/>
               <a:t>Click to edit Master title style</a:t>
             </a:r>
-            <a:endParaRPr lang="en-US"/>
           </a:p>
         </p:txBody>
       </p:sp>
@@ -1887,7 +1887,7 @@
           <a:p>
             <a:fld id="{5BCAD085-E8A6-8845-BD4E-CB4CCA059FC4}" type="datetimeFigureOut">
               <a:rPr lang="en-US" smtClean="0"/>
-              <a:t>1/27/13</a:t>
+              <a:t>6/1/26</a:t>
             </a:fld>
             <a:endParaRPr lang="en-US"/>
           </a:p>
@@ -1982,7 +1982,7 @@
           <a:p>
             <a:fld id="{5BCAD085-E8A6-8845-BD4E-CB4CCA059FC4}" type="datetimeFigureOut">
               <a:rPr lang="en-US" smtClean="0"/>
-              <a:t>1/27/13</a:t>
+              <a:t>6/1/26</a:t>
             </a:fld>
             <a:endParaRPr lang="en-US"/>
           </a:p>
@@ -2085,10 +2085,9 @@
           </a:lstStyle>
           <a:p>
             <a:r>
-              <a:rPr lang="en-US" smtClean="0"/>
+              <a:rPr lang="en-US"/>
               <a:t>Click to edit Master title style</a:t>
             </a:r>
-            <a:endParaRPr lang="en-US"/>
           </a:p>
         </p:txBody>
       </p:sp>
@@ -2142,38 +2141,37 @@
           <a:p>
             <a:pPr lvl="0"/>
             <a:r>
-              <a:rPr lang="en-US" smtClean="0"/>
+              <a:rPr lang="en-US"/>
               <a:t>Click to edit Master text styles</a:t>
             </a:r>
           </a:p>
           <a:p>
             <a:pPr lvl="1"/>
             <a:r>
-              <a:rPr lang="en-US" smtClean="0"/>
+              <a:rPr lang="en-US"/>
               <a:t>Second level</a:t>
             </a:r>
           </a:p>
           <a:p>
             <a:pPr lvl="2"/>
             <a:r>
-              <a:rPr lang="en-US" smtClean="0"/>
+              <a:rPr lang="en-US"/>
               <a:t>Third level</a:t>
             </a:r>
           </a:p>
           <a:p>
             <a:pPr lvl="3"/>
             <a:r>
-              <a:rPr lang="en-US" smtClean="0"/>
+              <a:rPr lang="en-US"/>
               <a:t>Fourth level</a:t>
             </a:r>
           </a:p>
           <a:p>
             <a:pPr lvl="4"/>
             <a:r>
-              <a:rPr lang="en-US" smtClean="0"/>
+              <a:rPr lang="en-US"/>
               <a:t>Fifth level</a:t>
             </a:r>
-            <a:endParaRPr lang="en-US"/>
           </a:p>
         </p:txBody>
       </p:sp>
@@ -2236,7 +2234,7 @@
           <a:p>
             <a:pPr lvl="0"/>
             <a:r>
-              <a:rPr lang="en-US" smtClean="0"/>
+              <a:rPr lang="en-US"/>
               <a:t>Click to edit Master text styles</a:t>
             </a:r>
           </a:p>
@@ -2259,7 +2257,7 @@
           <a:p>
             <a:fld id="{5BCAD085-E8A6-8845-BD4E-CB4CCA059FC4}" type="datetimeFigureOut">
               <a:rPr lang="en-US" smtClean="0"/>
-              <a:t>1/27/13</a:t>
+              <a:t>6/1/26</a:t>
             </a:fld>
             <a:endParaRPr lang="en-US"/>
           </a:p>
@@ -2362,10 +2360,9 @@
           </a:lstStyle>
           <a:p>
             <a:r>
-              <a:rPr lang="en-US" smtClean="0"/>
+              <a:rPr lang="en-US"/>
               <a:t>Click to edit Master title style</a:t>
             </a:r>
-            <a:endParaRPr lang="en-US"/>
           </a:p>
         </p:txBody>
       </p:sp>
@@ -2489,7 +2486,7 @@
           <a:p>
             <a:pPr lvl="0"/>
             <a:r>
-              <a:rPr lang="en-US" smtClean="0"/>
+              <a:rPr lang="en-US"/>
               <a:t>Click to edit Master text styles</a:t>
             </a:r>
           </a:p>
@@ -2512,7 +2509,7 @@
           <a:p>
             <a:fld id="{5BCAD085-E8A6-8845-BD4E-CB4CCA059FC4}" type="datetimeFigureOut">
               <a:rPr lang="en-US" smtClean="0"/>
-              <a:t>1/27/13</a:t>
+              <a:t>6/1/26</a:t>
             </a:fld>
             <a:endParaRPr lang="en-US"/>
           </a:p>
@@ -2621,10 +2618,9 @@
           <a:lstStyle/>
           <a:p>
             <a:r>
-              <a:rPr lang="en-US" smtClean="0"/>
+              <a:rPr lang="en-US"/>
               <a:t>Click to edit Master title style</a:t>
             </a:r>
-            <a:endParaRPr lang="en-US"/>
           </a:p>
         </p:txBody>
       </p:sp>
@@ -2655,38 +2651,37 @@
           <a:p>
             <a:pPr lvl="0"/>
             <a:r>
-              <a:rPr lang="en-US" smtClean="0"/>
+              <a:rPr lang="en-US"/>
               <a:t>Click to edit Master text styles</a:t>
             </a:r>
           </a:p>
           <a:p>
             <a:pPr lvl="1"/>
             <a:r>
-              <a:rPr lang="en-US" smtClean="0"/>
+              <a:rPr lang="en-US"/>
               <a:t>Second level</a:t>
             </a:r>
           </a:p>
           <a:p>
             <a:pPr lvl="2"/>
             <a:r>
-              <a:rPr lang="en-US" smtClean="0"/>
+              <a:rPr lang="en-US"/>
               <a:t>Third level</a:t>
             </a:r>
           </a:p>
           <a:p>
             <a:pPr lvl="3"/>
             <a:r>
-              <a:rPr lang="en-US" smtClean="0"/>
+              <a:rPr lang="en-US"/>
               <a:t>Fourth level</a:t>
             </a:r>
           </a:p>
           <a:p>
             <a:pPr lvl="4"/>
             <a:r>
-              <a:rPr lang="en-US" smtClean="0"/>
+              <a:rPr lang="en-US"/>
               <a:t>Fifth level</a:t>
             </a:r>
-            <a:endParaRPr lang="en-US"/>
           </a:p>
         </p:txBody>
       </p:sp>
@@ -2725,7 +2720,7 @@
           <a:p>
             <a:fld id="{5BCAD085-E8A6-8845-BD4E-CB4CCA059FC4}" type="datetimeFigureOut">
               <a:rPr lang="en-US" smtClean="0"/>
-              <a:t>1/27/13</a:t>
+              <a:t>6/1/26</a:t>
             </a:fld>
             <a:endParaRPr lang="en-US"/>
           </a:p>
@@ -3084,7 +3079,7 @@
 </file>
 
 <file path=ppt/slides/slide1.xml><?xml version="1.0" encoding="utf-8"?>
-<p:sld xmlns:a="http://schemas.openxmlformats.org/drawingml/2006/main" xmlns:p="http://schemas.openxmlformats.org/presentationml/2006/main" xmlns:r="http://schemas.openxmlformats.org/officeDocument/2006/relationships">
+<p:sld xmlns:a="http://schemas.openxmlformats.org/drawingml/2006/main" xmlns:r="http://schemas.openxmlformats.org/officeDocument/2006/relationships" xmlns:p="http://schemas.openxmlformats.org/presentationml/2006/main">
   <p:cSld>
     <p:bg>
       <p:bgPr>
@@ -3100,7 +3095,14 @@
         <p:cNvGrpSpPr/>
         <p:nvPr/>
       </p:nvGrpSpPr>
-      <p:grpSpPr/>
+      <p:grpSpPr>
+        <a:xfrm>
+          <a:off x="0" y="0"/>
+          <a:ext cx="0" cy="0"/>
+          <a:chOff x="0" y="0"/>
+          <a:chExt cx="0" cy="0"/>
+        </a:xfrm>
+      </p:grpSpPr>
       <p:sp>
         <p:nvSpPr>
           <p:cNvPr id="2" name="TextBox 1"/>
@@ -3118,7 +3120,7 @@
           <a:noFill/>
         </p:spPr>
         <p:txBody>
-          <a:bodyPr wrap="square" lIns="0" rIns="0" tIns="0" bIns="0">
+          <a:bodyPr wrap="square" lIns="0" tIns="0" rIns="0" bIns="0">
             <a:spAutoFit/>
           </a:bodyPr>
           <a:lstStyle/>
@@ -3157,7 +3159,7 @@
           <a:noFill/>
         </p:spPr>
         <p:txBody>
-          <a:bodyPr wrap="square" lIns="0" rIns="0" tIns="0" bIns="0">
+          <a:bodyPr wrap="square" lIns="0" tIns="0" rIns="0" bIns="0">
             <a:spAutoFit/>
           </a:bodyPr>
           <a:lstStyle/>
@@ -3212,7 +3214,7 @@
           <a:noFill/>
         </p:spPr>
         <p:txBody>
-          <a:bodyPr wrap="square" lIns="0" rIns="0" tIns="0" bIns="0">
+          <a:bodyPr wrap="square" lIns="0" tIns="0" rIns="0" bIns="0">
             <a:spAutoFit/>
           </a:bodyPr>
           <a:lstStyle/>
@@ -3243,7 +3245,7 @@
         <p:spPr>
           <a:xfrm>
             <a:off x="731520" y="5897880"/>
-            <a:ext cx="10058400" cy="365760"/>
+            <a:ext cx="10058400" cy="273986"/>
           </a:xfrm>
           <a:prstGeom prst="rect">
             <a:avLst/>
@@ -3251,7 +3253,7 @@
           <a:noFill/>
         </p:spPr>
         <p:txBody>
-          <a:bodyPr wrap="square" lIns="0" rIns="0" tIns="0" bIns="0">
+          <a:bodyPr wrap="square" lIns="0" tIns="0" rIns="0" bIns="0">
             <a:spAutoFit/>
           </a:bodyPr>
           <a:lstStyle/>
@@ -3262,13 +3264,49 @@
               </a:lnSpc>
             </a:pPr>
             <a:r>
-              <a:rPr sz="1200" b="0">
+              <a:rPr lang="ko-KR" altLang="en-US" sz="1500" dirty="0">
                 <a:solidFill>
                   <a:srgbClr val="6B7280"/>
                 </a:solidFill>
                 <a:latin typeface="Pretendard"/>
               </a:rPr>
-              <a:t>이름 · 학번 · 2026.06</a:t>
+              <a:t>김근호</a:t>
+            </a:r>
+            <a:r>
+              <a:rPr sz="1500" b="0" dirty="0">
+                <a:solidFill>
+                  <a:srgbClr val="6B7280"/>
+                </a:solidFill>
+                <a:latin typeface="Pretendard"/>
+              </a:rPr>
+              <a:t> · </a:t>
+            </a:r>
+            <a:r>
+              <a:rPr lang="en-US" altLang="ko-KR" sz="1500" dirty="0">
+                <a:solidFill>
+                  <a:srgbClr val="6B7280"/>
+                </a:solidFill>
+                <a:latin typeface="Pretendard"/>
+              </a:rPr>
+              <a:t>20210915</a:t>
+            </a:r>
+            <a:r>
+              <a:rPr sz="1500" b="0" dirty="0">
+                <a:solidFill>
+                  <a:srgbClr val="6B7280"/>
+                </a:solidFill>
+                <a:latin typeface="Pretendard"/>
+              </a:rPr>
+              <a:t> · 2026.06</a:t>
+            </a:r>
+            <a:r>
+              <a:rPr lang="en-US" altLang="ko-KR" sz="1500" b="0" dirty="0">
+                <a:solidFill>
+                  <a:srgbClr val="6B7280"/>
+                </a:solidFill>
+                <a:latin typeface="Pretendard"/>
+              </a:rPr>
+              <a:t>.02</a:t>
             </a:r>
           </a:p>
         </p:txBody>
@@ -3290,7 +3328,7 @@
           <a:noFill/>
         </p:spPr>
         <p:txBody>
-          <a:bodyPr wrap="square" lIns="0" rIns="0" tIns="0" bIns="0">
+          <a:bodyPr wrap="square" lIns="0" tIns="0" rIns="0" bIns="0">
             <a:spAutoFit/>
           </a:bodyPr>
           <a:lstStyle/>
@@ -3307,8 +3345,23 @@
                 </a:solidFill>
                 <a:latin typeface="Pretendard"/>
               </a:rPr>
-              <a:t>https://proofolio.pages.dev</a:t>
-            </a:r>
+              <a:t>https://</a:t>
+            </a:r>
+            <a:r>
+              <a:rPr sz="1200" b="0" dirty="0" err="1">
+                <a:solidFill>
+                  <a:srgbClr val="059669"/>
+                </a:solidFill>
+                <a:latin typeface="Pretendard"/>
+              </a:rPr>
+              <a:t>proofolio.pages.dev</a:t>
+            </a:r>
+            <a:endParaRPr sz="1200" b="0" dirty="0">
+              <a:solidFill>
+                <a:srgbClr val="059669"/>
+              </a:solidFill>
+              <a:latin typeface="Pretendard"/>
+            </a:endParaRPr>
           </a:p>
         </p:txBody>
       </p:sp>
@@ -3321,7 +3374,7 @@
 </file>
 
 <file path=ppt/slides/slide2.xml><?xml version="1.0" encoding="utf-8"?>
-<p:sld xmlns:a="http://schemas.openxmlformats.org/drawingml/2006/main" xmlns:p="http://schemas.openxmlformats.org/presentationml/2006/main" xmlns:r="http://schemas.openxmlformats.org/officeDocument/2006/relationships">
+<p:sld xmlns:a="http://schemas.openxmlformats.org/drawingml/2006/main" xmlns:r="http://schemas.openxmlformats.org/officeDocument/2006/relationships" xmlns:p="http://schemas.openxmlformats.org/presentationml/2006/main">
   <p:cSld>
     <p:bg>
       <p:bgPr>
@@ -3337,7 +3390,14 @@
         <p:cNvGrpSpPr/>
         <p:nvPr/>
       </p:nvGrpSpPr>
-      <p:grpSpPr/>
+      <p:grpSpPr>
+        <a:xfrm>
+          <a:off x="0" y="0"/>
+          <a:ext cx="0" cy="0"/>
+          <a:chOff x="0" y="0"/>
+          <a:chExt cx="0" cy="0"/>
+        </a:xfrm>
+      </p:grpSpPr>
       <p:sp>
         <p:nvSpPr>
           <p:cNvPr id="2" name="TextBox 1"/>
@@ -3355,7 +3415,7 @@
           <a:noFill/>
         </p:spPr>
         <p:txBody>
-          <a:bodyPr wrap="square" lIns="0" rIns="0" tIns="0" bIns="0">
+          <a:bodyPr wrap="square" lIns="0" tIns="0" rIns="0" bIns="0">
             <a:spAutoFit/>
           </a:bodyPr>
           <a:lstStyle/>
@@ -3394,7 +3454,7 @@
           <a:noFill/>
         </p:spPr>
         <p:txBody>
-          <a:bodyPr wrap="square" lIns="0" rIns="0" tIns="0" bIns="0">
+          <a:bodyPr wrap="square" lIns="0" tIns="0" rIns="0" bIns="0">
             <a:spAutoFit/>
           </a:bodyPr>
           <a:lstStyle/>
@@ -3472,6 +3532,7 @@
           <a:lstStyle/>
           <a:p>
             <a:pPr algn="ctr"/>
+            <a:endParaRPr/>
           </a:p>
         </p:txBody>
       </p:sp>
@@ -3492,7 +3553,7 @@
           <a:noFill/>
         </p:spPr>
         <p:txBody>
-          <a:bodyPr wrap="square" lIns="0" rIns="0" tIns="0" bIns="0">
+          <a:bodyPr wrap="square" lIns="0" tIns="0" rIns="0" bIns="0">
             <a:spAutoFit/>
           </a:bodyPr>
           <a:lstStyle/>
@@ -3531,7 +3592,7 @@
           <a:noFill/>
         </p:spPr>
         <p:txBody>
-          <a:bodyPr wrap="square" lIns="0" rIns="0" tIns="0" bIns="0">
+          <a:bodyPr wrap="square" lIns="0" tIns="0" rIns="0" bIns="0">
             <a:spAutoFit/>
           </a:bodyPr>
           <a:lstStyle/>
@@ -3570,7 +3631,7 @@
           <a:noFill/>
         </p:spPr>
         <p:txBody>
-          <a:bodyPr wrap="square" lIns="0" rIns="0" tIns="0" bIns="0">
+          <a:bodyPr wrap="square" lIns="0" tIns="0" rIns="0" bIns="0">
             <a:spAutoFit/>
           </a:bodyPr>
           <a:lstStyle/>
@@ -3601,7 +3662,7 @@
 </file>
 
 <file path=ppt/slides/slide3.xml><?xml version="1.0" encoding="utf-8"?>
-<p:sld xmlns:a="http://schemas.openxmlformats.org/drawingml/2006/main" xmlns:p="http://schemas.openxmlformats.org/presentationml/2006/main" xmlns:r="http://schemas.openxmlformats.org/officeDocument/2006/relationships">
+<p:sld xmlns:a="http://schemas.openxmlformats.org/drawingml/2006/main" xmlns:r="http://schemas.openxmlformats.org/officeDocument/2006/relationships" xmlns:p="http://schemas.openxmlformats.org/presentationml/2006/main">
   <p:cSld>
     <p:bg>
       <p:bgPr>
@@ -3617,7 +3678,14 @@
         <p:cNvGrpSpPr/>
         <p:nvPr/>
       </p:nvGrpSpPr>
-      <p:grpSpPr/>
+      <p:grpSpPr>
+        <a:xfrm>
+          <a:off x="0" y="0"/>
+          <a:ext cx="0" cy="0"/>
+          <a:chOff x="0" y="0"/>
+          <a:chExt cx="0" cy="0"/>
+        </a:xfrm>
+      </p:grpSpPr>
       <p:sp>
         <p:nvSpPr>
           <p:cNvPr id="2" name="TextBox 1"/>
@@ -3635,7 +3703,7 @@
           <a:noFill/>
         </p:spPr>
         <p:txBody>
-          <a:bodyPr wrap="square" lIns="0" rIns="0" tIns="0" bIns="0">
+          <a:bodyPr wrap="square" lIns="0" tIns="0" rIns="0" bIns="0">
             <a:spAutoFit/>
           </a:bodyPr>
           <a:lstStyle/>
@@ -3674,7 +3742,7 @@
           <a:noFill/>
         </p:spPr>
         <p:txBody>
-          <a:bodyPr wrap="square" lIns="0" rIns="0" tIns="0" bIns="0">
+          <a:bodyPr wrap="square" lIns="0" tIns="0" rIns="0" bIns="0">
             <a:spAutoFit/>
           </a:bodyPr>
           <a:lstStyle/>
@@ -3752,6 +3820,7 @@
           <a:lstStyle/>
           <a:p>
             <a:pPr algn="ctr"/>
+            <a:endParaRPr/>
           </a:p>
         </p:txBody>
       </p:sp>
@@ -3772,7 +3841,7 @@
           <a:noFill/>
         </p:spPr>
         <p:txBody>
-          <a:bodyPr wrap="square" lIns="0" rIns="0" tIns="0" bIns="0">
+          <a:bodyPr wrap="square" lIns="0" tIns="0" rIns="0" bIns="0">
             <a:spAutoFit/>
           </a:bodyPr>
           <a:lstStyle/>
@@ -3811,7 +3880,7 @@
           <a:noFill/>
         </p:spPr>
         <p:txBody>
-          <a:bodyPr wrap="square" lIns="0" rIns="0" tIns="0" bIns="0">
+          <a:bodyPr wrap="square" lIns="0" tIns="0" rIns="0" bIns="0">
             <a:spAutoFit/>
           </a:bodyPr>
           <a:lstStyle/>
@@ -3866,7 +3935,7 @@
           <a:noFill/>
         </p:spPr>
         <p:txBody>
-          <a:bodyPr wrap="square" lIns="0" rIns="0" tIns="0" bIns="0">
+          <a:bodyPr wrap="square" lIns="0" tIns="0" rIns="0" bIns="0">
             <a:spAutoFit/>
           </a:bodyPr>
           <a:lstStyle/>
@@ -3905,7 +3974,7 @@
           <a:noFill/>
         </p:spPr>
         <p:txBody>
-          <a:bodyPr wrap="square" lIns="0" rIns="0" tIns="0" bIns="0">
+          <a:bodyPr wrap="square" lIns="0" tIns="0" rIns="0" bIns="0">
             <a:spAutoFit/>
           </a:bodyPr>
           <a:lstStyle/>
@@ -3944,7 +4013,7 @@
           <a:noFill/>
         </p:spPr>
         <p:txBody>
-          <a:bodyPr wrap="square" lIns="0" rIns="0" tIns="0" bIns="0">
+          <a:bodyPr wrap="square" lIns="0" tIns="0" rIns="0" bIns="0">
             <a:spAutoFit/>
           </a:bodyPr>
           <a:lstStyle/>
@@ -3983,7 +4052,7 @@
           <a:noFill/>
         </p:spPr>
         <p:txBody>
-          <a:bodyPr wrap="square" lIns="0" rIns="0" tIns="0" bIns="0">
+          <a:bodyPr wrap="square" lIns="0" tIns="0" rIns="0" bIns="0">
             <a:spAutoFit/>
           </a:bodyPr>
           <a:lstStyle/>
@@ -4014,7 +4083,7 @@
 </file>
 
 <file path=ppt/slides/slide4.xml><?xml version="1.0" encoding="utf-8"?>
-<p:sld xmlns:a="http://schemas.openxmlformats.org/drawingml/2006/main" xmlns:p="http://schemas.openxmlformats.org/presentationml/2006/main" xmlns:r="http://schemas.openxmlformats.org/officeDocument/2006/relationships">
+<p:sld xmlns:a="http://schemas.openxmlformats.org/drawingml/2006/main" xmlns:r="http://schemas.openxmlformats.org/officeDocument/2006/relationships" xmlns:p="http://schemas.openxmlformats.org/presentationml/2006/main">
   <p:cSld>
     <p:bg>
       <p:bgPr>
@@ -4030,7 +4099,14 @@
         <p:cNvGrpSpPr/>
         <p:nvPr/>
       </p:nvGrpSpPr>
-      <p:grpSpPr/>
+      <p:grpSpPr>
+        <a:xfrm>
+          <a:off x="0" y="0"/>
+          <a:ext cx="0" cy="0"/>
+          <a:chOff x="0" y="0"/>
+          <a:chExt cx="0" cy="0"/>
+        </a:xfrm>
+      </p:grpSpPr>
       <p:sp>
         <p:nvSpPr>
           <p:cNvPr id="2" name="TextBox 1"/>
@@ -4048,7 +4124,7 @@
           <a:noFill/>
         </p:spPr>
         <p:txBody>
-          <a:bodyPr wrap="square" lIns="0" rIns="0" tIns="0" bIns="0">
+          <a:bodyPr wrap="square" lIns="0" tIns="0" rIns="0" bIns="0">
             <a:spAutoFit/>
           </a:bodyPr>
           <a:lstStyle/>
@@ -4078,8 +4154,8 @@
         </p:nvSpPr>
         <p:spPr>
           <a:xfrm>
-            <a:off x="731520" y="2377440"/>
-            <a:ext cx="10972800" cy="2194560"/>
+            <a:off x="731520" y="1734533"/>
+            <a:ext cx="10972800" cy="3801041"/>
           </a:xfrm>
           <a:prstGeom prst="rect">
             <a:avLst/>
@@ -4087,7 +4163,7 @@
           <a:noFill/>
         </p:spPr>
         <p:txBody>
-          <a:bodyPr wrap="square" lIns="0" rIns="0" tIns="0" bIns="0">
+          <a:bodyPr wrap="square" lIns="0" tIns="0" rIns="0" bIns="0">
             <a:spAutoFit/>
           </a:bodyPr>
           <a:lstStyle/>
@@ -4098,7 +4174,7 @@
               </a:lnSpc>
             </a:pPr>
             <a:r>
-              <a:rPr sz="16000" b="1">
+              <a:rPr sz="13000" b="1" dirty="0">
                 <a:solidFill>
                   <a:srgbClr val="0B1220"/>
                 </a:solidFill>
@@ -4114,7 +4190,7 @@
               </a:lnSpc>
             </a:pPr>
             <a:r>
-              <a:rPr sz="16000" b="1">
+              <a:rPr sz="13000" b="1" dirty="0">
                 <a:solidFill>
                   <a:srgbClr val="0B1220"/>
                 </a:solidFill>
@@ -4133,8 +4209,8 @@
         </p:nvSpPr>
         <p:spPr>
           <a:xfrm>
-            <a:off x="731520" y="5349240"/>
-            <a:ext cx="10972800" cy="457200"/>
+            <a:off x="6606228" y="2926282"/>
+            <a:ext cx="10972800" cy="551689"/>
           </a:xfrm>
           <a:prstGeom prst="rect">
             <a:avLst/>
@@ -4142,7 +4218,7 @@
           <a:noFill/>
         </p:spPr>
         <p:txBody>
-          <a:bodyPr wrap="square" lIns="0" rIns="0" tIns="0" bIns="0">
+          <a:bodyPr wrap="square" lIns="0" tIns="0" rIns="0" bIns="0">
             <a:spAutoFit/>
           </a:bodyPr>
           <a:lstStyle/>
@@ -4153,14 +4229,29 @@
               </a:lnSpc>
             </a:pPr>
             <a:r>
-              <a:rPr sz="1800" b="0">
+              <a:rPr sz="3000" b="0" dirty="0">
                 <a:solidFill>
                   <a:srgbClr val="059669"/>
                 </a:solidFill>
                 <a:latin typeface="Pretendard"/>
               </a:rPr>
-              <a:t>https://proofolio.pages.dev</a:t>
-            </a:r>
+              <a:t>https://</a:t>
+            </a:r>
+            <a:r>
+              <a:rPr sz="3000" b="0" dirty="0" err="1">
+                <a:solidFill>
+                  <a:srgbClr val="059669"/>
+                </a:solidFill>
+                <a:latin typeface="Pretendard"/>
+              </a:rPr>
+              <a:t>proofolio.pages.dev</a:t>
+            </a:r>
+            <a:endParaRPr sz="3000" b="0" dirty="0">
+              <a:solidFill>
+                <a:srgbClr val="059669"/>
+              </a:solidFill>
+              <a:latin typeface="Pretendard"/>
+            </a:endParaRPr>
           </a:p>
         </p:txBody>
       </p:sp>
@@ -4172,8 +4263,8 @@
         </p:nvSpPr>
         <p:spPr>
           <a:xfrm>
-            <a:off x="731520" y="5806440"/>
-            <a:ext cx="10972800" cy="457200"/>
+            <a:off x="7670939" y="3635053"/>
+            <a:ext cx="10972800" cy="255711"/>
           </a:xfrm>
           <a:prstGeom prst="rect">
             <a:avLst/>
@@ -4181,7 +4272,7 @@
           <a:noFill/>
         </p:spPr>
         <p:txBody>
-          <a:bodyPr wrap="square" lIns="0" rIns="0" tIns="0" bIns="0">
+          <a:bodyPr wrap="square" lIns="0" tIns="0" rIns="0" bIns="0">
             <a:spAutoFit/>
           </a:bodyPr>
           <a:lstStyle/>
@@ -4192,13 +4283,76 @@
               </a:lnSpc>
             </a:pPr>
             <a:r>
-              <a:rPr sz="1400" b="0">
+              <a:rPr sz="1400" b="0" dirty="0" err="1">
                 <a:solidFill>
                   <a:srgbClr val="6B7280"/>
                 </a:solidFill>
                 <a:latin typeface="Pretendard"/>
               </a:rPr>
-              <a:t>발급 → 검증 → 위변조 감지 (90초)</a:t>
+              <a:t>발급</a:t>
+            </a:r>
+            <a:r>
+              <a:rPr sz="1400" b="0" dirty="0">
+                <a:solidFill>
+                  <a:srgbClr val="6B7280"/>
+                </a:solidFill>
+                <a:latin typeface="Pretendard"/>
+              </a:rPr>
+              <a:t> → </a:t>
+            </a:r>
+            <a:r>
+              <a:rPr sz="1400" b="0" dirty="0" err="1">
+                <a:solidFill>
+                  <a:srgbClr val="6B7280"/>
+                </a:solidFill>
+                <a:latin typeface="Pretendard"/>
+              </a:rPr>
+              <a:t>검증</a:t>
+            </a:r>
+            <a:r>
+              <a:rPr sz="1400" b="0" dirty="0">
+                <a:solidFill>
+                  <a:srgbClr val="6B7280"/>
+                </a:solidFill>
+                <a:latin typeface="Pretendard"/>
+              </a:rPr>
+              <a:t> → </a:t>
+            </a:r>
+            <a:r>
+              <a:rPr sz="1400" b="0" dirty="0" err="1">
+                <a:solidFill>
+                  <a:srgbClr val="6B7280"/>
+                </a:solidFill>
+                <a:latin typeface="Pretendard"/>
+              </a:rPr>
+              <a:t>위변조</a:t>
+            </a:r>
+            <a:r>
+              <a:rPr sz="1400" b="0" dirty="0">
+                <a:solidFill>
+                  <a:srgbClr val="6B7280"/>
+                </a:solidFill>
+                <a:latin typeface="Pretendard"/>
+              </a:rPr>
+              <a:t> </a:t>
+            </a:r>
+            <a:r>
+              <a:rPr sz="1400" b="0" dirty="0" err="1">
+                <a:solidFill>
+                  <a:srgbClr val="6B7280"/>
+                </a:solidFill>
+                <a:latin typeface="Pretendard"/>
+              </a:rPr>
+              <a:t>감지</a:t>
+            </a:r>
+            <a:r>
+              <a:rPr sz="1400" b="0" dirty="0">
+                <a:solidFill>
+                  <a:srgbClr val="6B7280"/>
+                </a:solidFill>
+                <a:latin typeface="Pretendard"/>
+              </a:rPr>
+              <a:t> </a:t>
             </a:r>
           </a:p>
         </p:txBody>
@@ -4212,7 +4366,7 @@
 </file>
 
 <file path=ppt/slides/slide5.xml><?xml version="1.0" encoding="utf-8"?>
-<p:sld xmlns:a="http://schemas.openxmlformats.org/drawingml/2006/main" xmlns:p="http://schemas.openxmlformats.org/presentationml/2006/main" xmlns:r="http://schemas.openxmlformats.org/officeDocument/2006/relationships">
+<p:sld xmlns:a="http://schemas.openxmlformats.org/drawingml/2006/main" xmlns:r="http://schemas.openxmlformats.org/officeDocument/2006/relationships" xmlns:p="http://schemas.openxmlformats.org/presentationml/2006/main">
   <p:cSld>
     <p:bg>
       <p:bgPr>
@@ -4228,7 +4382,14 @@
         <p:cNvGrpSpPr/>
         <p:nvPr/>
       </p:nvGrpSpPr>
-      <p:grpSpPr/>
+      <p:grpSpPr>
+        <a:xfrm>
+          <a:off x="0" y="0"/>
+          <a:ext cx="0" cy="0"/>
+          <a:chOff x="0" y="0"/>
+          <a:chExt cx="0" cy="0"/>
+        </a:xfrm>
+      </p:grpSpPr>
       <p:sp>
         <p:nvSpPr>
           <p:cNvPr id="2" name="TextBox 1"/>
@@ -4246,7 +4407,7 @@
           <a:noFill/>
         </p:spPr>
         <p:txBody>
-          <a:bodyPr wrap="square" lIns="0" rIns="0" tIns="0" bIns="0">
+          <a:bodyPr wrap="square" lIns="0" tIns="0" rIns="0" bIns="0">
             <a:spAutoFit/>
           </a:bodyPr>
           <a:lstStyle/>
@@ -4285,7 +4446,7 @@
           <a:noFill/>
         </p:spPr>
         <p:txBody>
-          <a:bodyPr wrap="square" lIns="0" rIns="0" tIns="0" bIns="0">
+          <a:bodyPr wrap="square" lIns="0" tIns="0" rIns="0" bIns="0">
             <a:spAutoFit/>
           </a:bodyPr>
           <a:lstStyle/>
@@ -4315,7 +4476,7 @@
         </p:nvSpPr>
         <p:spPr>
           <a:xfrm>
-            <a:off x="731520" y="2331720"/>
+            <a:off x="731520" y="2377440"/>
             <a:ext cx="10972800" cy="2377440"/>
           </a:xfrm>
           <a:prstGeom prst="rect">
@@ -4324,7 +4485,7 @@
           <a:noFill/>
         </p:spPr>
         <p:txBody>
-          <a:bodyPr wrap="square" lIns="0" rIns="0" tIns="0" bIns="0">
+          <a:bodyPr wrap="square" lIns="0" tIns="0" rIns="0" bIns="0">
             <a:spAutoFit/>
           </a:bodyPr>
           <a:lstStyle/>
@@ -4335,13 +4496,103 @@
               </a:lnSpc>
             </a:pPr>
             <a:r>
-              <a:rPr sz="1200" b="0">
+              <a:rPr sz="1200" b="0" dirty="0">
                 <a:solidFill>
                   <a:srgbClr val="3F4757"/>
                 </a:solidFill>
                 <a:latin typeface="Menlo"/>
               </a:rPr>
-              <a:t>[발급기관 지갑]  ─ issueCredential ─▶  [Proofolio · Sepolia]</a:t>
+              <a:t>[</a:t>
+            </a:r>
+            <a:r>
+              <a:rPr sz="1200" b="0" dirty="0" err="1">
+                <a:solidFill>
+                  <a:srgbClr val="3F4757"/>
+                </a:solidFill>
+                <a:latin typeface="Menlo"/>
+              </a:rPr>
+              <a:t>발급기관</a:t>
+            </a:r>
+            <a:r>
+              <a:rPr sz="1200" b="0" dirty="0">
+                <a:solidFill>
+                  <a:srgbClr val="3F4757"/>
+                </a:solidFill>
+                <a:latin typeface="Menlo"/>
+              </a:rPr>
+              <a:t> </a:t>
+            </a:r>
+            <a:r>
+              <a:rPr sz="1200" b="0" dirty="0" err="1">
+                <a:solidFill>
+                  <a:srgbClr val="3F4757"/>
+                </a:solidFill>
+                <a:latin typeface="Menlo"/>
+              </a:rPr>
+              <a:t>지갑</a:t>
+            </a:r>
+            <a:r>
+              <a:rPr sz="1200" b="0" dirty="0">
+                <a:solidFill>
+                  <a:srgbClr val="3F4757"/>
+                </a:solidFill>
+                <a:latin typeface="Menlo"/>
+              </a:rPr>
+              <a:t>]  ─ </a:t>
+            </a:r>
+            <a:r>
+              <a:rPr sz="1200" b="0" dirty="0" err="1">
+                <a:solidFill>
+                  <a:srgbClr val="3F4757"/>
+                </a:solidFill>
+                <a:latin typeface="Menlo"/>
+              </a:rPr>
+              <a:t>issueCredential</a:t>
+            </a:r>
+            <a:r>
+              <a:rPr sz="1200" b="0" dirty="0">
+                <a:solidFill>
+                  <a:srgbClr val="3F4757"/>
+                </a:solidFill>
+                <a:latin typeface="Menlo"/>
+              </a:rPr>
+              <a:t> ─▶  [</a:t>
+            </a:r>
+            <a:r>
+              <a:rPr sz="1200" b="0" dirty="0" err="1">
+                <a:solidFill>
+                  <a:srgbClr val="3F4757"/>
+                </a:solidFill>
+                <a:latin typeface="Menlo"/>
+              </a:rPr>
+              <a:t>Proofolio</a:t>
+            </a:r>
+            <a:r>
+              <a:rPr sz="1200" b="0" dirty="0">
+                <a:solidFill>
+                  <a:srgbClr val="3F4757"/>
+                </a:solidFill>
+                <a:latin typeface="Menlo"/>
+              </a:rPr>
+              <a:t> · </a:t>
+            </a:r>
+            <a:r>
+              <a:rPr sz="1200" b="0" dirty="0" err="1">
+                <a:solidFill>
+                  <a:srgbClr val="3F4757"/>
+                </a:solidFill>
+                <a:latin typeface="Menlo"/>
+              </a:rPr>
+              <a:t>Sepolia</a:t>
+            </a:r>
+            <a:r>
+              <a:rPr sz="1200" b="0" dirty="0">
+                <a:solidFill>
+                  <a:srgbClr val="3F4757"/>
+                </a:solidFill>
+                <a:latin typeface="Menlo"/>
+              </a:rPr>
+              <a:t>]</a:t>
             </a:r>
           </a:p>
           <a:p>
@@ -4351,7 +4602,7 @@
               </a:lnSpc>
             </a:pPr>
             <a:r>
-              <a:rPr sz="1200" b="0">
+              <a:rPr sz="1200" b="0" dirty="0">
                 <a:solidFill>
                   <a:srgbClr val="3F4757"/>
                 </a:solidFill>
@@ -4367,7 +4618,7 @@
               </a:lnSpc>
             </a:pPr>
             <a:r>
-              <a:rPr sz="1200" b="0">
+              <a:rPr sz="1200" b="0" dirty="0">
                 <a:solidFill>
                   <a:srgbClr val="3F4757"/>
                 </a:solidFill>
@@ -4383,13 +4634,31 @@
               </a:lnSpc>
             </a:pPr>
             <a:r>
-              <a:rPr sz="1200" b="0">
+              <a:rPr sz="1200" b="0" dirty="0">
                 <a:solidFill>
                   <a:srgbClr val="3F4757"/>
                 </a:solidFill>
                 <a:latin typeface="Menlo"/>
               </a:rPr>
-              <a:t>                                       [소울바운드 ERC-721]</a:t>
+              <a:t>                                       [</a:t>
+            </a:r>
+            <a:r>
+              <a:rPr sz="1200" b="0" dirty="0" err="1">
+                <a:solidFill>
+                  <a:srgbClr val="3F4757"/>
+                </a:solidFill>
+                <a:latin typeface="Menlo"/>
+              </a:rPr>
+              <a:t>소울바운드</a:t>
+            </a:r>
+            <a:r>
+              <a:rPr sz="1200" b="0" dirty="0">
+                <a:solidFill>
+                  <a:srgbClr val="3F4757"/>
+                </a:solidFill>
+                <a:latin typeface="Menlo"/>
+              </a:rPr>
+              <a:t> ERC-721]</a:t>
             </a:r>
           </a:p>
           <a:p>
@@ -4399,13 +4668,49 @@
               </a:lnSpc>
             </a:pPr>
             <a:r>
-              <a:rPr sz="1200" b="0">
+              <a:rPr sz="1200" b="0" dirty="0">
                 <a:solidFill>
                   <a:srgbClr val="3F4757"/>
                 </a:solidFill>
                 <a:latin typeface="Menlo"/>
               </a:rPr>
-              <a:t>                                          (보유자 지갑)</a:t>
+              <a:t>                                          (</a:t>
+            </a:r>
+            <a:r>
+              <a:rPr sz="1200" b="0" dirty="0" err="1">
+                <a:solidFill>
+                  <a:srgbClr val="3F4757"/>
+                </a:solidFill>
+                <a:latin typeface="Menlo"/>
+              </a:rPr>
+              <a:t>보유자</a:t>
+            </a:r>
+            <a:r>
+              <a:rPr sz="1200" b="0" dirty="0">
+                <a:solidFill>
+                  <a:srgbClr val="3F4757"/>
+                </a:solidFill>
+                <a:latin typeface="Menlo"/>
+              </a:rPr>
+              <a:t> </a:t>
+            </a:r>
+            <a:r>
+              <a:rPr sz="1200" b="0" dirty="0" err="1">
+                <a:solidFill>
+                  <a:srgbClr val="3F4757"/>
+                </a:solidFill>
+                <a:latin typeface="Menlo"/>
+              </a:rPr>
+              <a:t>지갑</a:t>
+            </a:r>
+            <a:r>
+              <a:rPr sz="1200" b="0" dirty="0">
+                <a:solidFill>
+                  <a:srgbClr val="3F4757"/>
+                </a:solidFill>
+                <a:latin typeface="Menlo"/>
+              </a:rPr>
+              <a:t>)</a:t>
             </a:r>
           </a:p>
           <a:p>
@@ -4415,7 +4720,7 @@
               </a:lnSpc>
             </a:pPr>
             <a:r>
-              <a:rPr sz="1200" b="0">
+              <a:rPr sz="1200" b="0" dirty="0">
                 <a:solidFill>
                   <a:srgbClr val="3F4757"/>
                 </a:solidFill>
@@ -4431,13 +4736,67 @@
               </a:lnSpc>
             </a:pPr>
             <a:r>
-              <a:rPr sz="1200" b="0">
+              <a:rPr sz="1200" b="0" dirty="0">
                 <a:solidFill>
                   <a:srgbClr val="3F4757"/>
                 </a:solidFill>
                 <a:latin typeface="Menlo"/>
               </a:rPr>
-              <a:t>          (지갑 없이) ◀─ verify(tokenId) + keccak256 ─┘</a:t>
+              <a:t>          (</a:t>
+            </a:r>
+            <a:r>
+              <a:rPr sz="1200" b="0" dirty="0" err="1">
+                <a:solidFill>
+                  <a:srgbClr val="3F4757"/>
+                </a:solidFill>
+                <a:latin typeface="Menlo"/>
+              </a:rPr>
+              <a:t>지갑</a:t>
+            </a:r>
+            <a:r>
+              <a:rPr sz="1200" b="0" dirty="0">
+                <a:solidFill>
+                  <a:srgbClr val="3F4757"/>
+                </a:solidFill>
+                <a:latin typeface="Menlo"/>
+              </a:rPr>
+              <a:t> </a:t>
+            </a:r>
+            <a:r>
+              <a:rPr sz="1200" b="0" dirty="0" err="1">
+                <a:solidFill>
+                  <a:srgbClr val="3F4757"/>
+                </a:solidFill>
+                <a:latin typeface="Menlo"/>
+              </a:rPr>
+              <a:t>없이</a:t>
+            </a:r>
+            <a:r>
+              <a:rPr sz="1200" b="0" dirty="0">
+                <a:solidFill>
+                  <a:srgbClr val="3F4757"/>
+                </a:solidFill>
+                <a:latin typeface="Menlo"/>
+              </a:rPr>
+              <a:t>) ◀─ verify(</a:t>
+            </a:r>
+            <a:r>
+              <a:rPr sz="1200" b="0" dirty="0" err="1">
+                <a:solidFill>
+                  <a:srgbClr val="3F4757"/>
+                </a:solidFill>
+                <a:latin typeface="Menlo"/>
+              </a:rPr>
+              <a:t>tokenId</a:t>
+            </a:r>
+            <a:r>
+              <a:rPr sz="1200" b="0" dirty="0">
+                <a:solidFill>
+                  <a:srgbClr val="3F4757"/>
+                </a:solidFill>
+                <a:latin typeface="Menlo"/>
+              </a:rPr>
+              <a:t>) + keccak256 ─┘</a:t>
             </a:r>
           </a:p>
           <a:p>
@@ -4447,14 +4806,65 @@
               </a:lnSpc>
             </a:pPr>
             <a:r>
-              <a:rPr sz="1200" b="0">
+              <a:rPr sz="1200" b="0" dirty="0">
                 <a:solidFill>
                   <a:srgbClr val="3F4757"/>
                 </a:solidFill>
                 <a:latin typeface="Menlo"/>
               </a:rPr>
-              <a:t>                       검증자가 직접 RPC 호출</a:t>
-            </a:r>
+              <a:t>                       </a:t>
+            </a:r>
+            <a:r>
+              <a:rPr sz="1200" b="0" dirty="0" err="1">
+                <a:solidFill>
+                  <a:srgbClr val="3F4757"/>
+                </a:solidFill>
+                <a:latin typeface="Menlo"/>
+              </a:rPr>
+              <a:t>검증자가</a:t>
+            </a:r>
+            <a:r>
+              <a:rPr sz="1200" b="0" dirty="0">
+                <a:solidFill>
+                  <a:srgbClr val="3F4757"/>
+                </a:solidFill>
+                <a:latin typeface="Menlo"/>
+              </a:rPr>
+              <a:t> </a:t>
+            </a:r>
+            <a:r>
+              <a:rPr sz="1200" b="0" dirty="0" err="1">
+                <a:solidFill>
+                  <a:srgbClr val="3F4757"/>
+                </a:solidFill>
+                <a:latin typeface="Menlo"/>
+              </a:rPr>
+              <a:t>직접</a:t>
+            </a:r>
+            <a:r>
+              <a:rPr sz="1200" b="0" dirty="0">
+                <a:solidFill>
+                  <a:srgbClr val="3F4757"/>
+                </a:solidFill>
+                <a:latin typeface="Menlo"/>
+              </a:rPr>
+              <a:t> RPC </a:t>
+            </a:r>
+            <a:r>
+              <a:rPr sz="1200" b="0" dirty="0" err="1">
+                <a:solidFill>
+                  <a:srgbClr val="3F4757"/>
+                </a:solidFill>
+                <a:latin typeface="Menlo"/>
+              </a:rPr>
+              <a:t>호출</a:t>
+            </a:r>
+            <a:endParaRPr sz="1200" b="0" dirty="0">
+              <a:solidFill>
+                <a:srgbClr val="3F4757"/>
+              </a:solidFill>
+              <a:latin typeface="Menlo"/>
+            </a:endParaRPr>
           </a:p>
         </p:txBody>
       </p:sp>
@@ -4498,6 +4908,7 @@
           <a:lstStyle/>
           <a:p>
             <a:pPr algn="ctr"/>
+            <a:endParaRPr/>
           </a:p>
         </p:txBody>
       </p:sp>
@@ -4518,7 +4929,7 @@
           <a:noFill/>
         </p:spPr>
         <p:txBody>
-          <a:bodyPr wrap="square" lIns="0" rIns="0" tIns="0" bIns="0">
+          <a:bodyPr wrap="square" lIns="0" tIns="0" rIns="0" bIns="0">
             <a:spAutoFit/>
           </a:bodyPr>
           <a:lstStyle/>
@@ -4529,13 +4940,31 @@
               </a:lnSpc>
             </a:pPr>
             <a:r>
-              <a:rPr sz="1400" b="0">
+              <a:rPr sz="1400" b="0" dirty="0">
                 <a:solidFill>
                   <a:srgbClr val="0B1220"/>
                 </a:solidFill>
                 <a:latin typeface="Pretendard"/>
               </a:rPr>
-              <a:t>·  ERC-721 + Ownable2Step + 소울바운드 (_update mint-only)</a:t>
+              <a:t>·  ERC-721 + Ownable2Step + </a:t>
+            </a:r>
+            <a:r>
+              <a:rPr sz="1400" b="0" dirty="0" err="1">
+                <a:solidFill>
+                  <a:srgbClr val="0B1220"/>
+                </a:solidFill>
+                <a:latin typeface="Pretendard"/>
+              </a:rPr>
+              <a:t>소울바운드</a:t>
+            </a:r>
+            <a:r>
+              <a:rPr sz="1400" b="0" dirty="0">
+                <a:solidFill>
+                  <a:srgbClr val="0B1220"/>
+                </a:solidFill>
+                <a:latin typeface="Pretendard"/>
+              </a:rPr>
+              <a:t> (_update mint-only)</a:t>
             </a:r>
           </a:p>
         </p:txBody>
@@ -4557,7 +4986,7 @@
           <a:noFill/>
         </p:spPr>
         <p:txBody>
-          <a:bodyPr wrap="square" lIns="0" rIns="0" tIns="0" bIns="0">
+          <a:bodyPr wrap="square" lIns="0" tIns="0" rIns="0" bIns="0">
             <a:spAutoFit/>
           </a:bodyPr>
           <a:lstStyle/>
@@ -4596,7 +5025,7 @@
           <a:noFill/>
         </p:spPr>
         <p:txBody>
-          <a:bodyPr wrap="square" lIns="0" rIns="0" tIns="0" bIns="0">
+          <a:bodyPr wrap="square" lIns="0" tIns="0" rIns="0" bIns="0">
             <a:spAutoFit/>
           </a:bodyPr>
           <a:lstStyle/>
@@ -4635,7 +5064,7 @@
           <a:noFill/>
         </p:spPr>
         <p:txBody>
-          <a:bodyPr wrap="square" lIns="0" rIns="0" tIns="0" bIns="0">
+          <a:bodyPr wrap="square" lIns="0" tIns="0" rIns="0" bIns="0">
             <a:spAutoFit/>
           </a:bodyPr>
           <a:lstStyle/>
@@ -4666,7 +5095,7 @@
 </file>
 
 <file path=ppt/slides/slide6.xml><?xml version="1.0" encoding="utf-8"?>
-<p:sld xmlns:a="http://schemas.openxmlformats.org/drawingml/2006/main" xmlns:p="http://schemas.openxmlformats.org/presentationml/2006/main" xmlns:r="http://schemas.openxmlformats.org/officeDocument/2006/relationships">
+<p:sld xmlns:a="http://schemas.openxmlformats.org/drawingml/2006/main" xmlns:r="http://schemas.openxmlformats.org/officeDocument/2006/relationships" xmlns:p="http://schemas.openxmlformats.org/presentationml/2006/main">
   <p:cSld>
     <p:bg>
       <p:bgPr>
@@ -4682,7 +5111,14 @@
         <p:cNvGrpSpPr/>
         <p:nvPr/>
       </p:nvGrpSpPr>
-      <p:grpSpPr/>
+      <p:grpSpPr>
+        <a:xfrm>
+          <a:off x="0" y="0"/>
+          <a:ext cx="0" cy="0"/>
+          <a:chOff x="0" y="0"/>
+          <a:chExt cx="0" cy="0"/>
+        </a:xfrm>
+      </p:grpSpPr>
       <p:sp>
         <p:nvSpPr>
           <p:cNvPr id="2" name="TextBox 1"/>
@@ -4700,7 +5136,7 @@
           <a:noFill/>
         </p:spPr>
         <p:txBody>
-          <a:bodyPr wrap="square" lIns="0" rIns="0" tIns="0" bIns="0">
+          <a:bodyPr wrap="square" lIns="0" tIns="0" rIns="0" bIns="0">
             <a:spAutoFit/>
           </a:bodyPr>
           <a:lstStyle/>
@@ -4739,7 +5175,7 @@
           <a:noFill/>
         </p:spPr>
         <p:txBody>
-          <a:bodyPr wrap="square" lIns="0" rIns="0" tIns="0" bIns="0">
+          <a:bodyPr wrap="square" lIns="0" tIns="0" rIns="0" bIns="0">
             <a:spAutoFit/>
           </a:bodyPr>
           <a:lstStyle/>
@@ -4778,7 +5214,7 @@
           <a:noFill/>
         </p:spPr>
         <p:txBody>
-          <a:bodyPr wrap="square" lIns="0" rIns="0" tIns="0" bIns="0">
+          <a:bodyPr wrap="square" lIns="0" tIns="0" rIns="0" bIns="0">
             <a:spAutoFit/>
           </a:bodyPr>
           <a:lstStyle/>
@@ -4817,7 +5253,7 @@
           <a:noFill/>
         </p:spPr>
         <p:txBody>
-          <a:bodyPr wrap="square" lIns="0" rIns="0" tIns="0" bIns="0">
+          <a:bodyPr wrap="square" lIns="0" tIns="0" rIns="0" bIns="0">
             <a:spAutoFit/>
           </a:bodyPr>
           <a:lstStyle/>
@@ -4828,13 +5264,139 @@
               </a:lnSpc>
             </a:pPr>
             <a:r>
-              <a:rPr sz="1400" b="0">
+              <a:rPr sz="1400" b="0" dirty="0">
                 <a:solidFill>
                   <a:srgbClr val="3F4757"/>
                 </a:solidFill>
                 <a:latin typeface="Pretendard"/>
               </a:rPr>
-              <a:t>PRD / SRS 1000줄을 AI와 같이 작성. AGENTS.md 로 규칙 박제.</a:t>
+              <a:t>PRD / SRS 1000줄을 </a:t>
+            </a:r>
+            <a:r>
+              <a:rPr sz="1400" b="0" dirty="0" err="1">
+                <a:solidFill>
+                  <a:srgbClr val="3F4757"/>
+                </a:solidFill>
+                <a:latin typeface="Pretendard"/>
+              </a:rPr>
+              <a:t>AI와</a:t>
+            </a:r>
+            <a:r>
+              <a:rPr sz="1400" b="0" dirty="0">
+                <a:solidFill>
+                  <a:srgbClr val="3F4757"/>
+                </a:solidFill>
+                <a:latin typeface="Pretendard"/>
+              </a:rPr>
+              <a:t> </a:t>
+            </a:r>
+            <a:r>
+              <a:rPr sz="1400" b="0" dirty="0" err="1">
+                <a:solidFill>
+                  <a:srgbClr val="3F4757"/>
+                </a:solidFill>
+                <a:latin typeface="Pretendard"/>
+              </a:rPr>
+              <a:t>같이</a:t>
+            </a:r>
+            <a:r>
+              <a:rPr sz="1400" b="0" dirty="0">
+                <a:solidFill>
+                  <a:srgbClr val="3F4757"/>
+                </a:solidFill>
+                <a:latin typeface="Pretendard"/>
+              </a:rPr>
+              <a:t> </a:t>
+            </a:r>
+            <a:r>
+              <a:rPr sz="1400" b="0" dirty="0" err="1">
+                <a:solidFill>
+                  <a:srgbClr val="3F4757"/>
+                </a:solidFill>
+                <a:latin typeface="Pretendard"/>
+              </a:rPr>
+              <a:t>작성</a:t>
+            </a:r>
+            <a:r>
+              <a:rPr sz="1400" b="0" dirty="0">
+                <a:solidFill>
+                  <a:srgbClr val="3F4757"/>
+                </a:solidFill>
+                <a:latin typeface="Pretendard"/>
+              </a:rPr>
+              <a:t>. </a:t>
+            </a:r>
+            <a:r>
+              <a:rPr sz="1400" b="0" dirty="0" err="1">
+                <a:solidFill>
+                  <a:srgbClr val="3F4757"/>
+                </a:solidFill>
+                <a:latin typeface="Pretendard"/>
+              </a:rPr>
+              <a:t>AGENTS.md</a:t>
+            </a:r>
+            <a:r>
+              <a:rPr sz="1400" b="0" dirty="0">
+                <a:solidFill>
+                  <a:srgbClr val="3F4757"/>
+                </a:solidFill>
+                <a:latin typeface="Pretendard"/>
+              </a:rPr>
+              <a:t> </a:t>
+            </a:r>
+            <a:r>
+              <a:rPr sz="1400" b="0" dirty="0" err="1">
+                <a:solidFill>
+                  <a:srgbClr val="3F4757"/>
+                </a:solidFill>
+                <a:latin typeface="Pretendard"/>
+              </a:rPr>
+              <a:t>로</a:t>
+            </a:r>
+            <a:r>
+              <a:rPr sz="1400" b="0" dirty="0">
+                <a:solidFill>
+                  <a:srgbClr val="3F4757"/>
+                </a:solidFill>
+                <a:latin typeface="Pretendard"/>
+              </a:rPr>
+              <a:t> </a:t>
+            </a:r>
+            <a:r>
+              <a:rPr sz="1400" b="0" dirty="0" err="1">
+                <a:solidFill>
+                  <a:srgbClr val="3F4757"/>
+                </a:solidFill>
+                <a:latin typeface="Pretendard"/>
+              </a:rPr>
+              <a:t>규칙</a:t>
+            </a:r>
+            <a:r>
+              <a:rPr sz="1400" b="0" dirty="0">
+                <a:solidFill>
+                  <a:srgbClr val="3F4757"/>
+                </a:solidFill>
+                <a:latin typeface="Pretendard"/>
+              </a:rPr>
+              <a:t> </a:t>
+            </a:r>
+            <a:r>
+              <a:rPr sz="1400" b="0" dirty="0" err="1">
+                <a:solidFill>
+                  <a:srgbClr val="3F4757"/>
+                </a:solidFill>
+                <a:latin typeface="Pretendard"/>
+              </a:rPr>
+              <a:t>박제</a:t>
+            </a:r>
+            <a:r>
+              <a:rPr sz="1400" b="0" dirty="0">
+                <a:solidFill>
+                  <a:srgbClr val="3F4757"/>
+                </a:solidFill>
+                <a:latin typeface="Pretendard"/>
+              </a:rPr>
+              <a:t>.</a:t>
             </a:r>
           </a:p>
         </p:txBody>
@@ -4856,7 +5418,7 @@
           <a:noFill/>
         </p:spPr>
         <p:txBody>
-          <a:bodyPr wrap="square" lIns="0" rIns="0" tIns="0" bIns="0">
+          <a:bodyPr wrap="square" lIns="0" tIns="0" rIns="0" bIns="0">
             <a:spAutoFit/>
           </a:bodyPr>
           <a:lstStyle/>
@@ -4895,7 +5457,7 @@
           <a:noFill/>
         </p:spPr>
         <p:txBody>
-          <a:bodyPr wrap="square" lIns="0" rIns="0" tIns="0" bIns="0">
+          <a:bodyPr wrap="square" lIns="0" tIns="0" rIns="0" bIns="0">
             <a:spAutoFit/>
           </a:bodyPr>
           <a:lstStyle/>
@@ -4934,7 +5496,7 @@
           <a:noFill/>
         </p:spPr>
         <p:txBody>
-          <a:bodyPr wrap="square" lIns="0" rIns="0" tIns="0" bIns="0">
+          <a:bodyPr wrap="square" lIns="0" tIns="0" rIns="0" bIns="0">
             <a:spAutoFit/>
           </a:bodyPr>
           <a:lstStyle/>
@@ -4973,7 +5535,7 @@
           <a:noFill/>
         </p:spPr>
         <p:txBody>
-          <a:bodyPr wrap="square" lIns="0" rIns="0" tIns="0" bIns="0">
+          <a:bodyPr wrap="square" lIns="0" tIns="0" rIns="0" bIns="0">
             <a:spAutoFit/>
           </a:bodyPr>
           <a:lstStyle/>
@@ -5012,7 +5574,7 @@
           <a:noFill/>
         </p:spPr>
         <p:txBody>
-          <a:bodyPr wrap="square" lIns="0" rIns="0" tIns="0" bIns="0">
+          <a:bodyPr wrap="square" lIns="0" tIns="0" rIns="0" bIns="0">
             <a:spAutoFit/>
           </a:bodyPr>
           <a:lstStyle/>
@@ -5051,7 +5613,7 @@
           <a:noFill/>
         </p:spPr>
         <p:txBody>
-          <a:bodyPr wrap="square" lIns="0" rIns="0" tIns="0" bIns="0">
+          <a:bodyPr wrap="square" lIns="0" tIns="0" rIns="0" bIns="0">
             <a:spAutoFit/>
           </a:bodyPr>
           <a:lstStyle/>
@@ -5082,7 +5644,7 @@
         <p:spPr>
           <a:xfrm>
             <a:off x="731520" y="6263640"/>
-            <a:ext cx="10972800" cy="457200"/>
+            <a:ext cx="10972800" cy="255711"/>
           </a:xfrm>
           <a:prstGeom prst="rect">
             <a:avLst/>
@@ -5090,7 +5652,7 @@
           <a:noFill/>
         </p:spPr>
         <p:txBody>
-          <a:bodyPr wrap="square" lIns="0" rIns="0" tIns="0" bIns="0">
+          <a:bodyPr wrap="square" lIns="0" tIns="0" rIns="0" bIns="0">
             <a:spAutoFit/>
           </a:bodyPr>
           <a:lstStyle/>
@@ -5101,13 +5663,112 @@
               </a:lnSpc>
             </a:pPr>
             <a:r>
-              <a:rPr sz="1400" b="0">
+              <a:rPr sz="1400" b="0" dirty="0" err="1">
                 <a:solidFill>
                   <a:srgbClr val="6B7280"/>
                 </a:solidFill>
                 <a:latin typeface="Pretendard"/>
               </a:rPr>
-              <a:t>AI는 빠른 손, 사람은 기준과 검증.   감사합니다.</a:t>
+              <a:t>AI는</a:t>
+            </a:r>
+            <a:r>
+              <a:rPr sz="1400" b="0" dirty="0">
+                <a:solidFill>
+                  <a:srgbClr val="6B7280"/>
+                </a:solidFill>
+                <a:latin typeface="Pretendard"/>
+              </a:rPr>
+              <a:t> </a:t>
+            </a:r>
+            <a:r>
+              <a:rPr lang="ko-KR" altLang="en-US" sz="1400" dirty="0">
+                <a:solidFill>
+                  <a:srgbClr val="6B7280"/>
+                </a:solidFill>
+                <a:latin typeface="Pretendard"/>
+              </a:rPr>
+              <a:t>구현과 재검증을 </a:t>
+            </a:r>
+            <a:r>
+              <a:rPr sz="1400" b="0" dirty="0">
+                <a:solidFill>
+                  <a:srgbClr val="6B7280"/>
+                </a:solidFill>
+                <a:latin typeface="Pretendard"/>
+              </a:rPr>
+              <a:t>, </a:t>
+            </a:r>
+            <a:r>
+              <a:rPr sz="1400" b="0" dirty="0" err="1">
+                <a:solidFill>
+                  <a:srgbClr val="6B7280"/>
+                </a:solidFill>
+                <a:latin typeface="Pretendard"/>
+              </a:rPr>
+              <a:t>사람은</a:t>
+            </a:r>
+            <a:r>
+              <a:rPr sz="1400" b="0" dirty="0">
+                <a:solidFill>
+                  <a:srgbClr val="6B7280"/>
+                </a:solidFill>
+                <a:latin typeface="Pretendard"/>
+              </a:rPr>
+              <a:t> </a:t>
+            </a:r>
+            <a:r>
+              <a:rPr sz="1400" b="0" dirty="0" err="1">
+                <a:solidFill>
+                  <a:srgbClr val="6B7280"/>
+                </a:solidFill>
+                <a:latin typeface="Pretendard"/>
+              </a:rPr>
+              <a:t>기준과</a:t>
+            </a:r>
+            <a:r>
+              <a:rPr sz="1400" b="0" dirty="0">
+                <a:solidFill>
+                  <a:srgbClr val="6B7280"/>
+                </a:solidFill>
+                <a:latin typeface="Pretendard"/>
+              </a:rPr>
+              <a:t> </a:t>
+            </a:r>
+            <a:r>
+              <a:rPr sz="1400" b="0" dirty="0" err="1">
+                <a:solidFill>
+                  <a:srgbClr val="6B7280"/>
+                </a:solidFill>
+                <a:latin typeface="Pretendard"/>
+              </a:rPr>
+              <a:t>검증</a:t>
+            </a:r>
+            <a:r>
+              <a:rPr sz="1400" b="0" dirty="0">
+                <a:solidFill>
+                  <a:srgbClr val="6B7280"/>
+                </a:solidFill>
+                <a:latin typeface="Pretendard"/>
+              </a:rPr>
+              <a:t>.   </a:t>
+            </a:r>
+            <a:r>
+              <a:rPr sz="1400" b="0" dirty="0" err="1">
+                <a:solidFill>
+                  <a:srgbClr val="6B7280"/>
+                </a:solidFill>
+                <a:latin typeface="Pretendard"/>
+              </a:rPr>
+              <a:t>감사합니다</a:t>
+            </a:r>
+            <a:r>
+              <a:rPr sz="1400" b="0" dirty="0">
+                <a:solidFill>
+                  <a:srgbClr val="6B7280"/>
+                </a:solidFill>
+                <a:latin typeface="Pretendard"/>
+              </a:rPr>
+              <a:t>.</a:t>
             </a:r>
           </a:p>
         </p:txBody>

</xml_diff>

<commit_message>
feat(deck): 7-slide layout with video/screenshot placeholders
</commit_message>
<xml_diff>
--- a/docs/Proofolio_발표.pptx
+++ b/docs/Proofolio_발표.pptx
@@ -5,14 +5,15 @@
     <p:sldMasterId id="2147483648" r:id="rId1"/>
   </p:sldMasterIdLst>
   <p:sldIdLst>
-    <p:sldId id="256" r:id="rId2"/>
-    <p:sldId id="257" r:id="rId3"/>
-    <p:sldId id="258" r:id="rId4"/>
-    <p:sldId id="259" r:id="rId5"/>
-    <p:sldId id="260" r:id="rId6"/>
-    <p:sldId id="261" r:id="rId7"/>
+    <p:sldId id="256" r:id="rId7"/>
+    <p:sldId id="257" r:id="rId8"/>
+    <p:sldId id="258" r:id="rId9"/>
+    <p:sldId id="259" r:id="rId10"/>
+    <p:sldId id="260" r:id="rId11"/>
+    <p:sldId id="261" r:id="rId12"/>
+    <p:sldId id="262" r:id="rId13"/>
   </p:sldIdLst>
-  <p:sldSz cx="12192000" cy="6858000"/>
+  <p:sldSz cx="12191695" cy="6858000" type="screen4x3"/>
   <p:notesSz cx="6858000" cy="9144000"/>
   <p:defaultTextStyle>
     <a:defPPr>
@@ -109,22 +110,6 @@
       </a:defRPr>
     </a:lvl9pPr>
   </p:defaultTextStyle>
-  <p:extLst>
-    <p:ext uri="{EFAFB233-063F-42B5-8137-9DF3F51BA10A}">
-      <p15:sldGuideLst xmlns:p15="http://schemas.microsoft.com/office/powerpoint/2012/main">
-        <p15:guide id="1" orient="horz" pos="2160">
-          <p15:clr>
-            <a:srgbClr val="A4A3A4"/>
-          </p15:clr>
-        </p15:guide>
-        <p15:guide id="2" pos="2880">
-          <p15:clr>
-            <a:srgbClr val="A4A3A4"/>
-          </p15:clr>
-        </p15:guide>
-      </p15:sldGuideLst>
-    </p:ext>
-  </p:extLst>
 </p:presentation>
 </file>
 
@@ -166,9 +151,10 @@
           <a:lstStyle/>
           <a:p>
             <a:r>
-              <a:rPr lang="en-US"/>
+              <a:rPr lang="en-US" smtClean="0"/>
               <a:t>Click to edit Master title style</a:t>
             </a:r>
+            <a:endParaRPr lang="en-US"/>
           </a:p>
         </p:txBody>
       </p:sp>
@@ -284,9 +270,10 @@
           </a:lstStyle>
           <a:p>
             <a:r>
-              <a:rPr lang="en-US"/>
+              <a:rPr lang="en-US" smtClean="0"/>
               <a:t>Click to edit Master subtitle style</a:t>
             </a:r>
+            <a:endParaRPr lang="en-US"/>
           </a:p>
         </p:txBody>
       </p:sp>
@@ -307,7 +294,7 @@
           <a:p>
             <a:fld id="{5BCAD085-E8A6-8845-BD4E-CB4CCA059FC4}" type="datetimeFigureOut">
               <a:rPr lang="en-US" smtClean="0"/>
-              <a:t>6/1/26</a:t>
+              <a:t>1/27/13</a:t>
             </a:fld>
             <a:endParaRPr lang="en-US"/>
           </a:p>
@@ -401,9 +388,10 @@
           <a:lstStyle/>
           <a:p>
             <a:r>
-              <a:rPr lang="en-US"/>
+              <a:rPr lang="en-US" smtClean="0"/>
               <a:t>Click to edit Master title style</a:t>
             </a:r>
+            <a:endParaRPr lang="en-US"/>
           </a:p>
         </p:txBody>
       </p:sp>
@@ -424,37 +412,38 @@
           <a:p>
             <a:pPr lvl="0"/>
             <a:r>
-              <a:rPr lang="en-US"/>
+              <a:rPr lang="en-US" smtClean="0"/>
               <a:t>Click to edit Master text styles</a:t>
             </a:r>
           </a:p>
           <a:p>
             <a:pPr lvl="1"/>
             <a:r>
-              <a:rPr lang="en-US"/>
+              <a:rPr lang="en-US" smtClean="0"/>
               <a:t>Second level</a:t>
             </a:r>
           </a:p>
           <a:p>
             <a:pPr lvl="2"/>
             <a:r>
-              <a:rPr lang="en-US"/>
+              <a:rPr lang="en-US" smtClean="0"/>
               <a:t>Third level</a:t>
             </a:r>
           </a:p>
           <a:p>
             <a:pPr lvl="3"/>
             <a:r>
-              <a:rPr lang="en-US"/>
+              <a:rPr lang="en-US" smtClean="0"/>
               <a:t>Fourth level</a:t>
             </a:r>
           </a:p>
           <a:p>
             <a:pPr lvl="4"/>
             <a:r>
-              <a:rPr lang="en-US"/>
+              <a:rPr lang="en-US" smtClean="0"/>
               <a:t>Fifth level</a:t>
             </a:r>
+            <a:endParaRPr lang="en-US"/>
           </a:p>
         </p:txBody>
       </p:sp>
@@ -475,7 +464,7 @@
           <a:p>
             <a:fld id="{5BCAD085-E8A6-8845-BD4E-CB4CCA059FC4}" type="datetimeFigureOut">
               <a:rPr lang="en-US" smtClean="0"/>
-              <a:t>6/1/26</a:t>
+              <a:t>1/27/13</a:t>
             </a:fld>
             <a:endParaRPr lang="en-US"/>
           </a:p>
@@ -574,9 +563,10 @@
           <a:lstStyle/>
           <a:p>
             <a:r>
-              <a:rPr lang="en-US"/>
+              <a:rPr lang="en-US" smtClean="0"/>
               <a:t>Click to edit Master title style</a:t>
             </a:r>
+            <a:endParaRPr lang="en-US"/>
           </a:p>
         </p:txBody>
       </p:sp>
@@ -602,37 +592,38 @@
           <a:p>
             <a:pPr lvl="0"/>
             <a:r>
-              <a:rPr lang="en-US"/>
+              <a:rPr lang="en-US" smtClean="0"/>
               <a:t>Click to edit Master text styles</a:t>
             </a:r>
           </a:p>
           <a:p>
             <a:pPr lvl="1"/>
             <a:r>
-              <a:rPr lang="en-US"/>
+              <a:rPr lang="en-US" smtClean="0"/>
               <a:t>Second level</a:t>
             </a:r>
           </a:p>
           <a:p>
             <a:pPr lvl="2"/>
             <a:r>
-              <a:rPr lang="en-US"/>
+              <a:rPr lang="en-US" smtClean="0"/>
               <a:t>Third level</a:t>
             </a:r>
           </a:p>
           <a:p>
             <a:pPr lvl="3"/>
             <a:r>
-              <a:rPr lang="en-US"/>
+              <a:rPr lang="en-US" smtClean="0"/>
               <a:t>Fourth level</a:t>
             </a:r>
           </a:p>
           <a:p>
             <a:pPr lvl="4"/>
             <a:r>
-              <a:rPr lang="en-US"/>
+              <a:rPr lang="en-US" smtClean="0"/>
               <a:t>Fifth level</a:t>
             </a:r>
+            <a:endParaRPr lang="en-US"/>
           </a:p>
         </p:txBody>
       </p:sp>
@@ -653,7 +644,7 @@
           <a:p>
             <a:fld id="{5BCAD085-E8A6-8845-BD4E-CB4CCA059FC4}" type="datetimeFigureOut">
               <a:rPr lang="en-US" smtClean="0"/>
-              <a:t>6/1/26</a:t>
+              <a:t>1/27/13</a:t>
             </a:fld>
             <a:endParaRPr lang="en-US"/>
           </a:p>
@@ -747,9 +738,10 @@
           <a:lstStyle/>
           <a:p>
             <a:r>
-              <a:rPr lang="en-US"/>
+              <a:rPr lang="en-US" smtClean="0"/>
               <a:t>Click to edit Master title style</a:t>
             </a:r>
+            <a:endParaRPr lang="en-US"/>
           </a:p>
         </p:txBody>
       </p:sp>
@@ -770,37 +762,38 @@
           <a:p>
             <a:pPr lvl="0"/>
             <a:r>
-              <a:rPr lang="en-US"/>
+              <a:rPr lang="en-US" smtClean="0"/>
               <a:t>Click to edit Master text styles</a:t>
             </a:r>
           </a:p>
           <a:p>
             <a:pPr lvl="1"/>
             <a:r>
-              <a:rPr lang="en-US"/>
+              <a:rPr lang="en-US" smtClean="0"/>
               <a:t>Second level</a:t>
             </a:r>
           </a:p>
           <a:p>
             <a:pPr lvl="2"/>
             <a:r>
-              <a:rPr lang="en-US"/>
+              <a:rPr lang="en-US" smtClean="0"/>
               <a:t>Third level</a:t>
             </a:r>
           </a:p>
           <a:p>
             <a:pPr lvl="3"/>
             <a:r>
-              <a:rPr lang="en-US"/>
+              <a:rPr lang="en-US" smtClean="0"/>
               <a:t>Fourth level</a:t>
             </a:r>
           </a:p>
           <a:p>
             <a:pPr lvl="4"/>
             <a:r>
-              <a:rPr lang="en-US"/>
+              <a:rPr lang="en-US" smtClean="0"/>
               <a:t>Fifth level</a:t>
             </a:r>
+            <a:endParaRPr lang="en-US"/>
           </a:p>
         </p:txBody>
       </p:sp>
@@ -821,7 +814,7 @@
           <a:p>
             <a:fld id="{5BCAD085-E8A6-8845-BD4E-CB4CCA059FC4}" type="datetimeFigureOut">
               <a:rPr lang="en-US" smtClean="0"/>
-              <a:t>6/1/26</a:t>
+              <a:t>1/27/13</a:t>
             </a:fld>
             <a:endParaRPr lang="en-US"/>
           </a:p>
@@ -924,9 +917,10 @@
           </a:lstStyle>
           <a:p>
             <a:r>
-              <a:rPr lang="en-US"/>
+              <a:rPr lang="en-US" smtClean="0"/>
               <a:t>Click to edit Master title style</a:t>
             </a:r>
+            <a:endParaRPr lang="en-US"/>
           </a:p>
         </p:txBody>
       </p:sp>
@@ -1043,7 +1037,7 @@
           <a:p>
             <a:pPr lvl="0"/>
             <a:r>
-              <a:rPr lang="en-US"/>
+              <a:rPr lang="en-US" smtClean="0"/>
               <a:t>Click to edit Master text styles</a:t>
             </a:r>
           </a:p>
@@ -1066,7 +1060,7 @@
           <a:p>
             <a:fld id="{5BCAD085-E8A6-8845-BD4E-CB4CCA059FC4}" type="datetimeFigureOut">
               <a:rPr lang="en-US" smtClean="0"/>
-              <a:t>6/1/26</a:t>
+              <a:t>1/27/13</a:t>
             </a:fld>
             <a:endParaRPr lang="en-US"/>
           </a:p>
@@ -1160,9 +1154,10 @@
           <a:lstStyle/>
           <a:p>
             <a:r>
-              <a:rPr lang="en-US"/>
+              <a:rPr lang="en-US" smtClean="0"/>
               <a:t>Click to edit Master title style</a:t>
             </a:r>
+            <a:endParaRPr lang="en-US"/>
           </a:p>
         </p:txBody>
       </p:sp>
@@ -1216,37 +1211,38 @@
           <a:p>
             <a:pPr lvl="0"/>
             <a:r>
-              <a:rPr lang="en-US"/>
+              <a:rPr lang="en-US" smtClean="0"/>
               <a:t>Click to edit Master text styles</a:t>
             </a:r>
           </a:p>
           <a:p>
             <a:pPr lvl="1"/>
             <a:r>
-              <a:rPr lang="en-US"/>
+              <a:rPr lang="en-US" smtClean="0"/>
               <a:t>Second level</a:t>
             </a:r>
           </a:p>
           <a:p>
             <a:pPr lvl="2"/>
             <a:r>
-              <a:rPr lang="en-US"/>
+              <a:rPr lang="en-US" smtClean="0"/>
               <a:t>Third level</a:t>
             </a:r>
           </a:p>
           <a:p>
             <a:pPr lvl="3"/>
             <a:r>
-              <a:rPr lang="en-US"/>
+              <a:rPr lang="en-US" smtClean="0"/>
               <a:t>Fourth level</a:t>
             </a:r>
           </a:p>
           <a:p>
             <a:pPr lvl="4"/>
             <a:r>
-              <a:rPr lang="en-US"/>
+              <a:rPr lang="en-US" smtClean="0"/>
               <a:t>Fifth level</a:t>
             </a:r>
+            <a:endParaRPr lang="en-US"/>
           </a:p>
         </p:txBody>
       </p:sp>
@@ -1300,37 +1296,38 @@
           <a:p>
             <a:pPr lvl="0"/>
             <a:r>
-              <a:rPr lang="en-US"/>
+              <a:rPr lang="en-US" smtClean="0"/>
               <a:t>Click to edit Master text styles</a:t>
             </a:r>
           </a:p>
           <a:p>
             <a:pPr lvl="1"/>
             <a:r>
-              <a:rPr lang="en-US"/>
+              <a:rPr lang="en-US" smtClean="0"/>
               <a:t>Second level</a:t>
             </a:r>
           </a:p>
           <a:p>
             <a:pPr lvl="2"/>
             <a:r>
-              <a:rPr lang="en-US"/>
+              <a:rPr lang="en-US" smtClean="0"/>
               <a:t>Third level</a:t>
             </a:r>
           </a:p>
           <a:p>
             <a:pPr lvl="3"/>
             <a:r>
-              <a:rPr lang="en-US"/>
+              <a:rPr lang="en-US" smtClean="0"/>
               <a:t>Fourth level</a:t>
             </a:r>
           </a:p>
           <a:p>
             <a:pPr lvl="4"/>
             <a:r>
-              <a:rPr lang="en-US"/>
+              <a:rPr lang="en-US" smtClean="0"/>
               <a:t>Fifth level</a:t>
             </a:r>
+            <a:endParaRPr lang="en-US"/>
           </a:p>
         </p:txBody>
       </p:sp>
@@ -1351,7 +1348,7 @@
           <a:p>
             <a:fld id="{5BCAD085-E8A6-8845-BD4E-CB4CCA059FC4}" type="datetimeFigureOut">
               <a:rPr lang="en-US" smtClean="0"/>
-              <a:t>6/1/26</a:t>
+              <a:t>1/27/13</a:t>
             </a:fld>
             <a:endParaRPr lang="en-US"/>
           </a:p>
@@ -1449,9 +1446,10 @@
           </a:lstStyle>
           <a:p>
             <a:r>
-              <a:rPr lang="en-US"/>
+              <a:rPr lang="en-US" smtClean="0"/>
               <a:t>Click to edit Master title style</a:t>
             </a:r>
+            <a:endParaRPr lang="en-US"/>
           </a:p>
         </p:txBody>
       </p:sp>
@@ -1514,7 +1512,7 @@
           <a:p>
             <a:pPr lvl="0"/>
             <a:r>
-              <a:rPr lang="en-US"/>
+              <a:rPr lang="en-US" smtClean="0"/>
               <a:t>Click to edit Master text styles</a:t>
             </a:r>
           </a:p>
@@ -1570,37 +1568,38 @@
           <a:p>
             <a:pPr lvl="0"/>
             <a:r>
-              <a:rPr lang="en-US"/>
+              <a:rPr lang="en-US" smtClean="0"/>
               <a:t>Click to edit Master text styles</a:t>
             </a:r>
           </a:p>
           <a:p>
             <a:pPr lvl="1"/>
             <a:r>
-              <a:rPr lang="en-US"/>
+              <a:rPr lang="en-US" smtClean="0"/>
               <a:t>Second level</a:t>
             </a:r>
           </a:p>
           <a:p>
             <a:pPr lvl="2"/>
             <a:r>
-              <a:rPr lang="en-US"/>
+              <a:rPr lang="en-US" smtClean="0"/>
               <a:t>Third level</a:t>
             </a:r>
           </a:p>
           <a:p>
             <a:pPr lvl="3"/>
             <a:r>
-              <a:rPr lang="en-US"/>
+              <a:rPr lang="en-US" smtClean="0"/>
               <a:t>Fourth level</a:t>
             </a:r>
           </a:p>
           <a:p>
             <a:pPr lvl="4"/>
             <a:r>
-              <a:rPr lang="en-US"/>
+              <a:rPr lang="en-US" smtClean="0"/>
               <a:t>Fifth level</a:t>
             </a:r>
+            <a:endParaRPr lang="en-US"/>
           </a:p>
         </p:txBody>
       </p:sp>
@@ -1663,7 +1662,7 @@
           <a:p>
             <a:pPr lvl="0"/>
             <a:r>
-              <a:rPr lang="en-US"/>
+              <a:rPr lang="en-US" smtClean="0"/>
               <a:t>Click to edit Master text styles</a:t>
             </a:r>
           </a:p>
@@ -1719,37 +1718,38 @@
           <a:p>
             <a:pPr lvl="0"/>
             <a:r>
-              <a:rPr lang="en-US"/>
+              <a:rPr lang="en-US" smtClean="0"/>
               <a:t>Click to edit Master text styles</a:t>
             </a:r>
           </a:p>
           <a:p>
             <a:pPr lvl="1"/>
             <a:r>
-              <a:rPr lang="en-US"/>
+              <a:rPr lang="en-US" smtClean="0"/>
               <a:t>Second level</a:t>
             </a:r>
           </a:p>
           <a:p>
             <a:pPr lvl="2"/>
             <a:r>
-              <a:rPr lang="en-US"/>
+              <a:rPr lang="en-US" smtClean="0"/>
               <a:t>Third level</a:t>
             </a:r>
           </a:p>
           <a:p>
             <a:pPr lvl="3"/>
             <a:r>
-              <a:rPr lang="en-US"/>
+              <a:rPr lang="en-US" smtClean="0"/>
               <a:t>Fourth level</a:t>
             </a:r>
           </a:p>
           <a:p>
             <a:pPr lvl="4"/>
             <a:r>
-              <a:rPr lang="en-US"/>
+              <a:rPr lang="en-US" smtClean="0"/>
               <a:t>Fifth level</a:t>
             </a:r>
+            <a:endParaRPr lang="en-US"/>
           </a:p>
         </p:txBody>
       </p:sp>
@@ -1770,7 +1770,7 @@
           <a:p>
             <a:fld id="{5BCAD085-E8A6-8845-BD4E-CB4CCA059FC4}" type="datetimeFigureOut">
               <a:rPr lang="en-US" smtClean="0"/>
-              <a:t>6/1/26</a:t>
+              <a:t>1/27/13</a:t>
             </a:fld>
             <a:endParaRPr lang="en-US"/>
           </a:p>
@@ -1864,9 +1864,10 @@
           <a:lstStyle/>
           <a:p>
             <a:r>
-              <a:rPr lang="en-US"/>
+              <a:rPr lang="en-US" smtClean="0"/>
               <a:t>Click to edit Master title style</a:t>
             </a:r>
+            <a:endParaRPr lang="en-US"/>
           </a:p>
         </p:txBody>
       </p:sp>
@@ -1887,7 +1888,7 @@
           <a:p>
             <a:fld id="{5BCAD085-E8A6-8845-BD4E-CB4CCA059FC4}" type="datetimeFigureOut">
               <a:rPr lang="en-US" smtClean="0"/>
-              <a:t>6/1/26</a:t>
+              <a:t>1/27/13</a:t>
             </a:fld>
             <a:endParaRPr lang="en-US"/>
           </a:p>
@@ -1982,7 +1983,7 @@
           <a:p>
             <a:fld id="{5BCAD085-E8A6-8845-BD4E-CB4CCA059FC4}" type="datetimeFigureOut">
               <a:rPr lang="en-US" smtClean="0"/>
-              <a:t>6/1/26</a:t>
+              <a:t>1/27/13</a:t>
             </a:fld>
             <a:endParaRPr lang="en-US"/>
           </a:p>
@@ -2085,9 +2086,10 @@
           </a:lstStyle>
           <a:p>
             <a:r>
-              <a:rPr lang="en-US"/>
+              <a:rPr lang="en-US" smtClean="0"/>
               <a:t>Click to edit Master title style</a:t>
             </a:r>
+            <a:endParaRPr lang="en-US"/>
           </a:p>
         </p:txBody>
       </p:sp>
@@ -2141,37 +2143,38 @@
           <a:p>
             <a:pPr lvl="0"/>
             <a:r>
-              <a:rPr lang="en-US"/>
+              <a:rPr lang="en-US" smtClean="0"/>
               <a:t>Click to edit Master text styles</a:t>
             </a:r>
           </a:p>
           <a:p>
             <a:pPr lvl="1"/>
             <a:r>
-              <a:rPr lang="en-US"/>
+              <a:rPr lang="en-US" smtClean="0"/>
               <a:t>Second level</a:t>
             </a:r>
           </a:p>
           <a:p>
             <a:pPr lvl="2"/>
             <a:r>
-              <a:rPr lang="en-US"/>
+              <a:rPr lang="en-US" smtClean="0"/>
               <a:t>Third level</a:t>
             </a:r>
           </a:p>
           <a:p>
             <a:pPr lvl="3"/>
             <a:r>
-              <a:rPr lang="en-US"/>
+              <a:rPr lang="en-US" smtClean="0"/>
               <a:t>Fourth level</a:t>
             </a:r>
           </a:p>
           <a:p>
             <a:pPr lvl="4"/>
             <a:r>
-              <a:rPr lang="en-US"/>
+              <a:rPr lang="en-US" smtClean="0"/>
               <a:t>Fifth level</a:t>
             </a:r>
+            <a:endParaRPr lang="en-US"/>
           </a:p>
         </p:txBody>
       </p:sp>
@@ -2234,7 +2237,7 @@
           <a:p>
             <a:pPr lvl="0"/>
             <a:r>
-              <a:rPr lang="en-US"/>
+              <a:rPr lang="en-US" smtClean="0"/>
               <a:t>Click to edit Master text styles</a:t>
             </a:r>
           </a:p>
@@ -2257,7 +2260,7 @@
           <a:p>
             <a:fld id="{5BCAD085-E8A6-8845-BD4E-CB4CCA059FC4}" type="datetimeFigureOut">
               <a:rPr lang="en-US" smtClean="0"/>
-              <a:t>6/1/26</a:t>
+              <a:t>1/27/13</a:t>
             </a:fld>
             <a:endParaRPr lang="en-US"/>
           </a:p>
@@ -2360,9 +2363,10 @@
           </a:lstStyle>
           <a:p>
             <a:r>
-              <a:rPr lang="en-US"/>
+              <a:rPr lang="en-US" smtClean="0"/>
               <a:t>Click to edit Master title style</a:t>
             </a:r>
+            <a:endParaRPr lang="en-US"/>
           </a:p>
         </p:txBody>
       </p:sp>
@@ -2486,7 +2490,7 @@
           <a:p>
             <a:pPr lvl="0"/>
             <a:r>
-              <a:rPr lang="en-US"/>
+              <a:rPr lang="en-US" smtClean="0"/>
               <a:t>Click to edit Master text styles</a:t>
             </a:r>
           </a:p>
@@ -2509,7 +2513,7 @@
           <a:p>
             <a:fld id="{5BCAD085-E8A6-8845-BD4E-CB4CCA059FC4}" type="datetimeFigureOut">
               <a:rPr lang="en-US" smtClean="0"/>
-              <a:t>6/1/26</a:t>
+              <a:t>1/27/13</a:t>
             </a:fld>
             <a:endParaRPr lang="en-US"/>
           </a:p>
@@ -2618,9 +2622,10 @@
           <a:lstStyle/>
           <a:p>
             <a:r>
-              <a:rPr lang="en-US"/>
+              <a:rPr lang="en-US" smtClean="0"/>
               <a:t>Click to edit Master title style</a:t>
             </a:r>
+            <a:endParaRPr lang="en-US"/>
           </a:p>
         </p:txBody>
       </p:sp>
@@ -2651,37 +2656,38 @@
           <a:p>
             <a:pPr lvl="0"/>
             <a:r>
-              <a:rPr lang="en-US"/>
+              <a:rPr lang="en-US" smtClean="0"/>
               <a:t>Click to edit Master text styles</a:t>
             </a:r>
           </a:p>
           <a:p>
             <a:pPr lvl="1"/>
             <a:r>
-              <a:rPr lang="en-US"/>
+              <a:rPr lang="en-US" smtClean="0"/>
               <a:t>Second level</a:t>
             </a:r>
           </a:p>
           <a:p>
             <a:pPr lvl="2"/>
             <a:r>
-              <a:rPr lang="en-US"/>
+              <a:rPr lang="en-US" smtClean="0"/>
               <a:t>Third level</a:t>
             </a:r>
           </a:p>
           <a:p>
             <a:pPr lvl="3"/>
             <a:r>
-              <a:rPr lang="en-US"/>
+              <a:rPr lang="en-US" smtClean="0"/>
               <a:t>Fourth level</a:t>
             </a:r>
           </a:p>
           <a:p>
             <a:pPr lvl="4"/>
             <a:r>
-              <a:rPr lang="en-US"/>
+              <a:rPr lang="en-US" smtClean="0"/>
               <a:t>Fifth level</a:t>
             </a:r>
+            <a:endParaRPr lang="en-US"/>
           </a:p>
         </p:txBody>
       </p:sp>
@@ -2720,7 +2726,7 @@
           <a:p>
             <a:fld id="{5BCAD085-E8A6-8845-BD4E-CB4CCA059FC4}" type="datetimeFigureOut">
               <a:rPr lang="en-US" smtClean="0"/>
-              <a:t>6/1/26</a:t>
+              <a:t>1/27/13</a:t>
             </a:fld>
             <a:endParaRPr lang="en-US"/>
           </a:p>
@@ -3079,7 +3085,7 @@
 </file>
 
 <file path=ppt/slides/slide1.xml><?xml version="1.0" encoding="utf-8"?>
-<p:sld xmlns:a="http://schemas.openxmlformats.org/drawingml/2006/main" xmlns:r="http://schemas.openxmlformats.org/officeDocument/2006/relationships" xmlns:p="http://schemas.openxmlformats.org/presentationml/2006/main">
+<p:sld xmlns:a="http://schemas.openxmlformats.org/drawingml/2006/main" xmlns:p="http://schemas.openxmlformats.org/presentationml/2006/main" xmlns:r="http://schemas.openxmlformats.org/officeDocument/2006/relationships">
   <p:cSld>
     <p:bg>
       <p:bgPr>
@@ -3095,14 +3101,7 @@
         <p:cNvGrpSpPr/>
         <p:nvPr/>
       </p:nvGrpSpPr>
-      <p:grpSpPr>
-        <a:xfrm>
-          <a:off x="0" y="0"/>
-          <a:ext cx="0" cy="0"/>
-          <a:chOff x="0" y="0"/>
-          <a:chExt cx="0" cy="0"/>
-        </a:xfrm>
-      </p:grpSpPr>
+      <p:grpSpPr/>
       <p:sp>
         <p:nvSpPr>
           <p:cNvPr id="2" name="TextBox 1"/>
@@ -3120,7 +3119,7 @@
           <a:noFill/>
         </p:spPr>
         <p:txBody>
-          <a:bodyPr wrap="square" lIns="0" tIns="0" rIns="0" bIns="0">
+          <a:bodyPr wrap="square" lIns="0" rIns="0" tIns="0" bIns="0">
             <a:spAutoFit/>
           </a:bodyPr>
           <a:lstStyle/>
@@ -3159,7 +3158,7 @@
           <a:noFill/>
         </p:spPr>
         <p:txBody>
-          <a:bodyPr wrap="square" lIns="0" tIns="0" rIns="0" bIns="0">
+          <a:bodyPr wrap="square" lIns="0" rIns="0" tIns="0" bIns="0">
             <a:spAutoFit/>
           </a:bodyPr>
           <a:lstStyle/>
@@ -3214,7 +3213,7 @@
           <a:noFill/>
         </p:spPr>
         <p:txBody>
-          <a:bodyPr wrap="square" lIns="0" tIns="0" rIns="0" bIns="0">
+          <a:bodyPr wrap="square" lIns="0" rIns="0" tIns="0" bIns="0">
             <a:spAutoFit/>
           </a:bodyPr>
           <a:lstStyle/>
@@ -3245,7 +3244,7 @@
         <p:spPr>
           <a:xfrm>
             <a:off x="731520" y="5897880"/>
-            <a:ext cx="10058400" cy="273986"/>
+            <a:ext cx="10058400" cy="365760"/>
           </a:xfrm>
           <a:prstGeom prst="rect">
             <a:avLst/>
@@ -3253,7 +3252,7 @@
           <a:noFill/>
         </p:spPr>
         <p:txBody>
-          <a:bodyPr wrap="square" lIns="0" tIns="0" rIns="0" bIns="0">
+          <a:bodyPr wrap="square" lIns="0" rIns="0" tIns="0" bIns="0">
             <a:spAutoFit/>
           </a:bodyPr>
           <a:lstStyle/>
@@ -3264,49 +3263,13 @@
               </a:lnSpc>
             </a:pPr>
             <a:r>
-              <a:rPr lang="ko-KR" altLang="en-US" sz="1500" dirty="0">
+              <a:rPr sz="1200" b="0">
                 <a:solidFill>
                   <a:srgbClr val="6B7280"/>
                 </a:solidFill>
                 <a:latin typeface="Pretendard"/>
               </a:rPr>
-              <a:t>김근호</a:t>
-            </a:r>
-            <a:r>
-              <a:rPr sz="1500" b="0" dirty="0">
-                <a:solidFill>
-                  <a:srgbClr val="6B7280"/>
-                </a:solidFill>
-                <a:latin typeface="Pretendard"/>
-              </a:rPr>
-              <a:t> · </a:t>
-            </a:r>
-            <a:r>
-              <a:rPr lang="en-US" altLang="ko-KR" sz="1500" dirty="0">
-                <a:solidFill>
-                  <a:srgbClr val="6B7280"/>
-                </a:solidFill>
-                <a:latin typeface="Pretendard"/>
-              </a:rPr>
-              <a:t>20210915</a:t>
-            </a:r>
-            <a:r>
-              <a:rPr sz="1500" b="0" dirty="0">
-                <a:solidFill>
-                  <a:srgbClr val="6B7280"/>
-                </a:solidFill>
-                <a:latin typeface="Pretendard"/>
-              </a:rPr>
-              <a:t> · 2026.06</a:t>
-            </a:r>
-            <a:r>
-              <a:rPr lang="en-US" altLang="ko-KR" sz="1500" b="0" dirty="0">
-                <a:solidFill>
-                  <a:srgbClr val="6B7280"/>
-                </a:solidFill>
-                <a:latin typeface="Pretendard"/>
-              </a:rPr>
-              <a:t>.02</a:t>
+              <a:t>이름 · 학번 · 2026.06</a:t>
             </a:r>
           </a:p>
         </p:txBody>
@@ -3328,7 +3291,7 @@
           <a:noFill/>
         </p:spPr>
         <p:txBody>
-          <a:bodyPr wrap="square" lIns="0" tIns="0" rIns="0" bIns="0">
+          <a:bodyPr wrap="square" lIns="0" rIns="0" tIns="0" bIns="0">
             <a:spAutoFit/>
           </a:bodyPr>
           <a:lstStyle/>
@@ -3345,23 +3308,8 @@
                 </a:solidFill>
                 <a:latin typeface="Pretendard"/>
               </a:rPr>
-              <a:t>https://</a:t>
-            </a:r>
-            <a:r>
-              <a:rPr sz="1200" b="0" dirty="0" err="1">
-                <a:solidFill>
-                  <a:srgbClr val="059669"/>
-                </a:solidFill>
-                <a:latin typeface="Pretendard"/>
-              </a:rPr>
-              <a:t>proofolio.pages.dev</a:t>
-            </a:r>
-            <a:endParaRPr sz="1200" b="0" dirty="0">
-              <a:solidFill>
-                <a:srgbClr val="059669"/>
-              </a:solidFill>
-              <a:latin typeface="Pretendard"/>
-            </a:endParaRPr>
+              <a:t>https://proofolio.pages.dev</a:t>
+            </a:r>
           </a:p>
         </p:txBody>
       </p:sp>
@@ -3374,7 +3322,7 @@
 </file>
 
 <file path=ppt/slides/slide2.xml><?xml version="1.0" encoding="utf-8"?>
-<p:sld xmlns:a="http://schemas.openxmlformats.org/drawingml/2006/main" xmlns:r="http://schemas.openxmlformats.org/officeDocument/2006/relationships" xmlns:p="http://schemas.openxmlformats.org/presentationml/2006/main">
+<p:sld xmlns:a="http://schemas.openxmlformats.org/drawingml/2006/main" xmlns:p="http://schemas.openxmlformats.org/presentationml/2006/main" xmlns:r="http://schemas.openxmlformats.org/officeDocument/2006/relationships">
   <p:cSld>
     <p:bg>
       <p:bgPr>
@@ -3390,14 +3338,7 @@
         <p:cNvGrpSpPr/>
         <p:nvPr/>
       </p:nvGrpSpPr>
-      <p:grpSpPr>
-        <a:xfrm>
-          <a:off x="0" y="0"/>
-          <a:ext cx="0" cy="0"/>
-          <a:chOff x="0" y="0"/>
-          <a:chExt cx="0" cy="0"/>
-        </a:xfrm>
-      </p:grpSpPr>
+      <p:grpSpPr/>
       <p:sp>
         <p:nvSpPr>
           <p:cNvPr id="2" name="TextBox 1"/>
@@ -3415,7 +3356,7 @@
           <a:noFill/>
         </p:spPr>
         <p:txBody>
-          <a:bodyPr wrap="square" lIns="0" tIns="0" rIns="0" bIns="0">
+          <a:bodyPr wrap="square" lIns="0" rIns="0" tIns="0" bIns="0">
             <a:spAutoFit/>
           </a:bodyPr>
           <a:lstStyle/>
@@ -3454,7 +3395,7 @@
           <a:noFill/>
         </p:spPr>
         <p:txBody>
-          <a:bodyPr wrap="square" lIns="0" tIns="0" rIns="0" bIns="0">
+          <a:bodyPr wrap="square" lIns="0" rIns="0" tIns="0" bIns="0">
             <a:spAutoFit/>
           </a:bodyPr>
           <a:lstStyle/>
@@ -3532,7 +3473,6 @@
           <a:lstStyle/>
           <a:p>
             <a:pPr algn="ctr"/>
-            <a:endParaRPr/>
           </a:p>
         </p:txBody>
       </p:sp>
@@ -3553,7 +3493,7 @@
           <a:noFill/>
         </p:spPr>
         <p:txBody>
-          <a:bodyPr wrap="square" lIns="0" tIns="0" rIns="0" bIns="0">
+          <a:bodyPr wrap="square" lIns="0" rIns="0" tIns="0" bIns="0">
             <a:spAutoFit/>
           </a:bodyPr>
           <a:lstStyle/>
@@ -3592,7 +3532,7 @@
           <a:noFill/>
         </p:spPr>
         <p:txBody>
-          <a:bodyPr wrap="square" lIns="0" tIns="0" rIns="0" bIns="0">
+          <a:bodyPr wrap="square" lIns="0" rIns="0" tIns="0" bIns="0">
             <a:spAutoFit/>
           </a:bodyPr>
           <a:lstStyle/>
@@ -3631,7 +3571,7 @@
           <a:noFill/>
         </p:spPr>
         <p:txBody>
-          <a:bodyPr wrap="square" lIns="0" tIns="0" rIns="0" bIns="0">
+          <a:bodyPr wrap="square" lIns="0" rIns="0" tIns="0" bIns="0">
             <a:spAutoFit/>
           </a:bodyPr>
           <a:lstStyle/>
@@ -3662,7 +3602,7 @@
 </file>
 
 <file path=ppt/slides/slide3.xml><?xml version="1.0" encoding="utf-8"?>
-<p:sld xmlns:a="http://schemas.openxmlformats.org/drawingml/2006/main" xmlns:r="http://schemas.openxmlformats.org/officeDocument/2006/relationships" xmlns:p="http://schemas.openxmlformats.org/presentationml/2006/main">
+<p:sld xmlns:a="http://schemas.openxmlformats.org/drawingml/2006/main" xmlns:p="http://schemas.openxmlformats.org/presentationml/2006/main" xmlns:r="http://schemas.openxmlformats.org/officeDocument/2006/relationships">
   <p:cSld>
     <p:bg>
       <p:bgPr>
@@ -3678,14 +3618,7 @@
         <p:cNvGrpSpPr/>
         <p:nvPr/>
       </p:nvGrpSpPr>
-      <p:grpSpPr>
-        <a:xfrm>
-          <a:off x="0" y="0"/>
-          <a:ext cx="0" cy="0"/>
-          <a:chOff x="0" y="0"/>
-          <a:chExt cx="0" cy="0"/>
-        </a:xfrm>
-      </p:grpSpPr>
+      <p:grpSpPr/>
       <p:sp>
         <p:nvSpPr>
           <p:cNvPr id="2" name="TextBox 1"/>
@@ -3703,7 +3636,7 @@
           <a:noFill/>
         </p:spPr>
         <p:txBody>
-          <a:bodyPr wrap="square" lIns="0" tIns="0" rIns="0" bIns="0">
+          <a:bodyPr wrap="square" lIns="0" rIns="0" tIns="0" bIns="0">
             <a:spAutoFit/>
           </a:bodyPr>
           <a:lstStyle/>
@@ -3742,7 +3675,7 @@
           <a:noFill/>
         </p:spPr>
         <p:txBody>
-          <a:bodyPr wrap="square" lIns="0" tIns="0" rIns="0" bIns="0">
+          <a:bodyPr wrap="square" lIns="0" rIns="0" tIns="0" bIns="0">
             <a:spAutoFit/>
           </a:bodyPr>
           <a:lstStyle/>
@@ -3820,7 +3753,6 @@
           <a:lstStyle/>
           <a:p>
             <a:pPr algn="ctr"/>
-            <a:endParaRPr/>
           </a:p>
         </p:txBody>
       </p:sp>
@@ -3841,7 +3773,7 @@
           <a:noFill/>
         </p:spPr>
         <p:txBody>
-          <a:bodyPr wrap="square" lIns="0" tIns="0" rIns="0" bIns="0">
+          <a:bodyPr wrap="square" lIns="0" rIns="0" tIns="0" bIns="0">
             <a:spAutoFit/>
           </a:bodyPr>
           <a:lstStyle/>
@@ -3880,7 +3812,7 @@
           <a:noFill/>
         </p:spPr>
         <p:txBody>
-          <a:bodyPr wrap="square" lIns="0" tIns="0" rIns="0" bIns="0">
+          <a:bodyPr wrap="square" lIns="0" rIns="0" tIns="0" bIns="0">
             <a:spAutoFit/>
           </a:bodyPr>
           <a:lstStyle/>
@@ -3935,7 +3867,7 @@
           <a:noFill/>
         </p:spPr>
         <p:txBody>
-          <a:bodyPr wrap="square" lIns="0" tIns="0" rIns="0" bIns="0">
+          <a:bodyPr wrap="square" lIns="0" rIns="0" tIns="0" bIns="0">
             <a:spAutoFit/>
           </a:bodyPr>
           <a:lstStyle/>
@@ -3974,7 +3906,7 @@
           <a:noFill/>
         </p:spPr>
         <p:txBody>
-          <a:bodyPr wrap="square" lIns="0" tIns="0" rIns="0" bIns="0">
+          <a:bodyPr wrap="square" lIns="0" rIns="0" tIns="0" bIns="0">
             <a:spAutoFit/>
           </a:bodyPr>
           <a:lstStyle/>
@@ -4013,7 +3945,7 @@
           <a:noFill/>
         </p:spPr>
         <p:txBody>
-          <a:bodyPr wrap="square" lIns="0" tIns="0" rIns="0" bIns="0">
+          <a:bodyPr wrap="square" lIns="0" rIns="0" tIns="0" bIns="0">
             <a:spAutoFit/>
           </a:bodyPr>
           <a:lstStyle/>
@@ -4052,7 +3984,7 @@
           <a:noFill/>
         </p:spPr>
         <p:txBody>
-          <a:bodyPr wrap="square" lIns="0" tIns="0" rIns="0" bIns="0">
+          <a:bodyPr wrap="square" lIns="0" rIns="0" tIns="0" bIns="0">
             <a:spAutoFit/>
           </a:bodyPr>
           <a:lstStyle/>
@@ -4083,7 +4015,7 @@
 </file>
 
 <file path=ppt/slides/slide4.xml><?xml version="1.0" encoding="utf-8"?>
-<p:sld xmlns:a="http://schemas.openxmlformats.org/drawingml/2006/main" xmlns:r="http://schemas.openxmlformats.org/officeDocument/2006/relationships" xmlns:p="http://schemas.openxmlformats.org/presentationml/2006/main">
+<p:sld xmlns:a="http://schemas.openxmlformats.org/drawingml/2006/main" xmlns:p="http://schemas.openxmlformats.org/presentationml/2006/main" xmlns:r="http://schemas.openxmlformats.org/officeDocument/2006/relationships">
   <p:cSld>
     <p:bg>
       <p:bgPr>
@@ -4099,14 +4031,7 @@
         <p:cNvGrpSpPr/>
         <p:nvPr/>
       </p:nvGrpSpPr>
-      <p:grpSpPr>
-        <a:xfrm>
-          <a:off x="0" y="0"/>
-          <a:ext cx="0" cy="0"/>
-          <a:chOff x="0" y="0"/>
-          <a:chExt cx="0" cy="0"/>
-        </a:xfrm>
-      </p:grpSpPr>
+      <p:grpSpPr/>
       <p:sp>
         <p:nvSpPr>
           <p:cNvPr id="2" name="TextBox 1"/>
@@ -4124,7 +4049,7 @@
           <a:noFill/>
         </p:spPr>
         <p:txBody>
-          <a:bodyPr wrap="square" lIns="0" tIns="0" rIns="0" bIns="0">
+          <a:bodyPr wrap="square" lIns="0" rIns="0" tIns="0" bIns="0">
             <a:spAutoFit/>
           </a:bodyPr>
           <a:lstStyle/>
@@ -4154,8 +4079,8 @@
         </p:nvSpPr>
         <p:spPr>
           <a:xfrm>
-            <a:off x="731520" y="1734533"/>
-            <a:ext cx="10972800" cy="3801041"/>
+            <a:off x="731520" y="1051560"/>
+            <a:ext cx="10972800" cy="640080"/>
           </a:xfrm>
           <a:prstGeom prst="rect">
             <a:avLst/>
@@ -4163,54 +4088,108 @@
           <a:noFill/>
         </p:spPr>
         <p:txBody>
-          <a:bodyPr wrap="square" lIns="0" tIns="0" rIns="0" bIns="0">
+          <a:bodyPr wrap="square" lIns="0" rIns="0" tIns="0" bIns="0">
             <a:spAutoFit/>
           </a:bodyPr>
           <a:lstStyle/>
           <a:p>
             <a:pPr algn="l">
               <a:lnSpc>
-                <a:spcPct val="95000"/>
+                <a:spcPct val="110000"/>
               </a:lnSpc>
             </a:pPr>
             <a:r>
-              <a:rPr sz="13000" b="1" dirty="0">
+              <a:rPr sz="3200" b="1">
                 <a:solidFill>
                   <a:srgbClr val="0B1220"/>
                 </a:solidFill>
                 <a:latin typeface="Pretendard"/>
               </a:rPr>
-              <a:t>LIVE</a:t>
-            </a:r>
-          </a:p>
-          <a:p>
-            <a:pPr algn="l">
-              <a:lnSpc>
-                <a:spcPct val="95000"/>
-              </a:lnSpc>
+              <a:t>발급 영상 → 라이브 검증</a:t>
+            </a:r>
+          </a:p>
+        </p:txBody>
+      </p:sp>
+      <p:sp>
+        <p:nvSpPr>
+          <p:cNvPr id="4" name="Rounded Rectangle 3"/>
+          <p:cNvSpPr/>
+          <p:nvPr/>
+        </p:nvSpPr>
+        <p:spPr>
+          <a:xfrm>
+            <a:off x="1981047" y="2011680"/>
+            <a:ext cx="8229600" cy="4114800"/>
+          </a:xfrm>
+          <a:prstGeom prst="roundRect">
+            <a:avLst/>
+          </a:prstGeom>
+          <a:solidFill>
+            <a:srgbClr val="F1F3F7"/>
+          </a:solidFill>
+          <a:ln w="12700">
+            <a:solidFill>
+              <a:srgbClr val="E6E8EE"/>
+            </a:solidFill>
+          </a:ln>
+        </p:spPr>
+        <p:style>
+          <a:lnRef idx="1">
+            <a:schemeClr val="accent1"/>
+          </a:lnRef>
+          <a:fillRef idx="3">
+            <a:schemeClr val="accent1"/>
+          </a:fillRef>
+          <a:effectRef idx="2">
+            <a:schemeClr val="accent1"/>
+          </a:effectRef>
+          <a:fontRef idx="minor">
+            <a:schemeClr val="lt1"/>
+          </a:fontRef>
+        </p:style>
+        <p:txBody>
+          <a:bodyPr rtlCol="0" anchor="ctr" wrap="square" lIns="254000" rIns="254000" tIns="254000" bIns="254000"/>
+          <a:lstStyle/>
+          <a:p>
+            <a:pPr algn="ctr"/>
+            <a:r>
+              <a:rPr sz="1800" b="1">
+                <a:solidFill>
+                  <a:srgbClr val="6B7280"/>
+                </a:solidFill>
+                <a:latin typeface="Pretendard"/>
+              </a:rPr>
+              <a:t>▶  발급 흐름 영상</a:t>
+            </a:r>
+          </a:p>
+          <a:p>
+            <a:pPr algn="ctr">
+              <a:spcBef>
+                <a:spcPts val="600"/>
+              </a:spcBef>
             </a:pPr>
             <a:r>
-              <a:rPr sz="13000" b="1" dirty="0">
-                <a:solidFill>
-                  <a:srgbClr val="0B1220"/>
+              <a:rPr sz="1000">
+                <a:solidFill>
+                  <a:srgbClr val="6B7280"/>
                 </a:solidFill>
                 <a:latin typeface="Pretendard"/>
               </a:rPr>
-              <a:t>DEMO.</a:t>
-            </a:r>
-          </a:p>
-        </p:txBody>
-      </p:sp>
-      <p:sp>
-        <p:nvSpPr>
-          <p:cNvPr id="4" name="TextBox 3"/>
+              <a:t>이 자리에 .mov 파일을 드래그 (자동재생, 음소거, 15~20초)</a:t>
+            </a:r>
+          </a:p>
+        </p:txBody>
+      </p:sp>
+      <p:sp>
+        <p:nvSpPr>
+          <p:cNvPr id="5" name="TextBox 4"/>
           <p:cNvSpPr txBox="1"/>
           <p:nvPr/>
         </p:nvSpPr>
         <p:spPr>
           <a:xfrm>
-            <a:off x="6606228" y="2926282"/>
-            <a:ext cx="10972800" cy="551689"/>
+            <a:off x="731520" y="6355080"/>
+            <a:ext cx="10972800" cy="365760"/>
           </a:xfrm>
           <a:prstGeom prst="rect">
             <a:avLst/>
@@ -4218,141 +4197,24 @@
           <a:noFill/>
         </p:spPr>
         <p:txBody>
-          <a:bodyPr wrap="square" lIns="0" tIns="0" rIns="0" bIns="0">
+          <a:bodyPr wrap="square" lIns="0" rIns="0" tIns="0" bIns="0">
             <a:spAutoFit/>
           </a:bodyPr>
           <a:lstStyle/>
           <a:p>
-            <a:pPr algn="l">
+            <a:pPr algn="ctr">
               <a:lnSpc>
                 <a:spcPct val="130000"/>
               </a:lnSpc>
             </a:pPr>
             <a:r>
-              <a:rPr sz="3000" b="0" dirty="0">
-                <a:solidFill>
-                  <a:srgbClr val="059669"/>
+              <a:rPr sz="1200" b="0">
+                <a:solidFill>
+                  <a:srgbClr val="6B7280"/>
                 </a:solidFill>
                 <a:latin typeface="Pretendard"/>
               </a:rPr>
-              <a:t>https://</a:t>
-            </a:r>
-            <a:r>
-              <a:rPr sz="3000" b="0" dirty="0" err="1">
-                <a:solidFill>
-                  <a:srgbClr val="059669"/>
-                </a:solidFill>
-                <a:latin typeface="Pretendard"/>
-              </a:rPr>
-              <a:t>proofolio.pages.dev</a:t>
-            </a:r>
-            <a:endParaRPr sz="3000" b="0" dirty="0">
-              <a:solidFill>
-                <a:srgbClr val="059669"/>
-              </a:solidFill>
-              <a:latin typeface="Pretendard"/>
-            </a:endParaRPr>
-          </a:p>
-        </p:txBody>
-      </p:sp>
-      <p:sp>
-        <p:nvSpPr>
-          <p:cNvPr id="5" name="TextBox 4"/>
-          <p:cNvSpPr txBox="1"/>
-          <p:nvPr/>
-        </p:nvSpPr>
-        <p:spPr>
-          <a:xfrm>
-            <a:off x="7670939" y="3635053"/>
-            <a:ext cx="10972800" cy="255711"/>
-          </a:xfrm>
-          <a:prstGeom prst="rect">
-            <a:avLst/>
-          </a:prstGeom>
-          <a:noFill/>
-        </p:spPr>
-        <p:txBody>
-          <a:bodyPr wrap="square" lIns="0" tIns="0" rIns="0" bIns="0">
-            <a:spAutoFit/>
-          </a:bodyPr>
-          <a:lstStyle/>
-          <a:p>
-            <a:pPr algn="l">
-              <a:lnSpc>
-                <a:spcPct val="130000"/>
-              </a:lnSpc>
-            </a:pPr>
-            <a:r>
-              <a:rPr sz="1400" b="0" dirty="0" err="1">
-                <a:solidFill>
-                  <a:srgbClr val="6B7280"/>
-                </a:solidFill>
-                <a:latin typeface="Pretendard"/>
-              </a:rPr>
-              <a:t>발급</a:t>
-            </a:r>
-            <a:r>
-              <a:rPr sz="1400" b="0" dirty="0">
-                <a:solidFill>
-                  <a:srgbClr val="6B7280"/>
-                </a:solidFill>
-                <a:latin typeface="Pretendard"/>
-              </a:rPr>
-              <a:t> → </a:t>
-            </a:r>
-            <a:r>
-              <a:rPr sz="1400" b="0" dirty="0" err="1">
-                <a:solidFill>
-                  <a:srgbClr val="6B7280"/>
-                </a:solidFill>
-                <a:latin typeface="Pretendard"/>
-              </a:rPr>
-              <a:t>검증</a:t>
-            </a:r>
-            <a:r>
-              <a:rPr sz="1400" b="0" dirty="0">
-                <a:solidFill>
-                  <a:srgbClr val="6B7280"/>
-                </a:solidFill>
-                <a:latin typeface="Pretendard"/>
-              </a:rPr>
-              <a:t> → </a:t>
-            </a:r>
-            <a:r>
-              <a:rPr sz="1400" b="0" dirty="0" err="1">
-                <a:solidFill>
-                  <a:srgbClr val="6B7280"/>
-                </a:solidFill>
-                <a:latin typeface="Pretendard"/>
-              </a:rPr>
-              <a:t>위변조</a:t>
-            </a:r>
-            <a:r>
-              <a:rPr sz="1400" b="0" dirty="0">
-                <a:solidFill>
-                  <a:srgbClr val="6B7280"/>
-                </a:solidFill>
-                <a:latin typeface="Pretendard"/>
-              </a:rPr>
-              <a:t> </a:t>
-            </a:r>
-            <a:r>
-              <a:rPr sz="1400" b="0" dirty="0" err="1">
-                <a:solidFill>
-                  <a:srgbClr val="6B7280"/>
-                </a:solidFill>
-                <a:latin typeface="Pretendard"/>
-              </a:rPr>
-              <a:t>감지</a:t>
-            </a:r>
-            <a:r>
-              <a:rPr sz="1400" b="0" dirty="0">
-                <a:solidFill>
-                  <a:srgbClr val="6B7280"/>
-                </a:solidFill>
-                <a:latin typeface="Pretendard"/>
-              </a:rPr>
-              <a:t> </a:t>
+              <a:t>영상 자동재생 후 → 브라우저로 전환해 라이브 검증</a:t>
             </a:r>
           </a:p>
         </p:txBody>
@@ -4366,7 +4228,7 @@
 </file>
 
 <file path=ppt/slides/slide5.xml><?xml version="1.0" encoding="utf-8"?>
-<p:sld xmlns:a="http://schemas.openxmlformats.org/drawingml/2006/main" xmlns:r="http://schemas.openxmlformats.org/officeDocument/2006/relationships" xmlns:p="http://schemas.openxmlformats.org/presentationml/2006/main">
+<p:sld xmlns:a="http://schemas.openxmlformats.org/drawingml/2006/main" xmlns:p="http://schemas.openxmlformats.org/presentationml/2006/main" xmlns:r="http://schemas.openxmlformats.org/officeDocument/2006/relationships">
   <p:cSld>
     <p:bg>
       <p:bgPr>
@@ -4382,14 +4244,7 @@
         <p:cNvGrpSpPr/>
         <p:nvPr/>
       </p:nvGrpSpPr>
-      <p:grpSpPr>
-        <a:xfrm>
-          <a:off x="0" y="0"/>
-          <a:ext cx="0" cy="0"/>
-          <a:chOff x="0" y="0"/>
-          <a:chExt cx="0" cy="0"/>
-        </a:xfrm>
-      </p:grpSpPr>
+      <p:grpSpPr/>
       <p:sp>
         <p:nvSpPr>
           <p:cNvPr id="2" name="TextBox 1"/>
@@ -4407,7 +4262,7 @@
           <a:noFill/>
         </p:spPr>
         <p:txBody>
-          <a:bodyPr wrap="square" lIns="0" tIns="0" rIns="0" bIns="0">
+          <a:bodyPr wrap="square" lIns="0" rIns="0" tIns="0" bIns="0">
             <a:spAutoFit/>
           </a:bodyPr>
           <a:lstStyle/>
@@ -4424,7 +4279,7 @@
                 </a:solidFill>
                 <a:latin typeface="Pretendard"/>
               </a:rPr>
-              <a:t>04 · ARCHITECTURE &amp; ENGINEERING</a:t>
+              <a:t>04 · 그 외 화면</a:t>
             </a:r>
           </a:p>
         </p:txBody>
@@ -4437,8 +4292,8 @@
         </p:nvSpPr>
         <p:spPr>
           <a:xfrm>
-            <a:off x="731520" y="1097280"/>
-            <a:ext cx="10972800" cy="914400"/>
+            <a:off x="731520" y="1051560"/>
+            <a:ext cx="10972800" cy="640080"/>
           </a:xfrm>
           <a:prstGeom prst="rect">
             <a:avLst/>
@@ -4446,7 +4301,7 @@
           <a:noFill/>
         </p:spPr>
         <p:txBody>
-          <a:bodyPr wrap="square" lIns="0" tIns="0" rIns="0" bIns="0">
+          <a:bodyPr wrap="square" lIns="0" rIns="0" tIns="0" bIns="0">
             <a:spAutoFit/>
           </a:bodyPr>
           <a:lstStyle/>
@@ -4457,13 +4312,13 @@
               </a:lnSpc>
             </a:pPr>
             <a:r>
-              <a:rPr sz="3600" b="1">
+              <a:rPr sz="3200" b="1">
                 <a:solidFill>
                   <a:srgbClr val="0B1220"/>
                 </a:solidFill>
                 <a:latin typeface="Pretendard"/>
               </a:rPr>
-              <a:t>단순한 데모가 아닙니다.</a:t>
+              <a:t>관리자 · 발급기관 · 보유자</a:t>
             </a:r>
           </a:p>
         </p:txBody>
@@ -4476,8 +4331,8 @@
         </p:nvSpPr>
         <p:spPr>
           <a:xfrm>
-            <a:off x="731520" y="2377440"/>
-            <a:ext cx="10972800" cy="2377440"/>
+            <a:off x="731520" y="1783080"/>
+            <a:ext cx="10972800" cy="457200"/>
           </a:xfrm>
           <a:prstGeom prst="rect">
             <a:avLst/>
@@ -4485,408 +4340,49 @@
           <a:noFill/>
         </p:spPr>
         <p:txBody>
-          <a:bodyPr wrap="square" lIns="0" tIns="0" rIns="0" bIns="0">
+          <a:bodyPr wrap="square" lIns="0" rIns="0" tIns="0" bIns="0">
             <a:spAutoFit/>
           </a:bodyPr>
           <a:lstStyle/>
           <a:p>
             <a:pPr algn="l">
               <a:lnSpc>
-                <a:spcPct val="135000"/>
+                <a:spcPct val="140000"/>
               </a:lnSpc>
             </a:pPr>
             <a:r>
-              <a:rPr sz="1200" b="0" dirty="0">
+              <a:rPr sz="1400" b="0">
                 <a:solidFill>
                   <a:srgbClr val="3F4757"/>
                 </a:solidFill>
-                <a:latin typeface="Menlo"/>
-              </a:rPr>
-              <a:t>[</a:t>
-            </a:r>
-            <a:r>
-              <a:rPr sz="1200" b="0" dirty="0" err="1">
-                <a:solidFill>
-                  <a:srgbClr val="3F4757"/>
-                </a:solidFill>
-                <a:latin typeface="Menlo"/>
-              </a:rPr>
-              <a:t>발급기관</a:t>
-            </a:r>
-            <a:r>
-              <a:rPr sz="1200" b="0" dirty="0">
-                <a:solidFill>
-                  <a:srgbClr val="3F4757"/>
-                </a:solidFill>
-                <a:latin typeface="Menlo"/>
-              </a:rPr>
-              <a:t> </a:t>
-            </a:r>
-            <a:r>
-              <a:rPr sz="1200" b="0" dirty="0" err="1">
-                <a:solidFill>
-                  <a:srgbClr val="3F4757"/>
-                </a:solidFill>
-                <a:latin typeface="Menlo"/>
-              </a:rPr>
-              <a:t>지갑</a:t>
-            </a:r>
-            <a:r>
-              <a:rPr sz="1200" b="0" dirty="0">
-                <a:solidFill>
-                  <a:srgbClr val="3F4757"/>
-                </a:solidFill>
-                <a:latin typeface="Menlo"/>
-              </a:rPr>
-              <a:t>]  ─ </a:t>
-            </a:r>
-            <a:r>
-              <a:rPr sz="1200" b="0" dirty="0" err="1">
-                <a:solidFill>
-                  <a:srgbClr val="3F4757"/>
-                </a:solidFill>
-                <a:latin typeface="Menlo"/>
-              </a:rPr>
-              <a:t>issueCredential</a:t>
-            </a:r>
-            <a:r>
-              <a:rPr sz="1200" b="0" dirty="0">
-                <a:solidFill>
-                  <a:srgbClr val="3F4757"/>
-                </a:solidFill>
-                <a:latin typeface="Menlo"/>
-              </a:rPr>
-              <a:t> ─▶  [</a:t>
-            </a:r>
-            <a:r>
-              <a:rPr sz="1200" b="0" dirty="0" err="1">
-                <a:solidFill>
-                  <a:srgbClr val="3F4757"/>
-                </a:solidFill>
-                <a:latin typeface="Menlo"/>
-              </a:rPr>
-              <a:t>Proofolio</a:t>
-            </a:r>
-            <a:r>
-              <a:rPr sz="1200" b="0" dirty="0">
-                <a:solidFill>
-                  <a:srgbClr val="3F4757"/>
-                </a:solidFill>
-                <a:latin typeface="Menlo"/>
-              </a:rPr>
-              <a:t> · </a:t>
-            </a:r>
-            <a:r>
-              <a:rPr sz="1200" b="0" dirty="0" err="1">
-                <a:solidFill>
-                  <a:srgbClr val="3F4757"/>
-                </a:solidFill>
-                <a:latin typeface="Menlo"/>
-              </a:rPr>
-              <a:t>Sepolia</a:t>
-            </a:r>
-            <a:r>
-              <a:rPr sz="1200" b="0" dirty="0">
-                <a:solidFill>
-                  <a:srgbClr val="3F4757"/>
-                </a:solidFill>
-                <a:latin typeface="Menlo"/>
-              </a:rPr>
-              <a:t>]</a:t>
-            </a:r>
-          </a:p>
-          <a:p>
-            <a:pPr algn="l">
-              <a:lnSpc>
-                <a:spcPct val="135000"/>
-              </a:lnSpc>
-            </a:pPr>
-            <a:r>
-              <a:rPr sz="1200" b="0" dirty="0">
-                <a:solidFill>
-                  <a:srgbClr val="3F4757"/>
-                </a:solidFill>
-                <a:latin typeface="Menlo"/>
-              </a:rPr>
-              <a:t>                                                │</a:t>
-            </a:r>
-          </a:p>
-          <a:p>
-            <a:pPr algn="l">
-              <a:lnSpc>
-                <a:spcPct val="135000"/>
-              </a:lnSpc>
-            </a:pPr>
-            <a:r>
-              <a:rPr sz="1200" b="0" dirty="0">
-                <a:solidFill>
-                  <a:srgbClr val="3F4757"/>
-                </a:solidFill>
-                <a:latin typeface="Menlo"/>
-              </a:rPr>
-              <a:t>                                                ▼</a:t>
-            </a:r>
-          </a:p>
-          <a:p>
-            <a:pPr algn="l">
-              <a:lnSpc>
-                <a:spcPct val="135000"/>
-              </a:lnSpc>
-            </a:pPr>
-            <a:r>
-              <a:rPr sz="1200" b="0" dirty="0">
-                <a:solidFill>
-                  <a:srgbClr val="3F4757"/>
-                </a:solidFill>
-                <a:latin typeface="Menlo"/>
-              </a:rPr>
-              <a:t>                                       [</a:t>
-            </a:r>
-            <a:r>
-              <a:rPr sz="1200" b="0" dirty="0" err="1">
-                <a:solidFill>
-                  <a:srgbClr val="3F4757"/>
-                </a:solidFill>
-                <a:latin typeface="Menlo"/>
-              </a:rPr>
-              <a:t>소울바운드</a:t>
-            </a:r>
-            <a:r>
-              <a:rPr sz="1200" b="0" dirty="0">
-                <a:solidFill>
-                  <a:srgbClr val="3F4757"/>
-                </a:solidFill>
-                <a:latin typeface="Menlo"/>
-              </a:rPr>
-              <a:t> ERC-721]</a:t>
-            </a:r>
-          </a:p>
-          <a:p>
-            <a:pPr algn="l">
-              <a:lnSpc>
-                <a:spcPct val="135000"/>
-              </a:lnSpc>
-            </a:pPr>
-            <a:r>
-              <a:rPr sz="1200" b="0" dirty="0">
-                <a:solidFill>
-                  <a:srgbClr val="3F4757"/>
-                </a:solidFill>
-                <a:latin typeface="Menlo"/>
-              </a:rPr>
-              <a:t>                                          (</a:t>
-            </a:r>
-            <a:r>
-              <a:rPr sz="1200" b="0" dirty="0" err="1">
-                <a:solidFill>
-                  <a:srgbClr val="3F4757"/>
-                </a:solidFill>
-                <a:latin typeface="Menlo"/>
-              </a:rPr>
-              <a:t>보유자</a:t>
-            </a:r>
-            <a:r>
-              <a:rPr sz="1200" b="0" dirty="0">
-                <a:solidFill>
-                  <a:srgbClr val="3F4757"/>
-                </a:solidFill>
-                <a:latin typeface="Menlo"/>
-              </a:rPr>
-              <a:t> </a:t>
-            </a:r>
-            <a:r>
-              <a:rPr sz="1200" b="0" dirty="0" err="1">
-                <a:solidFill>
-                  <a:srgbClr val="3F4757"/>
-                </a:solidFill>
-                <a:latin typeface="Menlo"/>
-              </a:rPr>
-              <a:t>지갑</a:t>
-            </a:r>
-            <a:r>
-              <a:rPr sz="1200" b="0" dirty="0">
-                <a:solidFill>
-                  <a:srgbClr val="3F4757"/>
-                </a:solidFill>
-                <a:latin typeface="Menlo"/>
-              </a:rPr>
-              <a:t>)</a:t>
-            </a:r>
-          </a:p>
-          <a:p>
-            <a:pPr algn="l">
-              <a:lnSpc>
-                <a:spcPct val="135000"/>
-              </a:lnSpc>
-            </a:pPr>
-            <a:r>
-              <a:rPr sz="1200" b="0" dirty="0">
-                <a:solidFill>
-                  <a:srgbClr val="3F4757"/>
-                </a:solidFill>
-                <a:latin typeface="Menlo"/>
-              </a:rPr>
-              <a:t>                                                │</a:t>
-            </a:r>
-          </a:p>
-          <a:p>
-            <a:pPr algn="l">
-              <a:lnSpc>
-                <a:spcPct val="135000"/>
-              </a:lnSpc>
-            </a:pPr>
-            <a:r>
-              <a:rPr sz="1200" b="0" dirty="0">
-                <a:solidFill>
-                  <a:srgbClr val="3F4757"/>
-                </a:solidFill>
-                <a:latin typeface="Menlo"/>
-              </a:rPr>
-              <a:t>          (</a:t>
-            </a:r>
-            <a:r>
-              <a:rPr sz="1200" b="0" dirty="0" err="1">
-                <a:solidFill>
-                  <a:srgbClr val="3F4757"/>
-                </a:solidFill>
-                <a:latin typeface="Menlo"/>
-              </a:rPr>
-              <a:t>지갑</a:t>
-            </a:r>
-            <a:r>
-              <a:rPr sz="1200" b="0" dirty="0">
-                <a:solidFill>
-                  <a:srgbClr val="3F4757"/>
-                </a:solidFill>
-                <a:latin typeface="Menlo"/>
-              </a:rPr>
-              <a:t> </a:t>
-            </a:r>
-            <a:r>
-              <a:rPr sz="1200" b="0" dirty="0" err="1">
-                <a:solidFill>
-                  <a:srgbClr val="3F4757"/>
-                </a:solidFill>
-                <a:latin typeface="Menlo"/>
-              </a:rPr>
-              <a:t>없이</a:t>
-            </a:r>
-            <a:r>
-              <a:rPr sz="1200" b="0" dirty="0">
-                <a:solidFill>
-                  <a:srgbClr val="3F4757"/>
-                </a:solidFill>
-                <a:latin typeface="Menlo"/>
-              </a:rPr>
-              <a:t>) ◀─ verify(</a:t>
-            </a:r>
-            <a:r>
-              <a:rPr sz="1200" b="0" dirty="0" err="1">
-                <a:solidFill>
-                  <a:srgbClr val="3F4757"/>
-                </a:solidFill>
-                <a:latin typeface="Menlo"/>
-              </a:rPr>
-              <a:t>tokenId</a:t>
-            </a:r>
-            <a:r>
-              <a:rPr sz="1200" b="0" dirty="0">
-                <a:solidFill>
-                  <a:srgbClr val="3F4757"/>
-                </a:solidFill>
-                <a:latin typeface="Menlo"/>
-              </a:rPr>
-              <a:t>) + keccak256 ─┘</a:t>
-            </a:r>
-          </a:p>
-          <a:p>
-            <a:pPr algn="l">
-              <a:lnSpc>
-                <a:spcPct val="135000"/>
-              </a:lnSpc>
-            </a:pPr>
-            <a:r>
-              <a:rPr sz="1200" b="0" dirty="0">
-                <a:solidFill>
-                  <a:srgbClr val="3F4757"/>
-                </a:solidFill>
-                <a:latin typeface="Menlo"/>
-              </a:rPr>
-              <a:t>                       </a:t>
-            </a:r>
-            <a:r>
-              <a:rPr sz="1200" b="0" dirty="0" err="1">
-                <a:solidFill>
-                  <a:srgbClr val="3F4757"/>
-                </a:solidFill>
-                <a:latin typeface="Menlo"/>
-              </a:rPr>
-              <a:t>검증자가</a:t>
-            </a:r>
-            <a:r>
-              <a:rPr sz="1200" b="0" dirty="0">
-                <a:solidFill>
-                  <a:srgbClr val="3F4757"/>
-                </a:solidFill>
-                <a:latin typeface="Menlo"/>
-              </a:rPr>
-              <a:t> </a:t>
-            </a:r>
-            <a:r>
-              <a:rPr sz="1200" b="0" dirty="0" err="1">
-                <a:solidFill>
-                  <a:srgbClr val="3F4757"/>
-                </a:solidFill>
-                <a:latin typeface="Menlo"/>
-              </a:rPr>
-              <a:t>직접</a:t>
-            </a:r>
-            <a:r>
-              <a:rPr sz="1200" b="0" dirty="0">
-                <a:solidFill>
-                  <a:srgbClr val="3F4757"/>
-                </a:solidFill>
-                <a:latin typeface="Menlo"/>
-              </a:rPr>
-              <a:t> RPC </a:t>
-            </a:r>
-            <a:r>
-              <a:rPr sz="1200" b="0" dirty="0" err="1">
-                <a:solidFill>
-                  <a:srgbClr val="3F4757"/>
-                </a:solidFill>
-                <a:latin typeface="Menlo"/>
-              </a:rPr>
-              <a:t>호출</a:t>
-            </a:r>
-            <a:endParaRPr sz="1200" b="0" dirty="0">
-              <a:solidFill>
-                <a:srgbClr val="3F4757"/>
-              </a:solidFill>
-              <a:latin typeface="Menlo"/>
-            </a:endParaRPr>
-          </a:p>
-        </p:txBody>
-      </p:sp>
-      <p:sp>
-        <p:nvSpPr>
-          <p:cNvPr id="5" name="Rectangle 4"/>
+                <a:latin typeface="Pretendard"/>
+              </a:rPr>
+              <a:t>검증 외에도 다음 화면들이 같은 디자인 시스템으로 구현되어 있습니다.</a:t>
+            </a:r>
+          </a:p>
+        </p:txBody>
+      </p:sp>
+      <p:sp>
+        <p:nvSpPr>
+          <p:cNvPr id="5" name="Rounded Rectangle 4"/>
           <p:cNvSpPr/>
           <p:nvPr/>
         </p:nvSpPr>
         <p:spPr>
           <a:xfrm>
-            <a:off x="731520" y="4892040"/>
-            <a:ext cx="10698480" cy="8000"/>
-          </a:xfrm>
-          <a:prstGeom prst="rect">
+            <a:off x="586587" y="2743200"/>
+            <a:ext cx="3520440" cy="2743200"/>
+          </a:xfrm>
+          <a:prstGeom prst="roundRect">
             <a:avLst/>
           </a:prstGeom>
           <a:solidFill>
-            <a:srgbClr val="E6E8EE"/>
+            <a:srgbClr val="F1F3F7"/>
           </a:solidFill>
-          <a:ln>
-            <a:noFill/>
+          <a:ln w="12700">
+            <a:solidFill>
+              <a:srgbClr val="E6E8EE"/>
+            </a:solidFill>
           </a:ln>
         </p:spPr>
         <p:style>
@@ -4904,11 +4400,35 @@
           </a:fontRef>
         </p:style>
         <p:txBody>
-          <a:bodyPr rtlCol="0" anchor="ctr"/>
+          <a:bodyPr rtlCol="0" anchor="ctr" wrap="square" lIns="254000" rIns="254000" tIns="254000" bIns="254000"/>
           <a:lstStyle/>
           <a:p>
             <a:pPr algn="ctr"/>
-            <a:endParaRPr/>
+            <a:r>
+              <a:rPr sz="1800" b="1">
+                <a:solidFill>
+                  <a:srgbClr val="6B7280"/>
+                </a:solidFill>
+                <a:latin typeface="Pretendard"/>
+              </a:rPr>
+              <a:t>관리자 · /admin</a:t>
+            </a:r>
+          </a:p>
+          <a:p>
+            <a:pPr algn="ctr">
+              <a:spcBef>
+                <a:spcPts val="600"/>
+              </a:spcBef>
+            </a:pPr>
+            <a:r>
+              <a:rPr sz="1000">
+                <a:solidFill>
+                  <a:srgbClr val="6B7280"/>
+                </a:solidFill>
+                <a:latin typeface="Pretendard"/>
+              </a:rPr>
+              <a:t>스샷을 이 자리에 드래그</a:t>
+            </a:r>
           </a:p>
         </p:txBody>
       </p:sp>
@@ -4920,8 +4440,8 @@
         </p:nvSpPr>
         <p:spPr>
           <a:xfrm>
-            <a:off x="731520" y="5120640"/>
-            <a:ext cx="10972800" cy="365760"/>
+            <a:off x="586587" y="5623560"/>
+            <a:ext cx="3520440" cy="365760"/>
           </a:xfrm>
           <a:prstGeom prst="rect">
             <a:avLst/>
@@ -4929,56 +4449,108 @@
           <a:noFill/>
         </p:spPr>
         <p:txBody>
-          <a:bodyPr wrap="square" lIns="0" tIns="0" rIns="0" bIns="0">
+          <a:bodyPr wrap="square" lIns="0" rIns="0" tIns="0" bIns="0">
             <a:spAutoFit/>
           </a:bodyPr>
           <a:lstStyle/>
           <a:p>
-            <a:pPr algn="l">
+            <a:pPr algn="ctr">
               <a:lnSpc>
                 <a:spcPct val="130000"/>
               </a:lnSpc>
             </a:pPr>
             <a:r>
-              <a:rPr sz="1400" b="0" dirty="0">
-                <a:solidFill>
-                  <a:srgbClr val="0B1220"/>
+              <a:rPr sz="1100" b="0">
+                <a:solidFill>
+                  <a:srgbClr val="6B7280"/>
                 </a:solidFill>
                 <a:latin typeface="Pretendard"/>
               </a:rPr>
-              <a:t>·  ERC-721 + Ownable2Step + </a:t>
-            </a:r>
-            <a:r>
-              <a:rPr sz="1400" b="0" dirty="0" err="1">
-                <a:solidFill>
-                  <a:srgbClr val="0B1220"/>
+              <a:t>발급기관 등록 · 활성 관리</a:t>
+            </a:r>
+          </a:p>
+        </p:txBody>
+      </p:sp>
+      <p:sp>
+        <p:nvSpPr>
+          <p:cNvPr id="7" name="Rounded Rectangle 6"/>
+          <p:cNvSpPr/>
+          <p:nvPr/>
+        </p:nvSpPr>
+        <p:spPr>
+          <a:xfrm>
+            <a:off x="4335627" y="2743200"/>
+            <a:ext cx="3520440" cy="2743200"/>
+          </a:xfrm>
+          <a:prstGeom prst="roundRect">
+            <a:avLst/>
+          </a:prstGeom>
+          <a:solidFill>
+            <a:srgbClr val="F1F3F7"/>
+          </a:solidFill>
+          <a:ln w="12700">
+            <a:solidFill>
+              <a:srgbClr val="E6E8EE"/>
+            </a:solidFill>
+          </a:ln>
+        </p:spPr>
+        <p:style>
+          <a:lnRef idx="1">
+            <a:schemeClr val="accent1"/>
+          </a:lnRef>
+          <a:fillRef idx="3">
+            <a:schemeClr val="accent1"/>
+          </a:fillRef>
+          <a:effectRef idx="2">
+            <a:schemeClr val="accent1"/>
+          </a:effectRef>
+          <a:fontRef idx="minor">
+            <a:schemeClr val="lt1"/>
+          </a:fontRef>
+        </p:style>
+        <p:txBody>
+          <a:bodyPr rtlCol="0" anchor="ctr" wrap="square" lIns="254000" rIns="254000" tIns="254000" bIns="254000"/>
+          <a:lstStyle/>
+          <a:p>
+            <a:pPr algn="ctr"/>
+            <a:r>
+              <a:rPr sz="1800" b="1">
+                <a:solidFill>
+                  <a:srgbClr val="6B7280"/>
                 </a:solidFill>
                 <a:latin typeface="Pretendard"/>
               </a:rPr>
-              <a:t>소울바운드</a:t>
-            </a:r>
-            <a:r>
-              <a:rPr sz="1400" b="0" dirty="0">
-                <a:solidFill>
-                  <a:srgbClr val="0B1220"/>
+              <a:t>발급 · /issue</a:t>
+            </a:r>
+          </a:p>
+          <a:p>
+            <a:pPr algn="ctr">
+              <a:spcBef>
+                <a:spcPts val="600"/>
+              </a:spcBef>
+            </a:pPr>
+            <a:r>
+              <a:rPr sz="1000">
+                <a:solidFill>
+                  <a:srgbClr val="6B7280"/>
                 </a:solidFill>
                 <a:latin typeface="Pretendard"/>
               </a:rPr>
-              <a:t> (_update mint-only)</a:t>
-            </a:r>
-          </a:p>
-        </p:txBody>
-      </p:sp>
-      <p:sp>
-        <p:nvSpPr>
-          <p:cNvPr id="7" name="TextBox 6"/>
+              <a:t>스샷을 이 자리에 드래그</a:t>
+            </a:r>
+          </a:p>
+        </p:txBody>
+      </p:sp>
+      <p:sp>
+        <p:nvSpPr>
+          <p:cNvPr id="8" name="TextBox 7"/>
           <p:cNvSpPr txBox="1"/>
           <p:nvPr/>
         </p:nvSpPr>
         <p:spPr>
           <a:xfrm>
-            <a:off x="731520" y="5486400"/>
-            <a:ext cx="10972800" cy="365760"/>
+            <a:off x="4335627" y="5623560"/>
+            <a:ext cx="3520440" cy="365760"/>
           </a:xfrm>
           <a:prstGeom prst="rect">
             <a:avLst/>
@@ -4986,38 +4558,108 @@
           <a:noFill/>
         </p:spPr>
         <p:txBody>
-          <a:bodyPr wrap="square" lIns="0" tIns="0" rIns="0" bIns="0">
+          <a:bodyPr wrap="square" lIns="0" rIns="0" tIns="0" bIns="0">
             <a:spAutoFit/>
           </a:bodyPr>
           <a:lstStyle/>
           <a:p>
-            <a:pPr algn="l">
+            <a:pPr algn="ctr">
               <a:lnSpc>
                 <a:spcPct val="130000"/>
               </a:lnSpc>
             </a:pPr>
             <a:r>
-              <a:rPr sz="1400" b="0">
-                <a:solidFill>
-                  <a:srgbClr val="0B1220"/>
+              <a:rPr sz="1100" b="0">
+                <a:solidFill>
+                  <a:srgbClr val="6B7280"/>
                 </a:solidFill>
                 <a:latin typeface="Pretendard"/>
               </a:rPr>
-              <a:t>·  Hardhat 단위 테스트 17개 — 정상·엣지·보안</a:t>
-            </a:r>
-          </a:p>
-        </p:txBody>
-      </p:sp>
-      <p:sp>
-        <p:nvSpPr>
-          <p:cNvPr id="8" name="TextBox 7"/>
+              <a:t>보유자에게 증명서 발급</a:t>
+            </a:r>
+          </a:p>
+        </p:txBody>
+      </p:sp>
+      <p:sp>
+        <p:nvSpPr>
+          <p:cNvPr id="9" name="Rounded Rectangle 8"/>
+          <p:cNvSpPr/>
+          <p:nvPr/>
+        </p:nvSpPr>
+        <p:spPr>
+          <a:xfrm>
+            <a:off x="8084667" y="2743200"/>
+            <a:ext cx="3520440" cy="2743200"/>
+          </a:xfrm>
+          <a:prstGeom prst="roundRect">
+            <a:avLst/>
+          </a:prstGeom>
+          <a:solidFill>
+            <a:srgbClr val="F1F3F7"/>
+          </a:solidFill>
+          <a:ln w="12700">
+            <a:solidFill>
+              <a:srgbClr val="E6E8EE"/>
+            </a:solidFill>
+          </a:ln>
+        </p:spPr>
+        <p:style>
+          <a:lnRef idx="1">
+            <a:schemeClr val="accent1"/>
+          </a:lnRef>
+          <a:fillRef idx="3">
+            <a:schemeClr val="accent1"/>
+          </a:fillRef>
+          <a:effectRef idx="2">
+            <a:schemeClr val="accent1"/>
+          </a:effectRef>
+          <a:fontRef idx="minor">
+            <a:schemeClr val="lt1"/>
+          </a:fontRef>
+        </p:style>
+        <p:txBody>
+          <a:bodyPr rtlCol="0" anchor="ctr" wrap="square" lIns="254000" rIns="254000" tIns="254000" bIns="254000"/>
+          <a:lstStyle/>
+          <a:p>
+            <a:pPr algn="ctr"/>
+            <a:r>
+              <a:rPr sz="1800" b="1">
+                <a:solidFill>
+                  <a:srgbClr val="6B7280"/>
+                </a:solidFill>
+                <a:latin typeface="Pretendard"/>
+              </a:rPr>
+              <a:t>보유자 · /credentials</a:t>
+            </a:r>
+          </a:p>
+          <a:p>
+            <a:pPr algn="ctr">
+              <a:spcBef>
+                <a:spcPts val="600"/>
+              </a:spcBef>
+            </a:pPr>
+            <a:r>
+              <a:rPr sz="1000">
+                <a:solidFill>
+                  <a:srgbClr val="6B7280"/>
+                </a:solidFill>
+                <a:latin typeface="Pretendard"/>
+              </a:rPr>
+              <a:t>스샷을 이 자리에 드래그</a:t>
+            </a:r>
+          </a:p>
+        </p:txBody>
+      </p:sp>
+      <p:sp>
+        <p:nvSpPr>
+          <p:cNvPr id="10" name="TextBox 9"/>
           <p:cNvSpPr txBox="1"/>
           <p:nvPr/>
         </p:nvSpPr>
         <p:spPr>
           <a:xfrm>
-            <a:off x="731520" y="5852160"/>
-            <a:ext cx="10972800" cy="365760"/>
+            <a:off x="8084667" y="5623560"/>
+            <a:ext cx="3520440" cy="365760"/>
           </a:xfrm>
           <a:prstGeom prst="rect">
             <a:avLst/>
@@ -5025,63 +4667,24 @@
           <a:noFill/>
         </p:spPr>
         <p:txBody>
-          <a:bodyPr wrap="square" lIns="0" tIns="0" rIns="0" bIns="0">
+          <a:bodyPr wrap="square" lIns="0" rIns="0" tIns="0" bIns="0">
             <a:spAutoFit/>
           </a:bodyPr>
           <a:lstStyle/>
           <a:p>
-            <a:pPr algn="l">
+            <a:pPr algn="ctr">
               <a:lnSpc>
                 <a:spcPct val="130000"/>
               </a:lnSpc>
             </a:pPr>
             <a:r>
-              <a:rPr sz="1400" b="0">
-                <a:solidFill>
-                  <a:srgbClr val="0B1220"/>
+              <a:rPr sz="1100" b="0">
+                <a:solidFill>
+                  <a:srgbClr val="6B7280"/>
                 </a:solidFill>
                 <a:latin typeface="Pretendard"/>
               </a:rPr>
-              <a:t>·  Etherscan ✅ Verified — 누구나 소스코드 확인 가능</a:t>
-            </a:r>
-          </a:p>
-        </p:txBody>
-      </p:sp>
-      <p:sp>
-        <p:nvSpPr>
-          <p:cNvPr id="9" name="TextBox 8"/>
-          <p:cNvSpPr txBox="1"/>
-          <p:nvPr/>
-        </p:nvSpPr>
-        <p:spPr>
-          <a:xfrm>
-            <a:off x="731520" y="6217920"/>
-            <a:ext cx="10972800" cy="365760"/>
-          </a:xfrm>
-          <a:prstGeom prst="rect">
-            <a:avLst/>
-          </a:prstGeom>
-          <a:noFill/>
-        </p:spPr>
-        <p:txBody>
-          <a:bodyPr wrap="square" lIns="0" tIns="0" rIns="0" bIns="0">
-            <a:spAutoFit/>
-          </a:bodyPr>
-          <a:lstStyle/>
-          <a:p>
-            <a:pPr algn="l">
-              <a:lnSpc>
-                <a:spcPct val="130000"/>
-              </a:lnSpc>
-            </a:pPr>
-            <a:r>
-              <a:rPr sz="1400" b="0">
-                <a:solidFill>
-                  <a:srgbClr val="0B1220"/>
-                </a:solidFill>
-                <a:latin typeface="Pretendard"/>
-              </a:rPr>
-              <a:t>·  한계: 발급 사실만 보장. 기관 정당성은 별도 신뢰 앵커.</a:t>
+              <a:t>받은 증명서 보기</a:t>
             </a:r>
           </a:p>
         </p:txBody>
@@ -5095,7 +4698,7 @@
 </file>
 
 <file path=ppt/slides/slide6.xml><?xml version="1.0" encoding="utf-8"?>
-<p:sld xmlns:a="http://schemas.openxmlformats.org/drawingml/2006/main" xmlns:r="http://schemas.openxmlformats.org/officeDocument/2006/relationships" xmlns:p="http://schemas.openxmlformats.org/presentationml/2006/main">
+<p:sld xmlns:a="http://schemas.openxmlformats.org/drawingml/2006/main" xmlns:p="http://schemas.openxmlformats.org/presentationml/2006/main" xmlns:r="http://schemas.openxmlformats.org/officeDocument/2006/relationships">
   <p:cSld>
     <p:bg>
       <p:bgPr>
@@ -5111,14 +4714,7 @@
         <p:cNvGrpSpPr/>
         <p:nvPr/>
       </p:nvGrpSpPr>
-      <p:grpSpPr>
-        <a:xfrm>
-          <a:off x="0" y="0"/>
-          <a:ext cx="0" cy="0"/>
-          <a:chOff x="0" y="0"/>
-          <a:chExt cx="0" cy="0"/>
-        </a:xfrm>
-      </p:grpSpPr>
+      <p:grpSpPr/>
       <p:sp>
         <p:nvSpPr>
           <p:cNvPr id="2" name="TextBox 1"/>
@@ -5136,7 +4732,7 @@
           <a:noFill/>
         </p:spPr>
         <p:txBody>
-          <a:bodyPr wrap="square" lIns="0" tIns="0" rIns="0" bIns="0">
+          <a:bodyPr wrap="square" lIns="0" rIns="0" tIns="0" bIns="0">
             <a:spAutoFit/>
           </a:bodyPr>
           <a:lstStyle/>
@@ -5153,7 +4749,7 @@
                 </a:solidFill>
                 <a:latin typeface="Pretendard"/>
               </a:rPr>
-              <a:t>05 · VIBE CODING · 노하우</a:t>
+              <a:t>05 · ARCHITECTURE &amp; ENGINEERING</a:t>
             </a:r>
           </a:p>
         </p:txBody>
@@ -5175,7 +4771,7 @@
           <a:noFill/>
         </p:spPr>
         <p:txBody>
-          <a:bodyPr wrap="square" lIns="0" tIns="0" rIns="0" bIns="0">
+          <a:bodyPr wrap="square" lIns="0" rIns="0" tIns="0" bIns="0">
             <a:spAutoFit/>
           </a:bodyPr>
           <a:lstStyle/>
@@ -5192,7 +4788,7 @@
                 </a:solidFill>
                 <a:latin typeface="Pretendard"/>
               </a:rPr>
-              <a:t>AI로 어떻게 만들었나.</a:t>
+              <a:t>단순한 데모가 아닙니다.</a:t>
             </a:r>
           </a:p>
         </p:txBody>
@@ -5205,8 +4801,8 @@
         </p:nvSpPr>
         <p:spPr>
           <a:xfrm>
-            <a:off x="731520" y="2468880"/>
-            <a:ext cx="10972800" cy="365760"/>
+            <a:off x="731520" y="2331720"/>
+            <a:ext cx="10972800" cy="2377440"/>
           </a:xfrm>
           <a:prstGeom prst="rect">
             <a:avLst/>
@@ -5214,7 +4810,201 @@
           <a:noFill/>
         </p:spPr>
         <p:txBody>
-          <a:bodyPr wrap="square" lIns="0" tIns="0" rIns="0" bIns="0">
+          <a:bodyPr wrap="square" lIns="0" rIns="0" tIns="0" bIns="0">
+            <a:spAutoFit/>
+          </a:bodyPr>
+          <a:lstStyle/>
+          <a:p>
+            <a:pPr algn="l">
+              <a:lnSpc>
+                <a:spcPct val="135000"/>
+              </a:lnSpc>
+            </a:pPr>
+            <a:r>
+              <a:rPr sz="1200" b="0">
+                <a:solidFill>
+                  <a:srgbClr val="3F4757"/>
+                </a:solidFill>
+                <a:latin typeface="Menlo"/>
+              </a:rPr>
+              <a:t>[발급기관 지갑]  ─ issueCredential ─▶  [Proofolio · Sepolia]</a:t>
+            </a:r>
+          </a:p>
+          <a:p>
+            <a:pPr algn="l">
+              <a:lnSpc>
+                <a:spcPct val="135000"/>
+              </a:lnSpc>
+            </a:pPr>
+            <a:r>
+              <a:rPr sz="1200" b="0">
+                <a:solidFill>
+                  <a:srgbClr val="3F4757"/>
+                </a:solidFill>
+                <a:latin typeface="Menlo"/>
+              </a:rPr>
+              <a:t>                                                │</a:t>
+            </a:r>
+          </a:p>
+          <a:p>
+            <a:pPr algn="l">
+              <a:lnSpc>
+                <a:spcPct val="135000"/>
+              </a:lnSpc>
+            </a:pPr>
+            <a:r>
+              <a:rPr sz="1200" b="0">
+                <a:solidFill>
+                  <a:srgbClr val="3F4757"/>
+                </a:solidFill>
+                <a:latin typeface="Menlo"/>
+              </a:rPr>
+              <a:t>                                                ▼</a:t>
+            </a:r>
+          </a:p>
+          <a:p>
+            <a:pPr algn="l">
+              <a:lnSpc>
+                <a:spcPct val="135000"/>
+              </a:lnSpc>
+            </a:pPr>
+            <a:r>
+              <a:rPr sz="1200" b="0">
+                <a:solidFill>
+                  <a:srgbClr val="3F4757"/>
+                </a:solidFill>
+                <a:latin typeface="Menlo"/>
+              </a:rPr>
+              <a:t>                                       [소울바운드 ERC-721]</a:t>
+            </a:r>
+          </a:p>
+          <a:p>
+            <a:pPr algn="l">
+              <a:lnSpc>
+                <a:spcPct val="135000"/>
+              </a:lnSpc>
+            </a:pPr>
+            <a:r>
+              <a:rPr sz="1200" b="0">
+                <a:solidFill>
+                  <a:srgbClr val="3F4757"/>
+                </a:solidFill>
+                <a:latin typeface="Menlo"/>
+              </a:rPr>
+              <a:t>                                          (보유자 지갑)</a:t>
+            </a:r>
+          </a:p>
+          <a:p>
+            <a:pPr algn="l">
+              <a:lnSpc>
+                <a:spcPct val="135000"/>
+              </a:lnSpc>
+            </a:pPr>
+            <a:r>
+              <a:rPr sz="1200" b="0">
+                <a:solidFill>
+                  <a:srgbClr val="3F4757"/>
+                </a:solidFill>
+                <a:latin typeface="Menlo"/>
+              </a:rPr>
+              <a:t>                                                │</a:t>
+            </a:r>
+          </a:p>
+          <a:p>
+            <a:pPr algn="l">
+              <a:lnSpc>
+                <a:spcPct val="135000"/>
+              </a:lnSpc>
+            </a:pPr>
+            <a:r>
+              <a:rPr sz="1200" b="0">
+                <a:solidFill>
+                  <a:srgbClr val="3F4757"/>
+                </a:solidFill>
+                <a:latin typeface="Menlo"/>
+              </a:rPr>
+              <a:t>          (지갑 없이) ◀─ verify(tokenId) + keccak256 ─┘</a:t>
+            </a:r>
+          </a:p>
+          <a:p>
+            <a:pPr algn="l">
+              <a:lnSpc>
+                <a:spcPct val="135000"/>
+              </a:lnSpc>
+            </a:pPr>
+            <a:r>
+              <a:rPr sz="1200" b="0">
+                <a:solidFill>
+                  <a:srgbClr val="3F4757"/>
+                </a:solidFill>
+                <a:latin typeface="Menlo"/>
+              </a:rPr>
+              <a:t>                       검증자가 직접 RPC 호출</a:t>
+            </a:r>
+          </a:p>
+        </p:txBody>
+      </p:sp>
+      <p:sp>
+        <p:nvSpPr>
+          <p:cNvPr id="5" name="Rectangle 4"/>
+          <p:cNvSpPr/>
+          <p:nvPr/>
+        </p:nvSpPr>
+        <p:spPr>
+          <a:xfrm>
+            <a:off x="731520" y="4892040"/>
+            <a:ext cx="10698480" cy="8000"/>
+          </a:xfrm>
+          <a:prstGeom prst="rect">
+            <a:avLst/>
+          </a:prstGeom>
+          <a:solidFill>
+            <a:srgbClr val="E6E8EE"/>
+          </a:solidFill>
+          <a:ln>
+            <a:noFill/>
+          </a:ln>
+        </p:spPr>
+        <p:style>
+          <a:lnRef idx="1">
+            <a:schemeClr val="accent1"/>
+          </a:lnRef>
+          <a:fillRef idx="3">
+            <a:schemeClr val="accent1"/>
+          </a:fillRef>
+          <a:effectRef idx="2">
+            <a:schemeClr val="accent1"/>
+          </a:effectRef>
+          <a:fontRef idx="minor">
+            <a:schemeClr val="lt1"/>
+          </a:fontRef>
+        </p:style>
+        <p:txBody>
+          <a:bodyPr rtlCol="0" anchor="ctr"/>
+          <a:lstStyle/>
+          <a:p>
+            <a:pPr algn="ctr"/>
+          </a:p>
+        </p:txBody>
+      </p:sp>
+      <p:sp>
+        <p:nvSpPr>
+          <p:cNvPr id="6" name="TextBox 5"/>
+          <p:cNvSpPr txBox="1"/>
+          <p:nvPr/>
+        </p:nvSpPr>
+        <p:spPr>
+          <a:xfrm>
+            <a:off x="731520" y="5120640"/>
+            <a:ext cx="10972800" cy="365760"/>
+          </a:xfrm>
+          <a:prstGeom prst="rect">
+            <a:avLst/>
+          </a:prstGeom>
+          <a:noFill/>
+        </p:spPr>
+        <p:txBody>
+          <a:bodyPr wrap="square" lIns="0" rIns="0" tIns="0" bIns="0">
             <a:spAutoFit/>
           </a:bodyPr>
           <a:lstStyle/>
@@ -5225,27 +5015,27 @@
               </a:lnSpc>
             </a:pPr>
             <a:r>
-              <a:rPr sz="1500" b="1">
-                <a:solidFill>
-                  <a:srgbClr val="059669"/>
+              <a:rPr sz="1400" b="0">
+                <a:solidFill>
+                  <a:srgbClr val="0B1220"/>
                 </a:solidFill>
                 <a:latin typeface="Pretendard"/>
               </a:rPr>
-              <a:t>01  문서 먼저, 코드 나중</a:t>
-            </a:r>
-          </a:p>
-        </p:txBody>
-      </p:sp>
-      <p:sp>
-        <p:nvSpPr>
-          <p:cNvPr id="5" name="TextBox 4"/>
+              <a:t>·  ERC-721 + Ownable2Step + 소울바운드 (_update mint-only)</a:t>
+            </a:r>
+          </a:p>
+        </p:txBody>
+      </p:sp>
+      <p:sp>
+        <p:nvSpPr>
+          <p:cNvPr id="7" name="TextBox 6"/>
           <p:cNvSpPr txBox="1"/>
           <p:nvPr/>
         </p:nvSpPr>
         <p:spPr>
           <a:xfrm>
-            <a:off x="731520" y="2834640"/>
-            <a:ext cx="10972800" cy="457200"/>
+            <a:off x="731520" y="5486400"/>
+            <a:ext cx="10972800" cy="365760"/>
           </a:xfrm>
           <a:prstGeom prst="rect">
             <a:avLst/>
@@ -5253,7 +5043,267 @@
           <a:noFill/>
         </p:spPr>
         <p:txBody>
-          <a:bodyPr wrap="square" lIns="0" tIns="0" rIns="0" bIns="0">
+          <a:bodyPr wrap="square" lIns="0" rIns="0" tIns="0" bIns="0">
+            <a:spAutoFit/>
+          </a:bodyPr>
+          <a:lstStyle/>
+          <a:p>
+            <a:pPr algn="l">
+              <a:lnSpc>
+                <a:spcPct val="130000"/>
+              </a:lnSpc>
+            </a:pPr>
+            <a:r>
+              <a:rPr sz="1400" b="0">
+                <a:solidFill>
+                  <a:srgbClr val="0B1220"/>
+                </a:solidFill>
+                <a:latin typeface="Pretendard"/>
+              </a:rPr>
+              <a:t>·  Hardhat 단위 테스트 17개 — 정상·엣지·보안</a:t>
+            </a:r>
+          </a:p>
+        </p:txBody>
+      </p:sp>
+      <p:sp>
+        <p:nvSpPr>
+          <p:cNvPr id="8" name="TextBox 7"/>
+          <p:cNvSpPr txBox="1"/>
+          <p:nvPr/>
+        </p:nvSpPr>
+        <p:spPr>
+          <a:xfrm>
+            <a:off x="731520" y="5852160"/>
+            <a:ext cx="10972800" cy="365760"/>
+          </a:xfrm>
+          <a:prstGeom prst="rect">
+            <a:avLst/>
+          </a:prstGeom>
+          <a:noFill/>
+        </p:spPr>
+        <p:txBody>
+          <a:bodyPr wrap="square" lIns="0" rIns="0" tIns="0" bIns="0">
+            <a:spAutoFit/>
+          </a:bodyPr>
+          <a:lstStyle/>
+          <a:p>
+            <a:pPr algn="l">
+              <a:lnSpc>
+                <a:spcPct val="130000"/>
+              </a:lnSpc>
+            </a:pPr>
+            <a:r>
+              <a:rPr sz="1400" b="0">
+                <a:solidFill>
+                  <a:srgbClr val="0B1220"/>
+                </a:solidFill>
+                <a:latin typeface="Pretendard"/>
+              </a:rPr>
+              <a:t>·  Etherscan ✅ Verified — 누구나 소스코드 확인 가능</a:t>
+            </a:r>
+          </a:p>
+        </p:txBody>
+      </p:sp>
+      <p:sp>
+        <p:nvSpPr>
+          <p:cNvPr id="9" name="TextBox 8"/>
+          <p:cNvSpPr txBox="1"/>
+          <p:nvPr/>
+        </p:nvSpPr>
+        <p:spPr>
+          <a:xfrm>
+            <a:off x="731520" y="6217920"/>
+            <a:ext cx="10972800" cy="365760"/>
+          </a:xfrm>
+          <a:prstGeom prst="rect">
+            <a:avLst/>
+          </a:prstGeom>
+          <a:noFill/>
+        </p:spPr>
+        <p:txBody>
+          <a:bodyPr wrap="square" lIns="0" rIns="0" tIns="0" bIns="0">
+            <a:spAutoFit/>
+          </a:bodyPr>
+          <a:lstStyle/>
+          <a:p>
+            <a:pPr algn="l">
+              <a:lnSpc>
+                <a:spcPct val="130000"/>
+              </a:lnSpc>
+            </a:pPr>
+            <a:r>
+              <a:rPr sz="1400" b="0">
+                <a:solidFill>
+                  <a:srgbClr val="0B1220"/>
+                </a:solidFill>
+                <a:latin typeface="Pretendard"/>
+              </a:rPr>
+              <a:t>·  한계: 발급 사실만 보장. 기관 정당성은 별도 신뢰 앵커.</a:t>
+            </a:r>
+          </a:p>
+        </p:txBody>
+      </p:sp>
+    </p:spTree>
+  </p:cSld>
+  <p:clrMapOvr>
+    <a:masterClrMapping/>
+  </p:clrMapOvr>
+</p:sld>
+</file>
+
+<file path=ppt/slides/slide7.xml><?xml version="1.0" encoding="utf-8"?>
+<p:sld xmlns:a="http://schemas.openxmlformats.org/drawingml/2006/main" xmlns:p="http://schemas.openxmlformats.org/presentationml/2006/main" xmlns:r="http://schemas.openxmlformats.org/officeDocument/2006/relationships">
+  <p:cSld>
+    <p:bg>
+      <p:bgPr>
+        <a:solidFill>
+          <a:srgbClr val="F7F8FA"/>
+        </a:solidFill>
+        <a:effectLst/>
+      </p:bgPr>
+    </p:bg>
+    <p:spTree>
+      <p:nvGrpSpPr>
+        <p:cNvPr id="1" name=""/>
+        <p:cNvGrpSpPr/>
+        <p:nvPr/>
+      </p:nvGrpSpPr>
+      <p:grpSpPr/>
+      <p:sp>
+        <p:nvSpPr>
+          <p:cNvPr id="2" name="TextBox 1"/>
+          <p:cNvSpPr txBox="1"/>
+          <p:nvPr/>
+        </p:nvSpPr>
+        <p:spPr>
+          <a:xfrm>
+            <a:off x="731520" y="548640"/>
+            <a:ext cx="10058400" cy="320040"/>
+          </a:xfrm>
+          <a:prstGeom prst="rect">
+            <a:avLst/>
+          </a:prstGeom>
+          <a:noFill/>
+        </p:spPr>
+        <p:txBody>
+          <a:bodyPr wrap="square" lIns="0" rIns="0" tIns="0" bIns="0">
+            <a:spAutoFit/>
+          </a:bodyPr>
+          <a:lstStyle/>
+          <a:p>
+            <a:pPr algn="l">
+              <a:lnSpc>
+                <a:spcPct val="130000"/>
+              </a:lnSpc>
+            </a:pPr>
+            <a:r>
+              <a:rPr sz="1100" b="1">
+                <a:solidFill>
+                  <a:srgbClr val="059669"/>
+                </a:solidFill>
+                <a:latin typeface="Pretendard"/>
+              </a:rPr>
+              <a:t>06 · VIBE CODING · 노하우</a:t>
+            </a:r>
+          </a:p>
+        </p:txBody>
+      </p:sp>
+      <p:sp>
+        <p:nvSpPr>
+          <p:cNvPr id="3" name="TextBox 2"/>
+          <p:cNvSpPr txBox="1"/>
+          <p:nvPr/>
+        </p:nvSpPr>
+        <p:spPr>
+          <a:xfrm>
+            <a:off x="731520" y="1097280"/>
+            <a:ext cx="10972800" cy="914400"/>
+          </a:xfrm>
+          <a:prstGeom prst="rect">
+            <a:avLst/>
+          </a:prstGeom>
+          <a:noFill/>
+        </p:spPr>
+        <p:txBody>
+          <a:bodyPr wrap="square" lIns="0" rIns="0" tIns="0" bIns="0">
+            <a:spAutoFit/>
+          </a:bodyPr>
+          <a:lstStyle/>
+          <a:p>
+            <a:pPr algn="l">
+              <a:lnSpc>
+                <a:spcPct val="110000"/>
+              </a:lnSpc>
+            </a:pPr>
+            <a:r>
+              <a:rPr sz="3600" b="1">
+                <a:solidFill>
+                  <a:srgbClr val="0B1220"/>
+                </a:solidFill>
+                <a:latin typeface="Pretendard"/>
+              </a:rPr>
+              <a:t>AI로 어떻게 만들었나.</a:t>
+            </a:r>
+          </a:p>
+        </p:txBody>
+      </p:sp>
+      <p:sp>
+        <p:nvSpPr>
+          <p:cNvPr id="4" name="TextBox 3"/>
+          <p:cNvSpPr txBox="1"/>
+          <p:nvPr/>
+        </p:nvSpPr>
+        <p:spPr>
+          <a:xfrm>
+            <a:off x="731520" y="2468880"/>
+            <a:ext cx="10972800" cy="365760"/>
+          </a:xfrm>
+          <a:prstGeom prst="rect">
+            <a:avLst/>
+          </a:prstGeom>
+          <a:noFill/>
+        </p:spPr>
+        <p:txBody>
+          <a:bodyPr wrap="square" lIns="0" rIns="0" tIns="0" bIns="0">
+            <a:spAutoFit/>
+          </a:bodyPr>
+          <a:lstStyle/>
+          <a:p>
+            <a:pPr algn="l">
+              <a:lnSpc>
+                <a:spcPct val="130000"/>
+              </a:lnSpc>
+            </a:pPr>
+            <a:r>
+              <a:rPr sz="1500" b="1">
+                <a:solidFill>
+                  <a:srgbClr val="059669"/>
+                </a:solidFill>
+                <a:latin typeface="Pretendard"/>
+              </a:rPr>
+              <a:t>01  문서 먼저, 코드 나중</a:t>
+            </a:r>
+          </a:p>
+        </p:txBody>
+      </p:sp>
+      <p:sp>
+        <p:nvSpPr>
+          <p:cNvPr id="5" name="TextBox 4"/>
+          <p:cNvSpPr txBox="1"/>
+          <p:nvPr/>
+        </p:nvSpPr>
+        <p:spPr>
+          <a:xfrm>
+            <a:off x="731520" y="2834640"/>
+            <a:ext cx="10972800" cy="457200"/>
+          </a:xfrm>
+          <a:prstGeom prst="rect">
+            <a:avLst/>
+          </a:prstGeom>
+          <a:noFill/>
+        </p:spPr>
+        <p:txBody>
+          <a:bodyPr wrap="square" lIns="0" rIns="0" tIns="0" bIns="0">
             <a:spAutoFit/>
           </a:bodyPr>
           <a:lstStyle/>
@@ -5264,139 +5314,13 @@
               </a:lnSpc>
             </a:pPr>
             <a:r>
-              <a:rPr sz="1400" b="0" dirty="0">
+              <a:rPr sz="1400" b="0">
                 <a:solidFill>
                   <a:srgbClr val="3F4757"/>
                 </a:solidFill>
                 <a:latin typeface="Pretendard"/>
               </a:rPr>
-              <a:t>PRD / SRS 1000줄을 </a:t>
-            </a:r>
-            <a:r>
-              <a:rPr sz="1400" b="0" dirty="0" err="1">
-                <a:solidFill>
-                  <a:srgbClr val="3F4757"/>
-                </a:solidFill>
-                <a:latin typeface="Pretendard"/>
-              </a:rPr>
-              <a:t>AI와</a:t>
-            </a:r>
-            <a:r>
-              <a:rPr sz="1400" b="0" dirty="0">
-                <a:solidFill>
-                  <a:srgbClr val="3F4757"/>
-                </a:solidFill>
-                <a:latin typeface="Pretendard"/>
-              </a:rPr>
-              <a:t> </a:t>
-            </a:r>
-            <a:r>
-              <a:rPr sz="1400" b="0" dirty="0" err="1">
-                <a:solidFill>
-                  <a:srgbClr val="3F4757"/>
-                </a:solidFill>
-                <a:latin typeface="Pretendard"/>
-              </a:rPr>
-              <a:t>같이</a:t>
-            </a:r>
-            <a:r>
-              <a:rPr sz="1400" b="0" dirty="0">
-                <a:solidFill>
-                  <a:srgbClr val="3F4757"/>
-                </a:solidFill>
-                <a:latin typeface="Pretendard"/>
-              </a:rPr>
-              <a:t> </a:t>
-            </a:r>
-            <a:r>
-              <a:rPr sz="1400" b="0" dirty="0" err="1">
-                <a:solidFill>
-                  <a:srgbClr val="3F4757"/>
-                </a:solidFill>
-                <a:latin typeface="Pretendard"/>
-              </a:rPr>
-              <a:t>작성</a:t>
-            </a:r>
-            <a:r>
-              <a:rPr sz="1400" b="0" dirty="0">
-                <a:solidFill>
-                  <a:srgbClr val="3F4757"/>
-                </a:solidFill>
-                <a:latin typeface="Pretendard"/>
-              </a:rPr>
-              <a:t>. </a:t>
-            </a:r>
-            <a:r>
-              <a:rPr sz="1400" b="0" dirty="0" err="1">
-                <a:solidFill>
-                  <a:srgbClr val="3F4757"/>
-                </a:solidFill>
-                <a:latin typeface="Pretendard"/>
-              </a:rPr>
-              <a:t>AGENTS.md</a:t>
-            </a:r>
-            <a:r>
-              <a:rPr sz="1400" b="0" dirty="0">
-                <a:solidFill>
-                  <a:srgbClr val="3F4757"/>
-                </a:solidFill>
-                <a:latin typeface="Pretendard"/>
-              </a:rPr>
-              <a:t> </a:t>
-            </a:r>
-            <a:r>
-              <a:rPr sz="1400" b="0" dirty="0" err="1">
-                <a:solidFill>
-                  <a:srgbClr val="3F4757"/>
-                </a:solidFill>
-                <a:latin typeface="Pretendard"/>
-              </a:rPr>
-              <a:t>로</a:t>
-            </a:r>
-            <a:r>
-              <a:rPr sz="1400" b="0" dirty="0">
-                <a:solidFill>
-                  <a:srgbClr val="3F4757"/>
-                </a:solidFill>
-                <a:latin typeface="Pretendard"/>
-              </a:rPr>
-              <a:t> </a:t>
-            </a:r>
-            <a:r>
-              <a:rPr sz="1400" b="0" dirty="0" err="1">
-                <a:solidFill>
-                  <a:srgbClr val="3F4757"/>
-                </a:solidFill>
-                <a:latin typeface="Pretendard"/>
-              </a:rPr>
-              <a:t>규칙</a:t>
-            </a:r>
-            <a:r>
-              <a:rPr sz="1400" b="0" dirty="0">
-                <a:solidFill>
-                  <a:srgbClr val="3F4757"/>
-                </a:solidFill>
-                <a:latin typeface="Pretendard"/>
-              </a:rPr>
-              <a:t> </a:t>
-            </a:r>
-            <a:r>
-              <a:rPr sz="1400" b="0" dirty="0" err="1">
-                <a:solidFill>
-                  <a:srgbClr val="3F4757"/>
-                </a:solidFill>
-                <a:latin typeface="Pretendard"/>
-              </a:rPr>
-              <a:t>박제</a:t>
-            </a:r>
-            <a:r>
-              <a:rPr sz="1400" b="0" dirty="0">
-                <a:solidFill>
-                  <a:srgbClr val="3F4757"/>
-                </a:solidFill>
-                <a:latin typeface="Pretendard"/>
-              </a:rPr>
-              <a:t>.</a:t>
+              <a:t>PRD / SRS 1000줄을 AI와 같이 작성. AGENTS.md 로 규칙 박제.</a:t>
             </a:r>
           </a:p>
         </p:txBody>
@@ -5418,7 +5342,7 @@
           <a:noFill/>
         </p:spPr>
         <p:txBody>
-          <a:bodyPr wrap="square" lIns="0" tIns="0" rIns="0" bIns="0">
+          <a:bodyPr wrap="square" lIns="0" rIns="0" tIns="0" bIns="0">
             <a:spAutoFit/>
           </a:bodyPr>
           <a:lstStyle/>
@@ -5457,7 +5381,7 @@
           <a:noFill/>
         </p:spPr>
         <p:txBody>
-          <a:bodyPr wrap="square" lIns="0" tIns="0" rIns="0" bIns="0">
+          <a:bodyPr wrap="square" lIns="0" rIns="0" tIns="0" bIns="0">
             <a:spAutoFit/>
           </a:bodyPr>
           <a:lstStyle/>
@@ -5496,7 +5420,7 @@
           <a:noFill/>
         </p:spPr>
         <p:txBody>
-          <a:bodyPr wrap="square" lIns="0" tIns="0" rIns="0" bIns="0">
+          <a:bodyPr wrap="square" lIns="0" rIns="0" tIns="0" bIns="0">
             <a:spAutoFit/>
           </a:bodyPr>
           <a:lstStyle/>
@@ -5535,7 +5459,7 @@
           <a:noFill/>
         </p:spPr>
         <p:txBody>
-          <a:bodyPr wrap="square" lIns="0" tIns="0" rIns="0" bIns="0">
+          <a:bodyPr wrap="square" lIns="0" rIns="0" tIns="0" bIns="0">
             <a:spAutoFit/>
           </a:bodyPr>
           <a:lstStyle/>
@@ -5574,7 +5498,7 @@
           <a:noFill/>
         </p:spPr>
         <p:txBody>
-          <a:bodyPr wrap="square" lIns="0" tIns="0" rIns="0" bIns="0">
+          <a:bodyPr wrap="square" lIns="0" rIns="0" tIns="0" bIns="0">
             <a:spAutoFit/>
           </a:bodyPr>
           <a:lstStyle/>
@@ -5613,7 +5537,7 @@
           <a:noFill/>
         </p:spPr>
         <p:txBody>
-          <a:bodyPr wrap="square" lIns="0" tIns="0" rIns="0" bIns="0">
+          <a:bodyPr wrap="square" lIns="0" rIns="0" tIns="0" bIns="0">
             <a:spAutoFit/>
           </a:bodyPr>
           <a:lstStyle/>
@@ -5644,7 +5568,7 @@
         <p:spPr>
           <a:xfrm>
             <a:off x="731520" y="6263640"/>
-            <a:ext cx="10972800" cy="255711"/>
+            <a:ext cx="10972800" cy="457200"/>
           </a:xfrm>
           <a:prstGeom prst="rect">
             <a:avLst/>
@@ -5652,7 +5576,7 @@
           <a:noFill/>
         </p:spPr>
         <p:txBody>
-          <a:bodyPr wrap="square" lIns="0" tIns="0" rIns="0" bIns="0">
+          <a:bodyPr wrap="square" lIns="0" rIns="0" tIns="0" bIns="0">
             <a:spAutoFit/>
           </a:bodyPr>
           <a:lstStyle/>
@@ -5663,112 +5587,13 @@
               </a:lnSpc>
             </a:pPr>
             <a:r>
-              <a:rPr sz="1400" b="0" dirty="0" err="1">
+              <a:rPr sz="1400" b="0">
                 <a:solidFill>
                   <a:srgbClr val="6B7280"/>
                 </a:solidFill>
                 <a:latin typeface="Pretendard"/>
               </a:rPr>
-              <a:t>AI는</a:t>
-            </a:r>
-            <a:r>
-              <a:rPr sz="1400" b="0" dirty="0">
-                <a:solidFill>
-                  <a:srgbClr val="6B7280"/>
-                </a:solidFill>
-                <a:latin typeface="Pretendard"/>
-              </a:rPr>
-              <a:t> </a:t>
-            </a:r>
-            <a:r>
-              <a:rPr lang="ko-KR" altLang="en-US" sz="1400" dirty="0">
-                <a:solidFill>
-                  <a:srgbClr val="6B7280"/>
-                </a:solidFill>
-                <a:latin typeface="Pretendard"/>
-              </a:rPr>
-              <a:t>구현과 재검증을 </a:t>
-            </a:r>
-            <a:r>
-              <a:rPr sz="1400" b="0" dirty="0">
-                <a:solidFill>
-                  <a:srgbClr val="6B7280"/>
-                </a:solidFill>
-                <a:latin typeface="Pretendard"/>
-              </a:rPr>
-              <a:t>, </a:t>
-            </a:r>
-            <a:r>
-              <a:rPr sz="1400" b="0" dirty="0" err="1">
-                <a:solidFill>
-                  <a:srgbClr val="6B7280"/>
-                </a:solidFill>
-                <a:latin typeface="Pretendard"/>
-              </a:rPr>
-              <a:t>사람은</a:t>
-            </a:r>
-            <a:r>
-              <a:rPr sz="1400" b="0" dirty="0">
-                <a:solidFill>
-                  <a:srgbClr val="6B7280"/>
-                </a:solidFill>
-                <a:latin typeface="Pretendard"/>
-              </a:rPr>
-              <a:t> </a:t>
-            </a:r>
-            <a:r>
-              <a:rPr sz="1400" b="0" dirty="0" err="1">
-                <a:solidFill>
-                  <a:srgbClr val="6B7280"/>
-                </a:solidFill>
-                <a:latin typeface="Pretendard"/>
-              </a:rPr>
-              <a:t>기준과</a:t>
-            </a:r>
-            <a:r>
-              <a:rPr sz="1400" b="0" dirty="0">
-                <a:solidFill>
-                  <a:srgbClr val="6B7280"/>
-                </a:solidFill>
-                <a:latin typeface="Pretendard"/>
-              </a:rPr>
-              <a:t> </a:t>
-            </a:r>
-            <a:r>
-              <a:rPr sz="1400" b="0" dirty="0" err="1">
-                <a:solidFill>
-                  <a:srgbClr val="6B7280"/>
-                </a:solidFill>
-                <a:latin typeface="Pretendard"/>
-              </a:rPr>
-              <a:t>검증</a:t>
-            </a:r>
-            <a:r>
-              <a:rPr sz="1400" b="0" dirty="0">
-                <a:solidFill>
-                  <a:srgbClr val="6B7280"/>
-                </a:solidFill>
-                <a:latin typeface="Pretendard"/>
-              </a:rPr>
-              <a:t>.   </a:t>
-            </a:r>
-            <a:r>
-              <a:rPr sz="1400" b="0" dirty="0" err="1">
-                <a:solidFill>
-                  <a:srgbClr val="6B7280"/>
-                </a:solidFill>
-                <a:latin typeface="Pretendard"/>
-              </a:rPr>
-              <a:t>감사합니다</a:t>
-            </a:r>
-            <a:r>
-              <a:rPr sz="1400" b="0" dirty="0">
-                <a:solidFill>
-                  <a:srgbClr val="6B7280"/>
-                </a:solidFill>
-                <a:latin typeface="Pretendard"/>
-              </a:rPr>
-              <a:t>.</a:t>
+              <a:t>AI는 빠른 손, 사람은 기준과 검증.   감사합니다.</a:t>
             </a:r>
           </a:p>
         </p:txBody>

</xml_diff>

<commit_message>
docs(deck): plain Korean wording for architecture slide
</commit_message>
<xml_diff>
--- a/docs/Proofolio_발표.pptx
+++ b/docs/Proofolio_발표.pptx
@@ -4801,8 +4801,8 @@
         </p:nvSpPr>
         <p:spPr>
           <a:xfrm>
-            <a:off x="731520" y="2331720"/>
-            <a:ext cx="10972800" cy="2377440"/>
+            <a:off x="731520" y="2468880"/>
+            <a:ext cx="10972800" cy="2194560"/>
           </a:xfrm>
           <a:prstGeom prst="rect">
             <a:avLst/>
@@ -4815,131 +4815,67 @@
           </a:bodyPr>
           <a:lstStyle/>
           <a:p>
-            <a:pPr algn="l">
+            <a:pPr algn="ctr">
               <a:lnSpc>
-                <a:spcPct val="135000"/>
+                <a:spcPct val="160000"/>
               </a:lnSpc>
             </a:pPr>
             <a:r>
-              <a:rPr sz="1200" b="0">
+              <a:rPr sz="1700" b="0">
                 <a:solidFill>
                   <a:srgbClr val="3F4757"/>
                 </a:solidFill>
-                <a:latin typeface="Menlo"/>
-              </a:rPr>
-              <a:t>[발급기관 지갑]  ─ issueCredential ─▶  [Proofolio · Sepolia]</a:t>
-            </a:r>
-          </a:p>
-          <a:p>
-            <a:pPr algn="l">
+                <a:latin typeface="Pretendard"/>
+              </a:rPr>
+              <a:t>발급기관    →    블록체인에 영구 기록    →    보유자 지갑</a:t>
+            </a:r>
+          </a:p>
+          <a:p>
+            <a:pPr algn="ctr">
               <a:lnSpc>
-                <a:spcPct val="135000"/>
+                <a:spcPct val="160000"/>
               </a:lnSpc>
             </a:pPr>
             <a:r>
-              <a:rPr sz="1200" b="0">
+              <a:rPr sz="1700" b="0">
                 <a:solidFill>
                   <a:srgbClr val="3F4757"/>
                 </a:solidFill>
-                <a:latin typeface="Menlo"/>
-              </a:rPr>
-              <a:t>                                                │</a:t>
-            </a:r>
-          </a:p>
-          <a:p>
-            <a:pPr algn="l">
+                <a:latin typeface="Pretendard"/>
+              </a:rPr>
+              <a:t/>
+            </a:r>
+          </a:p>
+          <a:p>
+            <a:pPr algn="ctr">
               <a:lnSpc>
-                <a:spcPct val="135000"/>
+                <a:spcPct val="160000"/>
               </a:lnSpc>
             </a:pPr>
             <a:r>
-              <a:rPr sz="1200" b="0">
+              <a:rPr sz="1700" b="0">
                 <a:solidFill>
                   <a:srgbClr val="3F4757"/>
                 </a:solidFill>
-                <a:latin typeface="Menlo"/>
-              </a:rPr>
-              <a:t>                                                ▼</a:t>
-            </a:r>
-          </a:p>
-          <a:p>
-            <a:pPr algn="l">
+                <a:latin typeface="Pretendard"/>
+              </a:rPr>
+              <a:t>                              ↑</a:t>
+            </a:r>
+          </a:p>
+          <a:p>
+            <a:pPr algn="ctr">
               <a:lnSpc>
-                <a:spcPct val="135000"/>
+                <a:spcPct val="160000"/>
               </a:lnSpc>
             </a:pPr>
             <a:r>
-              <a:rPr sz="1200" b="0">
+              <a:rPr sz="1700" b="0">
                 <a:solidFill>
                   <a:srgbClr val="3F4757"/>
                 </a:solidFill>
-                <a:latin typeface="Menlo"/>
-              </a:rPr>
-              <a:t>                                       [소울바운드 ERC-721]</a:t>
-            </a:r>
-          </a:p>
-          <a:p>
-            <a:pPr algn="l">
-              <a:lnSpc>
-                <a:spcPct val="135000"/>
-              </a:lnSpc>
-            </a:pPr>
-            <a:r>
-              <a:rPr sz="1200" b="0">
-                <a:solidFill>
-                  <a:srgbClr val="3F4757"/>
-                </a:solidFill>
-                <a:latin typeface="Menlo"/>
-              </a:rPr>
-              <a:t>                                          (보유자 지갑)</a:t>
-            </a:r>
-          </a:p>
-          <a:p>
-            <a:pPr algn="l">
-              <a:lnSpc>
-                <a:spcPct val="135000"/>
-              </a:lnSpc>
-            </a:pPr>
-            <a:r>
-              <a:rPr sz="1200" b="0">
-                <a:solidFill>
-                  <a:srgbClr val="3F4757"/>
-                </a:solidFill>
-                <a:latin typeface="Menlo"/>
-              </a:rPr>
-              <a:t>                                                │</a:t>
-            </a:r>
-          </a:p>
-          <a:p>
-            <a:pPr algn="l">
-              <a:lnSpc>
-                <a:spcPct val="135000"/>
-              </a:lnSpc>
-            </a:pPr>
-            <a:r>
-              <a:rPr sz="1200" b="0">
-                <a:solidFill>
-                  <a:srgbClr val="3F4757"/>
-                </a:solidFill>
-                <a:latin typeface="Menlo"/>
-              </a:rPr>
-              <a:t>          (지갑 없이) ◀─ verify(tokenId) + keccak256 ─┘</a:t>
-            </a:r>
-          </a:p>
-          <a:p>
-            <a:pPr algn="l">
-              <a:lnSpc>
-                <a:spcPct val="135000"/>
-              </a:lnSpc>
-            </a:pPr>
-            <a:r>
-              <a:rPr sz="1200" b="0">
-                <a:solidFill>
-                  <a:srgbClr val="3F4757"/>
-                </a:solidFill>
-                <a:latin typeface="Menlo"/>
-              </a:rPr>
-              <a:t>                       검증자가 직접 RPC 호출</a:t>
+                <a:latin typeface="Pretendard"/>
+              </a:rPr>
+              <a:t>             검증자가 지갑 없이도 누구나 진위 확인</a:t>
             </a:r>
           </a:p>
         </p:txBody>
@@ -5021,7 +4957,7 @@
                 </a:solidFill>
                 <a:latin typeface="Pretendard"/>
               </a:rPr>
-              <a:t>·  ERC-721 + Ownable2Step + 소울바운드 (_update mint-only)</a:t>
+              <a:t>·  증명서는 양도가 불가능한 형태로 발급 — 사고팔 수 없음</a:t>
             </a:r>
           </a:p>
         </p:txBody>
@@ -5060,7 +4996,7 @@
                 </a:solidFill>
                 <a:latin typeface="Pretendard"/>
               </a:rPr>
-              <a:t>·  Hardhat 단위 테스트 17개 — 정상·엣지·보안</a:t>
+              <a:t>·  자동 테스트 17개로 정상 · 비정상 · 공격 시나리오까지 검증</a:t>
             </a:r>
           </a:p>
         </p:txBody>
@@ -5099,7 +5035,7 @@
                 </a:solidFill>
                 <a:latin typeface="Pretendard"/>
               </a:rPr>
-              <a:t>·  Etherscan ✅ Verified — 누구나 소스코드 확인 가능</a:t>
+              <a:t>·  코드를 Etherscan에 공개 — 저희를 안 믿어도 코드는 검증 가능</a:t>
             </a:r>
           </a:p>
         </p:txBody>
@@ -5138,7 +5074,7 @@
                 </a:solidFill>
                 <a:latin typeface="Pretendard"/>
               </a:rPr>
-              <a:t>·  한계: 발급 사실만 보장. 기관 정당성은 별도 신뢰 앵커.</a:t>
+              <a:t>·  한 가지 한계 — '기관이 발급했다'는 보장하지만 '기관이 좋은가'는 별도 검토</a:t>
             </a:r>
           </a:p>
         </p:txBody>

</xml_diff>

<commit_message>
feat(deck): 9-slide layout for 3-video + live demo flow
</commit_message>
<xml_diff>
--- a/docs/Proofolio_발표.pptx
+++ b/docs/Proofolio_발표.pptx
@@ -12,6 +12,8 @@
     <p:sldId id="260" r:id="rId11"/>
     <p:sldId id="261" r:id="rId12"/>
     <p:sldId id="262" r:id="rId13"/>
+    <p:sldId id="263" r:id="rId14"/>
+    <p:sldId id="264" r:id="rId15"/>
   </p:sldIdLst>
   <p:sldSz cx="12191695" cy="6858000" type="screen4x3"/>
   <p:notesSz cx="6858000" cy="9144000"/>
@@ -4066,7 +4068,7 @@
                 </a:solidFill>
                 <a:latin typeface="Pretendard"/>
               </a:rPr>
-              <a:t>03 · DEMO</a:t>
+              <a:t>03 · DEMO · ① 발급기관 등록</a:t>
             </a:r>
           </a:p>
         </p:txBody>
@@ -4099,13 +4101,13 @@
               </a:lnSpc>
             </a:pPr>
             <a:r>
-              <a:rPr sz="3200" b="1">
+              <a:rPr sz="3000" b="1">
                 <a:solidFill>
                   <a:srgbClr val="0B1220"/>
                 </a:solidFill>
                 <a:latin typeface="Pretendard"/>
               </a:rPr>
-              <a:t>발급 영상 → 라이브 검증</a:t>
+              <a:t>관리자가 새 발급기관을 등록합니다.</a:t>
             </a:r>
           </a:p>
         </p:txBody>
@@ -4159,7 +4161,7 @@
                 </a:solidFill>
                 <a:latin typeface="Pretendard"/>
               </a:rPr>
-              <a:t>▶  발급 흐름 영상</a:t>
+              <a:t>▶  영상 1</a:t>
             </a:r>
           </a:p>
           <a:p>
@@ -4175,46 +4177,7 @@
                 </a:solidFill>
                 <a:latin typeface="Pretendard"/>
               </a:rPr>
-              <a:t>이 자리에 .mov 파일을 드래그 (자동재생, 음소거, 15~20초)</a:t>
-            </a:r>
-          </a:p>
-        </p:txBody>
-      </p:sp>
-      <p:sp>
-        <p:nvSpPr>
-          <p:cNvPr id="5" name="TextBox 4"/>
-          <p:cNvSpPr txBox="1"/>
-          <p:nvPr/>
-        </p:nvSpPr>
-        <p:spPr>
-          <a:xfrm>
-            <a:off x="731520" y="6355080"/>
-            <a:ext cx="10972800" cy="365760"/>
-          </a:xfrm>
-          <a:prstGeom prst="rect">
-            <a:avLst/>
-          </a:prstGeom>
-          <a:noFill/>
-        </p:spPr>
-        <p:txBody>
-          <a:bodyPr wrap="square" lIns="0" rIns="0" tIns="0" bIns="0">
-            <a:spAutoFit/>
-          </a:bodyPr>
-          <a:lstStyle/>
-          <a:p>
-            <a:pPr algn="ctr">
-              <a:lnSpc>
-                <a:spcPct val="130000"/>
-              </a:lnSpc>
-            </a:pPr>
-            <a:r>
-              <a:rPr sz="1200" b="0">
-                <a:solidFill>
-                  <a:srgbClr val="6B7280"/>
-                </a:solidFill>
-                <a:latin typeface="Pretendard"/>
-              </a:rPr>
-              <a:t>영상 자동재생 후 → 브라우저로 전환해 라이브 검증</a:t>
+              <a:t>Admin이 발급기관 등록하는 .mov 드래그 · 자동재생 · 음소거</a:t>
             </a:r>
           </a:p>
         </p:txBody>
@@ -4279,7 +4242,7 @@
                 </a:solidFill>
                 <a:latin typeface="Pretendard"/>
               </a:rPr>
-              <a:t>04 · 그 외 화면</a:t>
+              <a:t>03 · DEMO · ② 증명서 발급</a:t>
             </a:r>
           </a:p>
         </p:txBody>
@@ -4312,66 +4275,27 @@
               </a:lnSpc>
             </a:pPr>
             <a:r>
-              <a:rPr sz="3200" b="1">
+              <a:rPr sz="3000" b="1">
                 <a:solidFill>
                   <a:srgbClr val="0B1220"/>
                 </a:solidFill>
                 <a:latin typeface="Pretendard"/>
               </a:rPr>
-              <a:t>관리자 · 발급기관 · 보유자</a:t>
-            </a:r>
-          </a:p>
-        </p:txBody>
-      </p:sp>
-      <p:sp>
-        <p:nvSpPr>
-          <p:cNvPr id="4" name="TextBox 3"/>
-          <p:cNvSpPr txBox="1"/>
-          <p:nvPr/>
-        </p:nvSpPr>
-        <p:spPr>
-          <a:xfrm>
-            <a:off x="731520" y="1783080"/>
-            <a:ext cx="10972800" cy="457200"/>
-          </a:xfrm>
-          <a:prstGeom prst="rect">
-            <a:avLst/>
-          </a:prstGeom>
-          <a:noFill/>
-        </p:spPr>
-        <p:txBody>
-          <a:bodyPr wrap="square" lIns="0" rIns="0" tIns="0" bIns="0">
-            <a:spAutoFit/>
-          </a:bodyPr>
-          <a:lstStyle/>
-          <a:p>
-            <a:pPr algn="l">
-              <a:lnSpc>
-                <a:spcPct val="140000"/>
-              </a:lnSpc>
-            </a:pPr>
-            <a:r>
-              <a:rPr sz="1400" b="0">
-                <a:solidFill>
-                  <a:srgbClr val="3F4757"/>
-                </a:solidFill>
-                <a:latin typeface="Pretendard"/>
-              </a:rPr>
-              <a:t>검증 외에도 다음 화면들이 같은 디자인 시스템으로 구현되어 있습니다.</a:t>
-            </a:r>
-          </a:p>
-        </p:txBody>
-      </p:sp>
-      <p:sp>
-        <p:nvSpPr>
-          <p:cNvPr id="5" name="Rounded Rectangle 4"/>
+              <a:t>발급기관이 학생에게 증명서를 발급합니다.</a:t>
+            </a:r>
+          </a:p>
+        </p:txBody>
+      </p:sp>
+      <p:sp>
+        <p:nvSpPr>
+          <p:cNvPr id="4" name="Rounded Rectangle 3"/>
           <p:cNvSpPr/>
           <p:nvPr/>
         </p:nvSpPr>
         <p:spPr>
           <a:xfrm>
-            <a:off x="586587" y="2743200"/>
-            <a:ext cx="3520440" cy="2743200"/>
+            <a:off x="1981047" y="2011680"/>
+            <a:ext cx="8229600" cy="4114800"/>
           </a:xfrm>
           <a:prstGeom prst="roundRect">
             <a:avLst/>
@@ -4411,7 +4335,7 @@
                 </a:solidFill>
                 <a:latin typeface="Pretendard"/>
               </a:rPr>
-              <a:t>관리자 · /admin</a:t>
+              <a:t>▶  영상 2</a:t>
             </a:r>
           </a:p>
           <a:p>
@@ -4427,264 +4351,7 @@
                 </a:solidFill>
                 <a:latin typeface="Pretendard"/>
               </a:rPr>
-              <a:t>스샷을 이 자리에 드래그</a:t>
-            </a:r>
-          </a:p>
-        </p:txBody>
-      </p:sp>
-      <p:sp>
-        <p:nvSpPr>
-          <p:cNvPr id="6" name="TextBox 5"/>
-          <p:cNvSpPr txBox="1"/>
-          <p:nvPr/>
-        </p:nvSpPr>
-        <p:spPr>
-          <a:xfrm>
-            <a:off x="586587" y="5623560"/>
-            <a:ext cx="3520440" cy="365760"/>
-          </a:xfrm>
-          <a:prstGeom prst="rect">
-            <a:avLst/>
-          </a:prstGeom>
-          <a:noFill/>
-        </p:spPr>
-        <p:txBody>
-          <a:bodyPr wrap="square" lIns="0" rIns="0" tIns="0" bIns="0">
-            <a:spAutoFit/>
-          </a:bodyPr>
-          <a:lstStyle/>
-          <a:p>
-            <a:pPr algn="ctr">
-              <a:lnSpc>
-                <a:spcPct val="130000"/>
-              </a:lnSpc>
-            </a:pPr>
-            <a:r>
-              <a:rPr sz="1100" b="0">
-                <a:solidFill>
-                  <a:srgbClr val="6B7280"/>
-                </a:solidFill>
-                <a:latin typeface="Pretendard"/>
-              </a:rPr>
-              <a:t>발급기관 등록 · 활성 관리</a:t>
-            </a:r>
-          </a:p>
-        </p:txBody>
-      </p:sp>
-      <p:sp>
-        <p:nvSpPr>
-          <p:cNvPr id="7" name="Rounded Rectangle 6"/>
-          <p:cNvSpPr/>
-          <p:nvPr/>
-        </p:nvSpPr>
-        <p:spPr>
-          <a:xfrm>
-            <a:off x="4335627" y="2743200"/>
-            <a:ext cx="3520440" cy="2743200"/>
-          </a:xfrm>
-          <a:prstGeom prst="roundRect">
-            <a:avLst/>
-          </a:prstGeom>
-          <a:solidFill>
-            <a:srgbClr val="F1F3F7"/>
-          </a:solidFill>
-          <a:ln w="12700">
-            <a:solidFill>
-              <a:srgbClr val="E6E8EE"/>
-            </a:solidFill>
-          </a:ln>
-        </p:spPr>
-        <p:style>
-          <a:lnRef idx="1">
-            <a:schemeClr val="accent1"/>
-          </a:lnRef>
-          <a:fillRef idx="3">
-            <a:schemeClr val="accent1"/>
-          </a:fillRef>
-          <a:effectRef idx="2">
-            <a:schemeClr val="accent1"/>
-          </a:effectRef>
-          <a:fontRef idx="minor">
-            <a:schemeClr val="lt1"/>
-          </a:fontRef>
-        </p:style>
-        <p:txBody>
-          <a:bodyPr rtlCol="0" anchor="ctr" wrap="square" lIns="254000" rIns="254000" tIns="254000" bIns="254000"/>
-          <a:lstStyle/>
-          <a:p>
-            <a:pPr algn="ctr"/>
-            <a:r>
-              <a:rPr sz="1800" b="1">
-                <a:solidFill>
-                  <a:srgbClr val="6B7280"/>
-                </a:solidFill>
-                <a:latin typeface="Pretendard"/>
-              </a:rPr>
-              <a:t>발급 · /issue</a:t>
-            </a:r>
-          </a:p>
-          <a:p>
-            <a:pPr algn="ctr">
-              <a:spcBef>
-                <a:spcPts val="600"/>
-              </a:spcBef>
-            </a:pPr>
-            <a:r>
-              <a:rPr sz="1000">
-                <a:solidFill>
-                  <a:srgbClr val="6B7280"/>
-                </a:solidFill>
-                <a:latin typeface="Pretendard"/>
-              </a:rPr>
-              <a:t>스샷을 이 자리에 드래그</a:t>
-            </a:r>
-          </a:p>
-        </p:txBody>
-      </p:sp>
-      <p:sp>
-        <p:nvSpPr>
-          <p:cNvPr id="8" name="TextBox 7"/>
-          <p:cNvSpPr txBox="1"/>
-          <p:nvPr/>
-        </p:nvSpPr>
-        <p:spPr>
-          <a:xfrm>
-            <a:off x="4335627" y="5623560"/>
-            <a:ext cx="3520440" cy="365760"/>
-          </a:xfrm>
-          <a:prstGeom prst="rect">
-            <a:avLst/>
-          </a:prstGeom>
-          <a:noFill/>
-        </p:spPr>
-        <p:txBody>
-          <a:bodyPr wrap="square" lIns="0" rIns="0" tIns="0" bIns="0">
-            <a:spAutoFit/>
-          </a:bodyPr>
-          <a:lstStyle/>
-          <a:p>
-            <a:pPr algn="ctr">
-              <a:lnSpc>
-                <a:spcPct val="130000"/>
-              </a:lnSpc>
-            </a:pPr>
-            <a:r>
-              <a:rPr sz="1100" b="0">
-                <a:solidFill>
-                  <a:srgbClr val="6B7280"/>
-                </a:solidFill>
-                <a:latin typeface="Pretendard"/>
-              </a:rPr>
-              <a:t>보유자에게 증명서 발급</a:t>
-            </a:r>
-          </a:p>
-        </p:txBody>
-      </p:sp>
-      <p:sp>
-        <p:nvSpPr>
-          <p:cNvPr id="9" name="Rounded Rectangle 8"/>
-          <p:cNvSpPr/>
-          <p:nvPr/>
-        </p:nvSpPr>
-        <p:spPr>
-          <a:xfrm>
-            <a:off x="8084667" y="2743200"/>
-            <a:ext cx="3520440" cy="2743200"/>
-          </a:xfrm>
-          <a:prstGeom prst="roundRect">
-            <a:avLst/>
-          </a:prstGeom>
-          <a:solidFill>
-            <a:srgbClr val="F1F3F7"/>
-          </a:solidFill>
-          <a:ln w="12700">
-            <a:solidFill>
-              <a:srgbClr val="E6E8EE"/>
-            </a:solidFill>
-          </a:ln>
-        </p:spPr>
-        <p:style>
-          <a:lnRef idx="1">
-            <a:schemeClr val="accent1"/>
-          </a:lnRef>
-          <a:fillRef idx="3">
-            <a:schemeClr val="accent1"/>
-          </a:fillRef>
-          <a:effectRef idx="2">
-            <a:schemeClr val="accent1"/>
-          </a:effectRef>
-          <a:fontRef idx="minor">
-            <a:schemeClr val="lt1"/>
-          </a:fontRef>
-        </p:style>
-        <p:txBody>
-          <a:bodyPr rtlCol="0" anchor="ctr" wrap="square" lIns="254000" rIns="254000" tIns="254000" bIns="254000"/>
-          <a:lstStyle/>
-          <a:p>
-            <a:pPr algn="ctr"/>
-            <a:r>
-              <a:rPr sz="1800" b="1">
-                <a:solidFill>
-                  <a:srgbClr val="6B7280"/>
-                </a:solidFill>
-                <a:latin typeface="Pretendard"/>
-              </a:rPr>
-              <a:t>보유자 · /credentials</a:t>
-            </a:r>
-          </a:p>
-          <a:p>
-            <a:pPr algn="ctr">
-              <a:spcBef>
-                <a:spcPts val="600"/>
-              </a:spcBef>
-            </a:pPr>
-            <a:r>
-              <a:rPr sz="1000">
-                <a:solidFill>
-                  <a:srgbClr val="6B7280"/>
-                </a:solidFill>
-                <a:latin typeface="Pretendard"/>
-              </a:rPr>
-              <a:t>스샷을 이 자리에 드래그</a:t>
-            </a:r>
-          </a:p>
-        </p:txBody>
-      </p:sp>
-      <p:sp>
-        <p:nvSpPr>
-          <p:cNvPr id="10" name="TextBox 9"/>
-          <p:cNvSpPr txBox="1"/>
-          <p:nvPr/>
-        </p:nvSpPr>
-        <p:spPr>
-          <a:xfrm>
-            <a:off x="8084667" y="5623560"/>
-            <a:ext cx="3520440" cy="365760"/>
-          </a:xfrm>
-          <a:prstGeom prst="rect">
-            <a:avLst/>
-          </a:prstGeom>
-          <a:noFill/>
-        </p:spPr>
-        <p:txBody>
-          <a:bodyPr wrap="square" lIns="0" rIns="0" tIns="0" bIns="0">
-            <a:spAutoFit/>
-          </a:bodyPr>
-          <a:lstStyle/>
-          <a:p>
-            <a:pPr algn="ctr">
-              <a:lnSpc>
-                <a:spcPct val="130000"/>
-              </a:lnSpc>
-            </a:pPr>
-            <a:r>
-              <a:rPr sz="1100" b="0">
-                <a:solidFill>
-                  <a:srgbClr val="6B7280"/>
-                </a:solidFill>
-                <a:latin typeface="Pretendard"/>
-              </a:rPr>
-              <a:t>받은 증명서 보기</a:t>
+              <a:t>지갑 주소·파일 입력 → 발급 .mov 드래그 · 자동재생 · 음소거</a:t>
             </a:r>
           </a:p>
         </p:txBody>
@@ -4749,7 +4416,7 @@
                 </a:solidFill>
                 <a:latin typeface="Pretendard"/>
               </a:rPr>
-              <a:t>05 · ARCHITECTURE &amp; ENGINEERING</a:t>
+              <a:t>03 · DEMO · ③ 수령 + QR</a:t>
             </a:r>
           </a:p>
         </p:txBody>
@@ -4762,8 +4429,8 @@
         </p:nvSpPr>
         <p:spPr>
           <a:xfrm>
-            <a:off x="731520" y="1097280"/>
-            <a:ext cx="10972800" cy="914400"/>
+            <a:off x="731520" y="1051560"/>
+            <a:ext cx="10972800" cy="640080"/>
           </a:xfrm>
           <a:prstGeom prst="rect">
             <a:avLst/>
@@ -4782,123 +4449,38 @@
               </a:lnSpc>
             </a:pPr>
             <a:r>
-              <a:rPr sz="3600" b="1">
+              <a:rPr sz="3000" b="1">
                 <a:solidFill>
                   <a:srgbClr val="0B1220"/>
                 </a:solidFill>
                 <a:latin typeface="Pretendard"/>
               </a:rPr>
-              <a:t>단순한 데모가 아닙니다.</a:t>
-            </a:r>
-          </a:p>
-        </p:txBody>
-      </p:sp>
-      <p:sp>
-        <p:nvSpPr>
-          <p:cNvPr id="4" name="TextBox 3"/>
-          <p:cNvSpPr txBox="1"/>
-          <p:nvPr/>
-        </p:nvSpPr>
-        <p:spPr>
-          <a:xfrm>
-            <a:off x="731520" y="2468880"/>
-            <a:ext cx="10972800" cy="2194560"/>
-          </a:xfrm>
-          <a:prstGeom prst="rect">
-            <a:avLst/>
-          </a:prstGeom>
-          <a:noFill/>
-        </p:spPr>
-        <p:txBody>
-          <a:bodyPr wrap="square" lIns="0" rIns="0" tIns="0" bIns="0">
-            <a:spAutoFit/>
-          </a:bodyPr>
-          <a:lstStyle/>
-          <a:p>
-            <a:pPr algn="ctr">
-              <a:lnSpc>
-                <a:spcPct val="160000"/>
-              </a:lnSpc>
-            </a:pPr>
-            <a:r>
-              <a:rPr sz="1700" b="0">
-                <a:solidFill>
-                  <a:srgbClr val="3F4757"/>
-                </a:solidFill>
-                <a:latin typeface="Pretendard"/>
-              </a:rPr>
-              <a:t>발급기관    →    블록체인에 영구 기록    →    보유자 지갑</a:t>
-            </a:r>
-          </a:p>
-          <a:p>
-            <a:pPr algn="ctr">
-              <a:lnSpc>
-                <a:spcPct val="160000"/>
-              </a:lnSpc>
-            </a:pPr>
-            <a:r>
-              <a:rPr sz="1700" b="0">
-                <a:solidFill>
-                  <a:srgbClr val="3F4757"/>
-                </a:solidFill>
-                <a:latin typeface="Pretendard"/>
-              </a:rPr>
-              <a:t/>
-            </a:r>
-          </a:p>
-          <a:p>
-            <a:pPr algn="ctr">
-              <a:lnSpc>
-                <a:spcPct val="160000"/>
-              </a:lnSpc>
-            </a:pPr>
-            <a:r>
-              <a:rPr sz="1700" b="0">
-                <a:solidFill>
-                  <a:srgbClr val="3F4757"/>
-                </a:solidFill>
-                <a:latin typeface="Pretendard"/>
-              </a:rPr>
-              <a:t>                              ↑</a:t>
-            </a:r>
-          </a:p>
-          <a:p>
-            <a:pPr algn="ctr">
-              <a:lnSpc>
-                <a:spcPct val="160000"/>
-              </a:lnSpc>
-            </a:pPr>
-            <a:r>
-              <a:rPr sz="1700" b="0">
-                <a:solidFill>
-                  <a:srgbClr val="3F4757"/>
-                </a:solidFill>
-                <a:latin typeface="Pretendard"/>
-              </a:rPr>
-              <a:t>             검증자가 지갑 없이도 누구나 진위 확인</a:t>
-            </a:r>
-          </a:p>
-        </p:txBody>
-      </p:sp>
-      <p:sp>
-        <p:nvSpPr>
-          <p:cNvPr id="5" name="Rectangle 4"/>
+              <a:t>학생이 자기 증명서와 QR을 확인합니다.</a:t>
+            </a:r>
+          </a:p>
+        </p:txBody>
+      </p:sp>
+      <p:sp>
+        <p:nvSpPr>
+          <p:cNvPr id="4" name="Rounded Rectangle 3"/>
           <p:cNvSpPr/>
           <p:nvPr/>
         </p:nvSpPr>
         <p:spPr>
           <a:xfrm>
-            <a:off x="731520" y="4892040"/>
-            <a:ext cx="10698480" cy="8000"/>
-          </a:xfrm>
-          <a:prstGeom prst="rect">
+            <a:off x="1981047" y="2011680"/>
+            <a:ext cx="8229600" cy="4114800"/>
+          </a:xfrm>
+          <a:prstGeom prst="roundRect">
             <a:avLst/>
           </a:prstGeom>
           <a:solidFill>
-            <a:srgbClr val="E6E8EE"/>
+            <a:srgbClr val="F1F3F7"/>
           </a:solidFill>
-          <a:ln>
-            <a:noFill/>
+          <a:ln w="12700">
+            <a:solidFill>
+              <a:srgbClr val="E6E8EE"/>
+            </a:solidFill>
           </a:ln>
         </p:spPr>
         <p:style>
@@ -4916,165 +4498,34 @@
           </a:fontRef>
         </p:style>
         <p:txBody>
-          <a:bodyPr rtlCol="0" anchor="ctr"/>
+          <a:bodyPr rtlCol="0" anchor="ctr" wrap="square" lIns="254000" rIns="254000" tIns="254000" bIns="254000"/>
           <a:lstStyle/>
           <a:p>
             <a:pPr algn="ctr"/>
-          </a:p>
-        </p:txBody>
-      </p:sp>
-      <p:sp>
-        <p:nvSpPr>
-          <p:cNvPr id="6" name="TextBox 5"/>
-          <p:cNvSpPr txBox="1"/>
-          <p:nvPr/>
-        </p:nvSpPr>
-        <p:spPr>
-          <a:xfrm>
-            <a:off x="731520" y="5120640"/>
-            <a:ext cx="10972800" cy="365760"/>
-          </a:xfrm>
-          <a:prstGeom prst="rect">
-            <a:avLst/>
-          </a:prstGeom>
-          <a:noFill/>
-        </p:spPr>
-        <p:txBody>
-          <a:bodyPr wrap="square" lIns="0" rIns="0" tIns="0" bIns="0">
-            <a:spAutoFit/>
-          </a:bodyPr>
-          <a:lstStyle/>
-          <a:p>
-            <a:pPr algn="l">
-              <a:lnSpc>
-                <a:spcPct val="130000"/>
-              </a:lnSpc>
+            <a:r>
+              <a:rPr sz="1800" b="1">
+                <a:solidFill>
+                  <a:srgbClr val="6B7280"/>
+                </a:solidFill>
+                <a:latin typeface="Pretendard"/>
+              </a:rPr>
+              <a:t>▶  영상 3</a:t>
+            </a:r>
+          </a:p>
+          <a:p>
+            <a:pPr algn="ctr">
+              <a:spcBef>
+                <a:spcPts val="600"/>
+              </a:spcBef>
             </a:pPr>
             <a:r>
-              <a:rPr sz="1400" b="0">
-                <a:solidFill>
-                  <a:srgbClr val="0B1220"/>
-                </a:solidFill>
-                <a:latin typeface="Pretendard"/>
-              </a:rPr>
-              <a:t>·  증명서는 양도가 불가능한 형태로 발급 — 사고팔 수 없음</a:t>
-            </a:r>
-          </a:p>
-        </p:txBody>
-      </p:sp>
-      <p:sp>
-        <p:nvSpPr>
-          <p:cNvPr id="7" name="TextBox 6"/>
-          <p:cNvSpPr txBox="1"/>
-          <p:nvPr/>
-        </p:nvSpPr>
-        <p:spPr>
-          <a:xfrm>
-            <a:off x="731520" y="5486400"/>
-            <a:ext cx="10972800" cy="365760"/>
-          </a:xfrm>
-          <a:prstGeom prst="rect">
-            <a:avLst/>
-          </a:prstGeom>
-          <a:noFill/>
-        </p:spPr>
-        <p:txBody>
-          <a:bodyPr wrap="square" lIns="0" rIns="0" tIns="0" bIns="0">
-            <a:spAutoFit/>
-          </a:bodyPr>
-          <a:lstStyle/>
-          <a:p>
-            <a:pPr algn="l">
-              <a:lnSpc>
-                <a:spcPct val="130000"/>
-              </a:lnSpc>
-            </a:pPr>
-            <a:r>
-              <a:rPr sz="1400" b="0">
-                <a:solidFill>
-                  <a:srgbClr val="0B1220"/>
-                </a:solidFill>
-                <a:latin typeface="Pretendard"/>
-              </a:rPr>
-              <a:t>·  자동 테스트 17개로 정상 · 비정상 · 공격 시나리오까지 검증</a:t>
-            </a:r>
-          </a:p>
-        </p:txBody>
-      </p:sp>
-      <p:sp>
-        <p:nvSpPr>
-          <p:cNvPr id="8" name="TextBox 7"/>
-          <p:cNvSpPr txBox="1"/>
-          <p:nvPr/>
-        </p:nvSpPr>
-        <p:spPr>
-          <a:xfrm>
-            <a:off x="731520" y="5852160"/>
-            <a:ext cx="10972800" cy="365760"/>
-          </a:xfrm>
-          <a:prstGeom prst="rect">
-            <a:avLst/>
-          </a:prstGeom>
-          <a:noFill/>
-        </p:spPr>
-        <p:txBody>
-          <a:bodyPr wrap="square" lIns="0" rIns="0" tIns="0" bIns="0">
-            <a:spAutoFit/>
-          </a:bodyPr>
-          <a:lstStyle/>
-          <a:p>
-            <a:pPr algn="l">
-              <a:lnSpc>
-                <a:spcPct val="130000"/>
-              </a:lnSpc>
-            </a:pPr>
-            <a:r>
-              <a:rPr sz="1400" b="0">
-                <a:solidFill>
-                  <a:srgbClr val="0B1220"/>
-                </a:solidFill>
-                <a:latin typeface="Pretendard"/>
-              </a:rPr>
-              <a:t>·  코드를 Etherscan에 공개 — 저희를 안 믿어도 코드는 검증 가능</a:t>
-            </a:r>
-          </a:p>
-        </p:txBody>
-      </p:sp>
-      <p:sp>
-        <p:nvSpPr>
-          <p:cNvPr id="9" name="TextBox 8"/>
-          <p:cNvSpPr txBox="1"/>
-          <p:nvPr/>
-        </p:nvSpPr>
-        <p:spPr>
-          <a:xfrm>
-            <a:off x="731520" y="6217920"/>
-            <a:ext cx="10972800" cy="365760"/>
-          </a:xfrm>
-          <a:prstGeom prst="rect">
-            <a:avLst/>
-          </a:prstGeom>
-          <a:noFill/>
-        </p:spPr>
-        <p:txBody>
-          <a:bodyPr wrap="square" lIns="0" rIns="0" tIns="0" bIns="0">
-            <a:spAutoFit/>
-          </a:bodyPr>
-          <a:lstStyle/>
-          <a:p>
-            <a:pPr algn="l">
-              <a:lnSpc>
-                <a:spcPct val="130000"/>
-              </a:lnSpc>
-            </a:pPr>
-            <a:r>
-              <a:rPr sz="1400" b="0">
-                <a:solidFill>
-                  <a:srgbClr val="0B1220"/>
-                </a:solidFill>
-                <a:latin typeface="Pretendard"/>
-              </a:rPr>
-              <a:t>·  한 가지 한계 — '기관이 발급했다'는 보장하지만 '기관이 좋은가'는 별도 검토</a:t>
+              <a:rPr sz="1000">
+                <a:solidFill>
+                  <a:srgbClr val="6B7280"/>
+                </a:solidFill>
+                <a:latin typeface="Pretendard"/>
+              </a:rPr>
+              <a:t>보유자 로그인 → 내 증명서 + QR + 검증 페이지 이동 .mov 드래그</a:t>
             </a:r>
           </a:p>
         </p:txBody>
@@ -5139,7 +4590,634 @@
                 </a:solidFill>
                 <a:latin typeface="Pretendard"/>
               </a:rPr>
-              <a:t>06 · VIBE CODING · 노하우</a:t>
+              <a:t>03 · DEMO · ④ 검증 (라이브)</a:t>
+            </a:r>
+          </a:p>
+        </p:txBody>
+      </p:sp>
+      <p:sp>
+        <p:nvSpPr>
+          <p:cNvPr id="3" name="TextBox 2"/>
+          <p:cNvSpPr txBox="1"/>
+          <p:nvPr/>
+        </p:nvSpPr>
+        <p:spPr>
+          <a:xfrm>
+            <a:off x="731520" y="2011680"/>
+            <a:ext cx="10972800" cy="1828800"/>
+          </a:xfrm>
+          <a:prstGeom prst="rect">
+            <a:avLst/>
+          </a:prstGeom>
+          <a:noFill/>
+        </p:spPr>
+        <p:txBody>
+          <a:bodyPr wrap="square" lIns="0" rIns="0" tIns="0" bIns="0">
+            <a:spAutoFit/>
+          </a:bodyPr>
+          <a:lstStyle/>
+          <a:p>
+            <a:pPr algn="l">
+              <a:lnSpc>
+                <a:spcPct val="115000"/>
+              </a:lnSpc>
+            </a:pPr>
+            <a:r>
+              <a:rPr sz="4400" b="1">
+                <a:solidFill>
+                  <a:srgbClr val="0B1220"/>
+                </a:solidFill>
+                <a:latin typeface="Pretendard"/>
+              </a:rPr>
+              <a:t>원본 파일 대조 →</a:t>
+            </a:r>
+          </a:p>
+          <a:p>
+            <a:pPr algn="l">
+              <a:lnSpc>
+                <a:spcPct val="115000"/>
+              </a:lnSpc>
+            </a:pPr>
+            <a:r>
+              <a:rPr sz="4400" b="1">
+                <a:solidFill>
+                  <a:srgbClr val="0B1220"/>
+                </a:solidFill>
+                <a:latin typeface="Pretendard"/>
+              </a:rPr>
+              <a:t>위변조 즉시 감지.</a:t>
+            </a:r>
+          </a:p>
+        </p:txBody>
+      </p:sp>
+      <p:sp>
+        <p:nvSpPr>
+          <p:cNvPr id="4" name="TextBox 3"/>
+          <p:cNvSpPr txBox="1"/>
+          <p:nvPr/>
+        </p:nvSpPr>
+        <p:spPr>
+          <a:xfrm>
+            <a:off x="731520" y="4663440"/>
+            <a:ext cx="10972800" cy="548640"/>
+          </a:xfrm>
+          <a:prstGeom prst="rect">
+            <a:avLst/>
+          </a:prstGeom>
+          <a:noFill/>
+        </p:spPr>
+        <p:txBody>
+          <a:bodyPr wrap="square" lIns="0" rIns="0" tIns="0" bIns="0">
+            <a:spAutoFit/>
+          </a:bodyPr>
+          <a:lstStyle/>
+          <a:p>
+            <a:pPr algn="l">
+              <a:lnSpc>
+                <a:spcPct val="130000"/>
+              </a:lnSpc>
+            </a:pPr>
+            <a:r>
+              <a:rPr sz="2200" b="1">
+                <a:solidFill>
+                  <a:srgbClr val="059669"/>
+                </a:solidFill>
+                <a:latin typeface="Pretendard"/>
+              </a:rPr>
+              <a:t>✅ 원본 일치       ❌ 해시 불일치</a:t>
+            </a:r>
+          </a:p>
+        </p:txBody>
+      </p:sp>
+      <p:sp>
+        <p:nvSpPr>
+          <p:cNvPr id="5" name="TextBox 4"/>
+          <p:cNvSpPr txBox="1"/>
+          <p:nvPr/>
+        </p:nvSpPr>
+        <p:spPr>
+          <a:xfrm>
+            <a:off x="731520" y="5440680"/>
+            <a:ext cx="10972800" cy="457200"/>
+          </a:xfrm>
+          <a:prstGeom prst="rect">
+            <a:avLst/>
+          </a:prstGeom>
+          <a:noFill/>
+        </p:spPr>
+        <p:txBody>
+          <a:bodyPr wrap="square" lIns="0" rIns="0" tIns="0" bIns="0">
+            <a:spAutoFit/>
+          </a:bodyPr>
+          <a:lstStyle/>
+          <a:p>
+            <a:pPr algn="l">
+              <a:lnSpc>
+                <a:spcPct val="130000"/>
+              </a:lnSpc>
+            </a:pPr>
+            <a:r>
+              <a:rPr sz="1400" b="0">
+                <a:solidFill>
+                  <a:srgbClr val="6B7280"/>
+                </a:solidFill>
+                <a:latin typeface="Pretendard"/>
+              </a:rPr>
+              <a:t>브라우저 전환 → proofolio.pages.dev/verify/{ID}</a:t>
+            </a:r>
+          </a:p>
+        </p:txBody>
+      </p:sp>
+      <p:sp>
+        <p:nvSpPr>
+          <p:cNvPr id="6" name="TextBox 5"/>
+          <p:cNvSpPr txBox="1"/>
+          <p:nvPr/>
+        </p:nvSpPr>
+        <p:spPr>
+          <a:xfrm>
+            <a:off x="731520" y="5943600"/>
+            <a:ext cx="10972800" cy="457200"/>
+          </a:xfrm>
+          <a:prstGeom prst="rect">
+            <a:avLst/>
+          </a:prstGeom>
+          <a:noFill/>
+        </p:spPr>
+        <p:txBody>
+          <a:bodyPr wrap="square" lIns="0" rIns="0" tIns="0" bIns="0">
+            <a:spAutoFit/>
+          </a:bodyPr>
+          <a:lstStyle/>
+          <a:p>
+            <a:pPr algn="l">
+              <a:lnSpc>
+                <a:spcPct val="130000"/>
+              </a:lnSpc>
+            </a:pPr>
+            <a:r>
+              <a:rPr sz="1200" b="0">
+                <a:solidFill>
+                  <a:srgbClr val="6B7280"/>
+                </a:solidFill>
+                <a:latin typeface="Pretendard"/>
+              </a:rPr>
+              <a:t>파일 A 업로드 → ✅    파일 B 업로드 → ❌    Etherscan 링크 확인</a:t>
+            </a:r>
+          </a:p>
+        </p:txBody>
+      </p:sp>
+    </p:spTree>
+  </p:cSld>
+  <p:clrMapOvr>
+    <a:masterClrMapping/>
+  </p:clrMapOvr>
+</p:sld>
+</file>
+
+<file path=ppt/slides/slide8.xml><?xml version="1.0" encoding="utf-8"?>
+<p:sld xmlns:a="http://schemas.openxmlformats.org/drawingml/2006/main" xmlns:p="http://schemas.openxmlformats.org/presentationml/2006/main" xmlns:r="http://schemas.openxmlformats.org/officeDocument/2006/relationships">
+  <p:cSld>
+    <p:bg>
+      <p:bgPr>
+        <a:solidFill>
+          <a:srgbClr val="F7F8FA"/>
+        </a:solidFill>
+        <a:effectLst/>
+      </p:bgPr>
+    </p:bg>
+    <p:spTree>
+      <p:nvGrpSpPr>
+        <p:cNvPr id="1" name=""/>
+        <p:cNvGrpSpPr/>
+        <p:nvPr/>
+      </p:nvGrpSpPr>
+      <p:grpSpPr/>
+      <p:sp>
+        <p:nvSpPr>
+          <p:cNvPr id="2" name="TextBox 1"/>
+          <p:cNvSpPr txBox="1"/>
+          <p:nvPr/>
+        </p:nvSpPr>
+        <p:spPr>
+          <a:xfrm>
+            <a:off x="731520" y="548640"/>
+            <a:ext cx="10058400" cy="320040"/>
+          </a:xfrm>
+          <a:prstGeom prst="rect">
+            <a:avLst/>
+          </a:prstGeom>
+          <a:noFill/>
+        </p:spPr>
+        <p:txBody>
+          <a:bodyPr wrap="square" lIns="0" rIns="0" tIns="0" bIns="0">
+            <a:spAutoFit/>
+          </a:bodyPr>
+          <a:lstStyle/>
+          <a:p>
+            <a:pPr algn="l">
+              <a:lnSpc>
+                <a:spcPct val="130000"/>
+              </a:lnSpc>
+            </a:pPr>
+            <a:r>
+              <a:rPr sz="1100" b="1">
+                <a:solidFill>
+                  <a:srgbClr val="059669"/>
+                </a:solidFill>
+                <a:latin typeface="Pretendard"/>
+              </a:rPr>
+              <a:t>04 · ARCHITECTURE &amp; ENGINEERING</a:t>
+            </a:r>
+          </a:p>
+        </p:txBody>
+      </p:sp>
+      <p:sp>
+        <p:nvSpPr>
+          <p:cNvPr id="3" name="TextBox 2"/>
+          <p:cNvSpPr txBox="1"/>
+          <p:nvPr/>
+        </p:nvSpPr>
+        <p:spPr>
+          <a:xfrm>
+            <a:off x="731520" y="1097280"/>
+            <a:ext cx="10972800" cy="914400"/>
+          </a:xfrm>
+          <a:prstGeom prst="rect">
+            <a:avLst/>
+          </a:prstGeom>
+          <a:noFill/>
+        </p:spPr>
+        <p:txBody>
+          <a:bodyPr wrap="square" lIns="0" rIns="0" tIns="0" bIns="0">
+            <a:spAutoFit/>
+          </a:bodyPr>
+          <a:lstStyle/>
+          <a:p>
+            <a:pPr algn="l">
+              <a:lnSpc>
+                <a:spcPct val="110000"/>
+              </a:lnSpc>
+            </a:pPr>
+            <a:r>
+              <a:rPr sz="3600" b="1">
+                <a:solidFill>
+                  <a:srgbClr val="0B1220"/>
+                </a:solidFill>
+                <a:latin typeface="Pretendard"/>
+              </a:rPr>
+              <a:t>단순한 데모가 아닙니다.</a:t>
+            </a:r>
+          </a:p>
+        </p:txBody>
+      </p:sp>
+      <p:sp>
+        <p:nvSpPr>
+          <p:cNvPr id="4" name="TextBox 3"/>
+          <p:cNvSpPr txBox="1"/>
+          <p:nvPr/>
+        </p:nvSpPr>
+        <p:spPr>
+          <a:xfrm>
+            <a:off x="731520" y="2468880"/>
+            <a:ext cx="10972800" cy="2194560"/>
+          </a:xfrm>
+          <a:prstGeom prst="rect">
+            <a:avLst/>
+          </a:prstGeom>
+          <a:noFill/>
+        </p:spPr>
+        <p:txBody>
+          <a:bodyPr wrap="square" lIns="0" rIns="0" tIns="0" bIns="0">
+            <a:spAutoFit/>
+          </a:bodyPr>
+          <a:lstStyle/>
+          <a:p>
+            <a:pPr algn="ctr">
+              <a:lnSpc>
+                <a:spcPct val="160000"/>
+              </a:lnSpc>
+            </a:pPr>
+            <a:r>
+              <a:rPr sz="1700" b="0">
+                <a:solidFill>
+                  <a:srgbClr val="3F4757"/>
+                </a:solidFill>
+                <a:latin typeface="Pretendard"/>
+              </a:rPr>
+              <a:t>발급기관    →    블록체인에 영구 기록    →    보유자 지갑</a:t>
+            </a:r>
+          </a:p>
+          <a:p>
+            <a:pPr algn="ctr">
+              <a:lnSpc>
+                <a:spcPct val="160000"/>
+              </a:lnSpc>
+            </a:pPr>
+            <a:r>
+              <a:rPr sz="1700" b="0">
+                <a:solidFill>
+                  <a:srgbClr val="3F4757"/>
+                </a:solidFill>
+                <a:latin typeface="Pretendard"/>
+              </a:rPr>
+              <a:t/>
+            </a:r>
+          </a:p>
+          <a:p>
+            <a:pPr algn="ctr">
+              <a:lnSpc>
+                <a:spcPct val="160000"/>
+              </a:lnSpc>
+            </a:pPr>
+            <a:r>
+              <a:rPr sz="1700" b="0">
+                <a:solidFill>
+                  <a:srgbClr val="3F4757"/>
+                </a:solidFill>
+                <a:latin typeface="Pretendard"/>
+              </a:rPr>
+              <a:t>                              ↑</a:t>
+            </a:r>
+          </a:p>
+          <a:p>
+            <a:pPr algn="ctr">
+              <a:lnSpc>
+                <a:spcPct val="160000"/>
+              </a:lnSpc>
+            </a:pPr>
+            <a:r>
+              <a:rPr sz="1700" b="0">
+                <a:solidFill>
+                  <a:srgbClr val="3F4757"/>
+                </a:solidFill>
+                <a:latin typeface="Pretendard"/>
+              </a:rPr>
+              <a:t>             검증자가 지갑 없이도 누구나 진위 확인</a:t>
+            </a:r>
+          </a:p>
+        </p:txBody>
+      </p:sp>
+      <p:sp>
+        <p:nvSpPr>
+          <p:cNvPr id="5" name="Rectangle 4"/>
+          <p:cNvSpPr/>
+          <p:nvPr/>
+        </p:nvSpPr>
+        <p:spPr>
+          <a:xfrm>
+            <a:off x="731520" y="4892040"/>
+            <a:ext cx="10698480" cy="8000"/>
+          </a:xfrm>
+          <a:prstGeom prst="rect">
+            <a:avLst/>
+          </a:prstGeom>
+          <a:solidFill>
+            <a:srgbClr val="E6E8EE"/>
+          </a:solidFill>
+          <a:ln>
+            <a:noFill/>
+          </a:ln>
+        </p:spPr>
+        <p:style>
+          <a:lnRef idx="1">
+            <a:schemeClr val="accent1"/>
+          </a:lnRef>
+          <a:fillRef idx="3">
+            <a:schemeClr val="accent1"/>
+          </a:fillRef>
+          <a:effectRef idx="2">
+            <a:schemeClr val="accent1"/>
+          </a:effectRef>
+          <a:fontRef idx="minor">
+            <a:schemeClr val="lt1"/>
+          </a:fontRef>
+        </p:style>
+        <p:txBody>
+          <a:bodyPr rtlCol="0" anchor="ctr"/>
+          <a:lstStyle/>
+          <a:p>
+            <a:pPr algn="ctr"/>
+          </a:p>
+        </p:txBody>
+      </p:sp>
+      <p:sp>
+        <p:nvSpPr>
+          <p:cNvPr id="6" name="TextBox 5"/>
+          <p:cNvSpPr txBox="1"/>
+          <p:nvPr/>
+        </p:nvSpPr>
+        <p:spPr>
+          <a:xfrm>
+            <a:off x="731520" y="5120640"/>
+            <a:ext cx="10972800" cy="365760"/>
+          </a:xfrm>
+          <a:prstGeom prst="rect">
+            <a:avLst/>
+          </a:prstGeom>
+          <a:noFill/>
+        </p:spPr>
+        <p:txBody>
+          <a:bodyPr wrap="square" lIns="0" rIns="0" tIns="0" bIns="0">
+            <a:spAutoFit/>
+          </a:bodyPr>
+          <a:lstStyle/>
+          <a:p>
+            <a:pPr algn="l">
+              <a:lnSpc>
+                <a:spcPct val="130000"/>
+              </a:lnSpc>
+            </a:pPr>
+            <a:r>
+              <a:rPr sz="1400" b="0">
+                <a:solidFill>
+                  <a:srgbClr val="0B1220"/>
+                </a:solidFill>
+                <a:latin typeface="Pretendard"/>
+              </a:rPr>
+              <a:t>·  증명서는 양도가 불가능한 형태로 발급 — 사고팔 수 없음</a:t>
+            </a:r>
+          </a:p>
+        </p:txBody>
+      </p:sp>
+      <p:sp>
+        <p:nvSpPr>
+          <p:cNvPr id="7" name="TextBox 6"/>
+          <p:cNvSpPr txBox="1"/>
+          <p:nvPr/>
+        </p:nvSpPr>
+        <p:spPr>
+          <a:xfrm>
+            <a:off x="731520" y="5486400"/>
+            <a:ext cx="10972800" cy="365760"/>
+          </a:xfrm>
+          <a:prstGeom prst="rect">
+            <a:avLst/>
+          </a:prstGeom>
+          <a:noFill/>
+        </p:spPr>
+        <p:txBody>
+          <a:bodyPr wrap="square" lIns="0" rIns="0" tIns="0" bIns="0">
+            <a:spAutoFit/>
+          </a:bodyPr>
+          <a:lstStyle/>
+          <a:p>
+            <a:pPr algn="l">
+              <a:lnSpc>
+                <a:spcPct val="130000"/>
+              </a:lnSpc>
+            </a:pPr>
+            <a:r>
+              <a:rPr sz="1400" b="0">
+                <a:solidFill>
+                  <a:srgbClr val="0B1220"/>
+                </a:solidFill>
+                <a:latin typeface="Pretendard"/>
+              </a:rPr>
+              <a:t>·  자동 테스트 17개로 정상 · 비정상 · 공격 시나리오까지 검증</a:t>
+            </a:r>
+          </a:p>
+        </p:txBody>
+      </p:sp>
+      <p:sp>
+        <p:nvSpPr>
+          <p:cNvPr id="8" name="TextBox 7"/>
+          <p:cNvSpPr txBox="1"/>
+          <p:nvPr/>
+        </p:nvSpPr>
+        <p:spPr>
+          <a:xfrm>
+            <a:off x="731520" y="5852160"/>
+            <a:ext cx="10972800" cy="365760"/>
+          </a:xfrm>
+          <a:prstGeom prst="rect">
+            <a:avLst/>
+          </a:prstGeom>
+          <a:noFill/>
+        </p:spPr>
+        <p:txBody>
+          <a:bodyPr wrap="square" lIns="0" rIns="0" tIns="0" bIns="0">
+            <a:spAutoFit/>
+          </a:bodyPr>
+          <a:lstStyle/>
+          <a:p>
+            <a:pPr algn="l">
+              <a:lnSpc>
+                <a:spcPct val="130000"/>
+              </a:lnSpc>
+            </a:pPr>
+            <a:r>
+              <a:rPr sz="1400" b="0">
+                <a:solidFill>
+                  <a:srgbClr val="0B1220"/>
+                </a:solidFill>
+                <a:latin typeface="Pretendard"/>
+              </a:rPr>
+              <a:t>·  코드를 Etherscan에 공개 — 저희를 안 믿어도 코드는 검증 가능</a:t>
+            </a:r>
+          </a:p>
+        </p:txBody>
+      </p:sp>
+      <p:sp>
+        <p:nvSpPr>
+          <p:cNvPr id="9" name="TextBox 8"/>
+          <p:cNvSpPr txBox="1"/>
+          <p:nvPr/>
+        </p:nvSpPr>
+        <p:spPr>
+          <a:xfrm>
+            <a:off x="731520" y="6217920"/>
+            <a:ext cx="10972800" cy="365760"/>
+          </a:xfrm>
+          <a:prstGeom prst="rect">
+            <a:avLst/>
+          </a:prstGeom>
+          <a:noFill/>
+        </p:spPr>
+        <p:txBody>
+          <a:bodyPr wrap="square" lIns="0" rIns="0" tIns="0" bIns="0">
+            <a:spAutoFit/>
+          </a:bodyPr>
+          <a:lstStyle/>
+          <a:p>
+            <a:pPr algn="l">
+              <a:lnSpc>
+                <a:spcPct val="130000"/>
+              </a:lnSpc>
+            </a:pPr>
+            <a:r>
+              <a:rPr sz="1400" b="0">
+                <a:solidFill>
+                  <a:srgbClr val="0B1220"/>
+                </a:solidFill>
+                <a:latin typeface="Pretendard"/>
+              </a:rPr>
+              <a:t>·  한 가지 한계 — '기관이 발급했다'는 보장하지만 '기관이 좋은가'는 별도 검토</a:t>
+            </a:r>
+          </a:p>
+        </p:txBody>
+      </p:sp>
+    </p:spTree>
+  </p:cSld>
+  <p:clrMapOvr>
+    <a:masterClrMapping/>
+  </p:clrMapOvr>
+</p:sld>
+</file>
+
+<file path=ppt/slides/slide9.xml><?xml version="1.0" encoding="utf-8"?>
+<p:sld xmlns:a="http://schemas.openxmlformats.org/drawingml/2006/main" xmlns:p="http://schemas.openxmlformats.org/presentationml/2006/main" xmlns:r="http://schemas.openxmlformats.org/officeDocument/2006/relationships">
+  <p:cSld>
+    <p:bg>
+      <p:bgPr>
+        <a:solidFill>
+          <a:srgbClr val="F7F8FA"/>
+        </a:solidFill>
+        <a:effectLst/>
+      </p:bgPr>
+    </p:bg>
+    <p:spTree>
+      <p:nvGrpSpPr>
+        <p:cNvPr id="1" name=""/>
+        <p:cNvGrpSpPr/>
+        <p:nvPr/>
+      </p:nvGrpSpPr>
+      <p:grpSpPr/>
+      <p:sp>
+        <p:nvSpPr>
+          <p:cNvPr id="2" name="TextBox 1"/>
+          <p:cNvSpPr txBox="1"/>
+          <p:nvPr/>
+        </p:nvSpPr>
+        <p:spPr>
+          <a:xfrm>
+            <a:off x="731520" y="548640"/>
+            <a:ext cx="10058400" cy="320040"/>
+          </a:xfrm>
+          <a:prstGeom prst="rect">
+            <a:avLst/>
+          </a:prstGeom>
+          <a:noFill/>
+        </p:spPr>
+        <p:txBody>
+          <a:bodyPr wrap="square" lIns="0" rIns="0" tIns="0" bIns="0">
+            <a:spAutoFit/>
+          </a:bodyPr>
+          <a:lstStyle/>
+          <a:p>
+            <a:pPr algn="l">
+              <a:lnSpc>
+                <a:spcPct val="130000"/>
+              </a:lnSpc>
+            </a:pPr>
+            <a:r>
+              <a:rPr sz="1100" b="1">
+                <a:solidFill>
+                  <a:srgbClr val="059669"/>
+                </a:solidFill>
+                <a:latin typeface="Pretendard"/>
+              </a:rPr>
+              <a:t>05 · VIBE CODING · 노하우</a:t>
             </a:r>
           </a:p>
         </p:txBody>

</xml_diff>